<commit_message>
Add alternate topic browsing structure
</commit_message>
<xml_diff>
--- a/docs/ehrman_search_methods_editable.pptx
+++ b/docs/ehrman_search_methods_editable.pptx
@@ -1,22 +1,22 @@
 
 <file path=ppt/presentation.xml><?xml version="1.0" encoding="utf-8"?>
-<p:presentation xmlns:a="http://schemas.openxmlformats.org/drawingml/2006/main" xmlns:r="http://schemas.openxmlformats.org/officeDocument/2006/relationships" xmlns:p="http://schemas.openxmlformats.org/presentationml/2006/main">
+<p:presentation xmlns:p="http://schemas.openxmlformats.org/presentationml/2006/main">
   <p:sldMasterIdLst>
-    <p:sldMasterId id="2147483648" r:id="rId1"/>
+    <p:sldMasterId xmlns:r="http://schemas.openxmlformats.org/officeDocument/2006/relationships" id="2147483648" r:id="Rd50737dae8b34df4"/>
   </p:sldMasterIdLst>
   <p:notesMasterIdLst>
-    <p:notesMasterId r:id="rId3"/>
+    <p:notesMasterId xmlns:r="http://schemas.openxmlformats.org/officeDocument/2006/relationships" r:id="R3dc4d0e1cb3643ec"/>
   </p:notesMasterIdLst>
   <p:sldIdLst>
-    <p:sldId id="256" r:id="rId2"/>
+    <p:sldId xmlns:r="http://schemas.openxmlformats.org/officeDocument/2006/relationships" id="256" r:id="Re9303360b01b437a"/>
   </p:sldIdLst>
   <p:sldSz cx="11430000" cy="7334250"/>
   <p:notesSz cx="6858000" cy="9144000"/>
   <p:defaultTextStyle>
-    <a:defPPr>
+    <a:defPPr xmlns:a="http://schemas.openxmlformats.org/drawingml/2006/main">
       <a:defRPr lang="en-US"/>
     </a:defPPr>
-    <a:lvl1pPr marL="0" indent="0" algn="l" defTabSz="914400">
+    <a:lvl1pPr xmlns:a="http://schemas.openxmlformats.org/drawingml/2006/main" marL="0" indent="0" algn="l" defTabSz="914400">
       <a:defRPr sz="1800" kern="1200">
         <a:solidFill>
           <a:schemeClr val="tx1"/>
@@ -26,7 +26,7 @@
         <a:cs typeface="+mn-cs"/>
       </a:defRPr>
     </a:lvl1pPr>
-    <a:lvl2pPr marL="457200" indent="0" algn="l" defTabSz="914400">
+    <a:lvl2pPr xmlns:a="http://schemas.openxmlformats.org/drawingml/2006/main" marL="457200" indent="0" algn="l" defTabSz="914400">
       <a:defRPr sz="1800" kern="1200">
         <a:solidFill>
           <a:schemeClr val="tx1"/>
@@ -36,7 +36,7 @@
         <a:cs typeface="+mn-cs"/>
       </a:defRPr>
     </a:lvl2pPr>
-    <a:lvl3pPr marL="914400" indent="0" algn="l" defTabSz="914400">
+    <a:lvl3pPr xmlns:a="http://schemas.openxmlformats.org/drawingml/2006/main" marL="914400" indent="0" algn="l" defTabSz="914400">
       <a:defRPr sz="1800" kern="1200">
         <a:solidFill>
           <a:schemeClr val="tx1"/>
@@ -46,7 +46,7 @@
         <a:cs typeface="+mn-cs"/>
       </a:defRPr>
     </a:lvl3pPr>
-    <a:lvl4pPr marL="1371600" indent="0" algn="l" defTabSz="914400">
+    <a:lvl4pPr xmlns:a="http://schemas.openxmlformats.org/drawingml/2006/main" marL="1371600" indent="0" algn="l" defTabSz="914400">
       <a:defRPr sz="1800" kern="1200">
         <a:solidFill>
           <a:schemeClr val="tx1"/>
@@ -56,7 +56,7 @@
         <a:cs typeface="+mn-cs"/>
       </a:defRPr>
     </a:lvl4pPr>
-    <a:lvl5pPr marL="1828800" indent="0" algn="l" defTabSz="914400">
+    <a:lvl5pPr xmlns:a="http://schemas.openxmlformats.org/drawingml/2006/main" marL="1828800" indent="0" algn="l" defTabSz="914400">
       <a:defRPr sz="1800" kern="1200">
         <a:solidFill>
           <a:schemeClr val="tx1"/>
@@ -66,7 +66,7 @@
         <a:cs typeface="+mn-cs"/>
       </a:defRPr>
     </a:lvl5pPr>
-    <a:lvl6pPr marL="2286000" indent="0" algn="l" defTabSz="914400">
+    <a:lvl6pPr xmlns:a="http://schemas.openxmlformats.org/drawingml/2006/main" marL="2286000" indent="0" algn="l" defTabSz="914400">
       <a:defRPr sz="1800" kern="1200">
         <a:solidFill>
           <a:schemeClr val="tx1"/>
@@ -76,7 +76,7 @@
         <a:cs typeface="+mn-cs"/>
       </a:defRPr>
     </a:lvl6pPr>
-    <a:lvl7pPr marL="2743200" indent="0" algn="l" defTabSz="914400">
+    <a:lvl7pPr xmlns:a="http://schemas.openxmlformats.org/drawingml/2006/main" marL="2743200" indent="0" algn="l" defTabSz="914400">
       <a:defRPr sz="1800" kern="1200">
         <a:solidFill>
           <a:schemeClr val="tx1"/>
@@ -86,7 +86,7 @@
         <a:cs typeface="+mn-cs"/>
       </a:defRPr>
     </a:lvl7pPr>
-    <a:lvl8pPr marL="3200400" indent="0" algn="l" defTabSz="914400">
+    <a:lvl8pPr xmlns:a="http://schemas.openxmlformats.org/drawingml/2006/main" marL="3200400" indent="0" algn="l" defTabSz="914400">
       <a:defRPr sz="1800" kern="1200">
         <a:solidFill>
           <a:schemeClr val="tx1"/>
@@ -96,7 +96,7 @@
         <a:cs typeface="+mn-cs"/>
       </a:defRPr>
     </a:lvl8pPr>
-    <a:lvl9pPr marL="3657600" indent="0" algn="l" defTabSz="914400">
+    <a:lvl9pPr xmlns:a="http://schemas.openxmlformats.org/drawingml/2006/main" marL="3657600" indent="0" algn="l" defTabSz="914400">
       <a:defRPr sz="1800" kern="1200">
         <a:solidFill>
           <a:schemeClr val="tx1"/>
@@ -111,11 +111,11 @@
 </file>
 
 <file path=ppt/notesMasters/notesMaster1.xml><?xml version="1.0" encoding="utf-8"?>
-<p:notesMaster xmlns:a="http://schemas.openxmlformats.org/drawingml/2006/main" xmlns:r="http://schemas.openxmlformats.org/officeDocument/2006/relationships" xmlns:p="http://schemas.openxmlformats.org/presentationml/2006/main">
+<p:notesMaster xmlns:p="http://schemas.openxmlformats.org/presentationml/2006/main">
   <p:cSld>
     <p:bg>
       <p:bgRef idx="1001">
-        <a:schemeClr val="bg1"/>
+        <a:schemeClr xmlns:a="http://schemas.openxmlformats.org/drawingml/2006/main" val="bg1"/>
       </p:bgRef>
     </p:bg>
     <p:spTree>
@@ -125,164 +125,380 @@
         <p:nvPr/>
       </p:nvGrpSpPr>
       <p:grpSpPr>
-        <a:xfrm>
-          <a:off x="0" y="0"/>
-          <a:ext cx="0" cy="0"/>
-          <a:chOff x="0" y="0"/>
-          <a:chExt cx="0" cy="0"/>
-        </a:xfrm>
+        <a:xfrm xmlns:a="http://schemas.openxmlformats.org/drawingml/2006/main"/>
       </p:grpSpPr>
       <p:sp>
         <p:nvSpPr>
           <p:cNvPr id="2" name="Header Placeholder"/>
-          <p:cNvSpPr>
-            <a:spLocks noGrp="1"/>
-          </p:cNvSpPr>
+          <p:cNvSpPr/>
           <p:nvPr>
             <p:ph type="hdr" sz="quarter"/>
           </p:nvPr>
         </p:nvSpPr>
         <p:spPr>
-          <a:prstGeom prst="rect">
-            <a:avLst/>
-          </a:prstGeom>
-        </p:spPr>
-        <p:txBody>
-          <a:bodyPr/>
-          <a:lstStyle/>
-          <a:p>
-            <a:endParaRPr/>
-          </a:p>
+          <a:prstGeom xmlns:a="http://schemas.openxmlformats.org/drawingml/2006/main" prst="rect">
+            <a:avLst/>
+          </a:prstGeom>
+        </p:spPr>
+        <p:txBody>
+          <a:bodyPr xmlns:a="http://schemas.openxmlformats.org/drawingml/2006/main"/>
+          <a:lstStyle xmlns:a="http://schemas.openxmlformats.org/drawingml/2006/main"/>
+          <a:p xmlns:a="http://schemas.openxmlformats.org/drawingml/2006/main"/>
         </p:txBody>
       </p:sp>
       <p:sp>
         <p:nvSpPr>
           <p:cNvPr id="3" name="Date Placeholder"/>
-          <p:cNvSpPr>
-            <a:spLocks noGrp="1"/>
-          </p:cNvSpPr>
+          <p:cNvSpPr/>
           <p:nvPr>
             <p:ph type="dt" sz="quarter" idx="1"/>
           </p:nvPr>
         </p:nvSpPr>
         <p:spPr>
-          <a:prstGeom prst="rect">
-            <a:avLst/>
-          </a:prstGeom>
-        </p:spPr>
-        <p:txBody>
-          <a:bodyPr/>
-          <a:lstStyle/>
-          <a:p>
-            <a:endParaRPr/>
-          </a:p>
+          <a:prstGeom xmlns:a="http://schemas.openxmlformats.org/drawingml/2006/main" prst="rect">
+            <a:avLst/>
+          </a:prstGeom>
+        </p:spPr>
+        <p:txBody>
+          <a:bodyPr xmlns:a="http://schemas.openxmlformats.org/drawingml/2006/main"/>
+          <a:lstStyle xmlns:a="http://schemas.openxmlformats.org/drawingml/2006/main"/>
+          <a:p xmlns:a="http://schemas.openxmlformats.org/drawingml/2006/main"/>
         </p:txBody>
       </p:sp>
       <p:sp>
         <p:nvSpPr>
           <p:cNvPr id="4" name="Slide Image Placeholder"/>
-          <p:cNvSpPr>
-            <a:spLocks noGrp="1" noRot="1" noChangeAspect="1"/>
-          </p:cNvSpPr>
+          <p:cNvSpPr/>
           <p:nvPr>
             <p:ph type="sldImg" idx="2"/>
           </p:nvPr>
         </p:nvSpPr>
         <p:spPr>
-          <a:prstGeom prst="rect">
-            <a:avLst/>
-          </a:prstGeom>
-        </p:spPr>
-        <p:txBody>
-          <a:bodyPr/>
-          <a:lstStyle/>
-          <a:p>
-            <a:endParaRPr/>
-          </a:p>
+          <a:prstGeom xmlns:a="http://schemas.openxmlformats.org/drawingml/2006/main" prst="rect">
+            <a:avLst/>
+          </a:prstGeom>
+        </p:spPr>
+        <p:txBody>
+          <a:bodyPr xmlns:a="http://schemas.openxmlformats.org/drawingml/2006/main"/>
+          <a:lstStyle xmlns:a="http://schemas.openxmlformats.org/drawingml/2006/main"/>
+          <a:p xmlns:a="http://schemas.openxmlformats.org/drawingml/2006/main"/>
         </p:txBody>
       </p:sp>
       <p:sp>
         <p:nvSpPr>
           <p:cNvPr id="5" name="Notes Placeholder"/>
-          <p:cNvSpPr>
-            <a:spLocks noGrp="1"/>
-          </p:cNvSpPr>
+          <p:cNvSpPr/>
           <p:nvPr>
             <p:ph type="body" sz="quarter" idx="3"/>
           </p:nvPr>
         </p:nvSpPr>
         <p:spPr>
-          <a:prstGeom prst="rect">
-            <a:avLst/>
-          </a:prstGeom>
-        </p:spPr>
-        <p:txBody>
-          <a:bodyPr/>
-          <a:lstStyle/>
-          <a:p>
-            <a:endParaRPr/>
-          </a:p>
+          <a:prstGeom xmlns:a="http://schemas.openxmlformats.org/drawingml/2006/main" prst="rect">
+            <a:avLst/>
+          </a:prstGeom>
+        </p:spPr>
+        <p:txBody>
+          <a:bodyPr xmlns:a="http://schemas.openxmlformats.org/drawingml/2006/main"/>
+          <a:lstStyle xmlns:a="http://schemas.openxmlformats.org/drawingml/2006/main"/>
+          <a:p xmlns:a="http://schemas.openxmlformats.org/drawingml/2006/main"/>
         </p:txBody>
       </p:sp>
       <p:sp>
         <p:nvSpPr>
           <p:cNvPr id="6" name="Footer Placeholder"/>
-          <p:cNvSpPr>
-            <a:spLocks noGrp="1"/>
-          </p:cNvSpPr>
+          <p:cNvSpPr/>
           <p:nvPr>
             <p:ph type="ftr" sz="quarter" idx="4"/>
           </p:nvPr>
         </p:nvSpPr>
         <p:spPr>
-          <a:prstGeom prst="rect">
-            <a:avLst/>
-          </a:prstGeom>
-        </p:spPr>
-        <p:txBody>
-          <a:bodyPr/>
-          <a:lstStyle/>
-          <a:p>
-            <a:endParaRPr/>
-          </a:p>
+          <a:prstGeom xmlns:a="http://schemas.openxmlformats.org/drawingml/2006/main" prst="rect">
+            <a:avLst/>
+          </a:prstGeom>
+        </p:spPr>
+        <p:txBody>
+          <a:bodyPr xmlns:a="http://schemas.openxmlformats.org/drawingml/2006/main"/>
+          <a:lstStyle xmlns:a="http://schemas.openxmlformats.org/drawingml/2006/main"/>
+          <a:p xmlns:a="http://schemas.openxmlformats.org/drawingml/2006/main"/>
         </p:txBody>
       </p:sp>
       <p:sp>
         <p:nvSpPr>
           <p:cNvPr id="7" name="Slide Number Placeholder"/>
-          <p:cNvSpPr>
-            <a:spLocks noGrp="1"/>
-          </p:cNvSpPr>
+          <p:cNvSpPr/>
           <p:nvPr>
             <p:ph type="sldNum" sz="quarter" idx="5"/>
           </p:nvPr>
         </p:nvSpPr>
         <p:spPr>
-          <a:prstGeom prst="rect">
-            <a:avLst/>
-          </a:prstGeom>
-        </p:spPr>
-        <p:txBody>
-          <a:bodyPr/>
-          <a:lstStyle/>
-          <a:p>
-            <a:endParaRPr/>
-          </a:p>
+          <a:prstGeom xmlns:a="http://schemas.openxmlformats.org/drawingml/2006/main" prst="rect">
+            <a:avLst/>
+          </a:prstGeom>
+        </p:spPr>
+        <p:txBody>
+          <a:bodyPr xmlns:a="http://schemas.openxmlformats.org/drawingml/2006/main"/>
+          <a:lstStyle xmlns:a="http://schemas.openxmlformats.org/drawingml/2006/main"/>
+          <a:p xmlns:a="http://schemas.openxmlformats.org/drawingml/2006/main"/>
         </p:txBody>
       </p:sp>
     </p:spTree>
   </p:cSld>
   <p:clrMap bg1="lt1" tx1="dk1" bg2="lt2" tx2="dk2" accent1="accent1" accent2="accent2" accent3="accent3" accent4="accent4" accent5="accent5" accent6="accent6" hlink="hlink" folHlink="folHlink"/>
   <p:notesStyle>
-    <a:lvl1pPr marL="0" algn="l" defTabSz="914400" rtl="0" eaLnBrk="1" latinLnBrk="0" hangingPunct="1">
+    <a:lvl1pPr xmlns:a="http://schemas.openxmlformats.org/drawingml/2006/main" marL="0" algn="l" defTabSz="914400" rtl="0" eaLnBrk="1" latinLnBrk="0" hangingPunct="1">
       <a:defRPr sz="1200" kern="1200"/>
     </a:lvl1pPr>
   </p:notesStyle>
 </p:notesMaster>
 </file>
 
+<file path=ppt/notesMasters/theme/theme3.xml><?xml version="1.0" encoding="utf-8"?>
+<a:theme xmlns:a="http://schemas.openxmlformats.org/drawingml/2006/main" name="ChatGPT">
+  <a:themeElements>
+    <a:clrScheme name="ChatGPT">
+      <a:dk1>
+        <a:srgbClr val="000000"/>
+      </a:dk1>
+      <a:lt1>
+        <a:srgbClr val="FFFFFF"/>
+      </a:lt1>
+      <a:dk2>
+        <a:srgbClr val="0E2841"/>
+      </a:dk2>
+      <a:lt2>
+        <a:srgbClr val="E8E8E8"/>
+      </a:lt2>
+      <a:accent1>
+        <a:srgbClr val="156082"/>
+      </a:accent1>
+      <a:accent2>
+        <a:srgbClr val="E97132"/>
+      </a:accent2>
+      <a:accent3>
+        <a:srgbClr val="196B24"/>
+      </a:accent3>
+      <a:accent4>
+        <a:srgbClr val="0F9ED5"/>
+      </a:accent4>
+      <a:accent5>
+        <a:srgbClr val="A02B93"/>
+      </a:accent5>
+      <a:accent6>
+        <a:srgbClr val="4EA72E"/>
+      </a:accent6>
+      <a:hlink>
+        <a:srgbClr val="467886"/>
+      </a:hlink>
+      <a:folHlink>
+        <a:srgbClr val="96607D"/>
+      </a:folHlink>
+    </a:clrScheme>
+    <a:fontScheme name="Office">
+      <a:majorFont>
+        <a:latin typeface="Calibri Light"/>
+        <a:ea typeface="Calibri Light"/>
+        <a:cs typeface="Calibri Light"/>
+      </a:majorFont>
+      <a:minorFont>
+        <a:latin typeface="Calibri"/>
+        <a:ea typeface="Calibri"/>
+        <a:cs typeface="Calibri"/>
+      </a:minorFont>
+    </a:fontScheme>
+    <a:fmtScheme name="ChatGPT">
+      <a:fillStyleLst>
+        <a:solidFill>
+          <a:schemeClr val="phClr"/>
+        </a:solidFill>
+        <a:gradFill>
+          <a:gsLst>
+            <a:gs pos="0">
+              <a:schemeClr val="phClr">
+                <a:tint val="67000"/>
+                <a:lumMod val="110000"/>
+                <a:satMod val="105000"/>
+              </a:schemeClr>
+            </a:gs>
+            <a:gs pos="50000">
+              <a:schemeClr val="phClr">
+                <a:tint val="73000"/>
+                <a:lumMod val="105000"/>
+                <a:satMod val="103000"/>
+              </a:schemeClr>
+            </a:gs>
+            <a:gs pos="100000">
+              <a:schemeClr val="phClr">
+                <a:tint val="81000"/>
+                <a:lumMod val="105000"/>
+                <a:satMod val="109000"/>
+              </a:schemeClr>
+            </a:gs>
+          </a:gsLst>
+          <a:lin ang="5400000" scaled="0"/>
+        </a:gradFill>
+        <a:gradFill>
+          <a:gsLst>
+            <a:gs pos="0">
+              <a:schemeClr val="phClr">
+                <a:tint val="94000"/>
+                <a:lumMod val="102000"/>
+                <a:satMod val="103000"/>
+              </a:schemeClr>
+            </a:gs>
+            <a:gs pos="50000">
+              <a:schemeClr val="phClr">
+                <a:shade val="100000"/>
+                <a:lumMod val="100000"/>
+                <a:satMod val="110000"/>
+              </a:schemeClr>
+            </a:gs>
+            <a:gs pos="100000">
+              <a:schemeClr val="phClr">
+                <a:shade val="78000"/>
+                <a:lumMod val="99000"/>
+                <a:satMod val="120000"/>
+              </a:schemeClr>
+            </a:gs>
+          </a:gsLst>
+          <a:lin ang="5400000" scaled="0"/>
+        </a:gradFill>
+      </a:fillStyleLst>
+      <a:lnStyleLst>
+        <a:ln w="12700">
+          <a:solidFill>
+            <a:schemeClr val="phClr"/>
+          </a:solidFill>
+          <a:prstDash val="solid"/>
+        </a:ln>
+        <a:ln w="19050">
+          <a:solidFill>
+            <a:schemeClr val="phClr"/>
+          </a:solidFill>
+          <a:prstDash val="solid"/>
+        </a:ln>
+        <a:ln w="25400">
+          <a:solidFill>
+            <a:schemeClr val="phClr"/>
+          </a:solidFill>
+          <a:prstDash val="solid"/>
+        </a:ln>
+      </a:lnStyleLst>
+      <a:effectStyleLst>
+        <a:effectStyle>
+          <a:effectLst/>
+        </a:effectStyle>
+        <a:effectStyle>
+          <a:effectLst/>
+        </a:effectStyle>
+        <a:effectStyle>
+          <a:effectLst>
+            <a:outerShdw blurRad="57150" dist="19050" dir="5400000">
+              <a:srgbClr val="000000">
+                <a:alpha val="16000"/>
+              </a:srgbClr>
+            </a:outerShdw>
+          </a:effectLst>
+        </a:effectStyle>
+        <a:effectStyle>
+          <a:effectLst>
+            <a:outerShdw blurRad="19050" dist="9525" dir="5400000">
+              <a:srgbClr val="000000">
+                <a:alpha val="6000"/>
+              </a:srgbClr>
+            </a:outerShdw>
+          </a:effectLst>
+        </a:effectStyle>
+        <a:effectStyle>
+          <a:effectLst>
+            <a:outerShdw blurRad="28575" dist="9525" dir="5400000">
+              <a:srgbClr val="000000">
+                <a:alpha val="8000"/>
+              </a:srgbClr>
+            </a:outerShdw>
+          </a:effectLst>
+        </a:effectStyle>
+        <a:effectStyle>
+          <a:effectLst>
+            <a:outerShdw blurRad="57150" dist="19050" dir="5400000">
+              <a:srgbClr val="000000">
+                <a:alpha val="10000"/>
+              </a:srgbClr>
+            </a:outerShdw>
+          </a:effectLst>
+        </a:effectStyle>
+        <a:effectStyle>
+          <a:effectLst>
+            <a:outerShdw blurRad="114300" dist="38100" dir="5400000">
+              <a:srgbClr val="000000">
+                <a:alpha val="12000"/>
+              </a:srgbClr>
+            </a:outerShdw>
+          </a:effectLst>
+        </a:effectStyle>
+        <a:effectStyle>
+          <a:effectLst>
+            <a:outerShdw blurRad="171450" dist="57150" dir="5400000">
+              <a:srgbClr val="000000">
+                <a:alpha val="16000"/>
+              </a:srgbClr>
+            </a:outerShdw>
+          </a:effectLst>
+        </a:effectStyle>
+        <a:effectStyle>
+          <a:effectLst>
+            <a:outerShdw blurRad="266700" dist="95250" dir="5400000">
+              <a:srgbClr val="000000">
+                <a:alpha val="24000"/>
+              </a:srgbClr>
+            </a:outerShdw>
+          </a:effectLst>
+        </a:effectStyle>
+      </a:effectStyleLst>
+      <a:bgFillStyleLst>
+        <a:solidFill>
+          <a:schemeClr val="phClr"/>
+        </a:solidFill>
+        <a:solidFill>
+          <a:schemeClr val="phClr">
+            <a:tint val="95000"/>
+            <a:satMod val="170000"/>
+          </a:schemeClr>
+        </a:solidFill>
+        <a:gradFill>
+          <a:gsLst>
+            <a:gs pos="0">
+              <a:schemeClr val="phClr">
+                <a:tint val="93000"/>
+                <a:shade val="98000"/>
+                <a:lumMod val="102000"/>
+                <a:satMod val="150000"/>
+              </a:schemeClr>
+            </a:gs>
+            <a:gs pos="50000">
+              <a:schemeClr val="phClr">
+                <a:tint val="98000"/>
+                <a:shade val="90000"/>
+                <a:lumMod val="103000"/>
+                <a:satMod val="130000"/>
+              </a:schemeClr>
+            </a:gs>
+            <a:gs pos="100000">
+              <a:schemeClr val="phClr">
+                <a:shade val="63000"/>
+                <a:satMod val="120000"/>
+              </a:schemeClr>
+            </a:gs>
+          </a:gsLst>
+          <a:lin ang="5400000" scaled="0"/>
+        </a:gradFill>
+      </a:bgFillStyleLst>
+    </a:fmtScheme>
+  </a:themeElements>
+</a:theme>
+</file>
+
 <file path=ppt/notesSlides/notesSlide1.xml><?xml version="1.0" encoding="utf-8"?>
-<p:notes xmlns:a="http://schemas.openxmlformats.org/drawingml/2006/main" xmlns:r="http://schemas.openxmlformats.org/officeDocument/2006/relationships" xmlns:p="http://schemas.openxmlformats.org/presentationml/2006/main">
+<p:notes xmlns:p="http://schemas.openxmlformats.org/presentationml/2006/main">
   <p:cSld>
     <p:spTree>
       <p:nvGrpSpPr>
@@ -291,21 +507,16 @@
         <p:nvPr/>
       </p:nvGrpSpPr>
       <p:grpSpPr>
-        <a:xfrm>
-          <a:off x="0" y="0"/>
-          <a:ext cx="0" cy="0"/>
-          <a:chOff x="0" y="0"/>
-          <a:chExt cx="0" cy="0"/>
-        </a:xfrm>
+        <a:xfrm xmlns:a="http://schemas.openxmlformats.org/drawingml/2006/main"/>
       </p:grpSpPr>
       <p:sp>
         <p:nvSpPr>
           <p:cNvPr id="2" name="Slide Image Placeholder 1"/>
           <p:cNvSpPr>
-            <a:spLocks noGrp="1" noRot="1" noChangeAspect="1"/>
+            <a:spLocks xmlns:a="http://schemas.openxmlformats.org/drawingml/2006/main" noGrp="1"/>
           </p:cNvSpPr>
           <p:nvPr>
-            <p:ph type="sldImg"/>
+            <p:ph type="sldImg" idx="0"/>
           </p:nvPr>
         </p:nvSpPr>
         <p:spPr/>
@@ -314,7 +525,7 @@
         <p:nvSpPr>
           <p:cNvPr id="3" name="Notes Placeholder 2"/>
           <p:cNvSpPr>
-            <a:spLocks noGrp="1"/>
+            <a:spLocks xmlns:a="http://schemas.openxmlformats.org/drawingml/2006/main" noGrp="1"/>
           </p:cNvSpPr>
           <p:nvPr>
             <p:ph type="body" idx="1"/>
@@ -322,18 +533,16 @@
         </p:nvSpPr>
         <p:spPr/>
         <p:txBody>
-          <a:bodyPr/>
-          <a:lstStyle/>
-          <a:p>
-            <a:endParaRPr/>
-          </a:p>
+          <a:bodyPr xmlns:a="http://schemas.openxmlformats.org/drawingml/2006/main"/>
+          <a:lstStyle xmlns:a="http://schemas.openxmlformats.org/drawingml/2006/main"/>
+          <a:p xmlns:a="http://schemas.openxmlformats.org/drawingml/2006/main"/>
         </p:txBody>
       </p:sp>
       <p:sp>
         <p:nvSpPr>
           <p:cNvPr id="4" name="Slide Number Placeholder 3"/>
           <p:cNvSpPr>
-            <a:spLocks noGrp="1"/>
+            <a:spLocks xmlns:a="http://schemas.openxmlformats.org/drawingml/2006/main" noGrp="1"/>
           </p:cNvSpPr>
           <p:nvPr>
             <p:ph type="sldNum" idx="5"/>
@@ -341,23 +550,21 @@
         </p:nvSpPr>
         <p:spPr/>
         <p:txBody>
-          <a:bodyPr/>
-          <a:lstStyle/>
-          <a:p>
-            <a:endParaRPr/>
-          </a:p>
+          <a:bodyPr xmlns:a="http://schemas.openxmlformats.org/drawingml/2006/main"/>
+          <a:lstStyle xmlns:a="http://schemas.openxmlformats.org/drawingml/2006/main"/>
+          <a:p xmlns:a="http://schemas.openxmlformats.org/drawingml/2006/main"/>
         </p:txBody>
       </p:sp>
     </p:spTree>
   </p:cSld>
   <p:clrMapOvr>
-    <a:masterClrMapping/>
+    <a:masterClrMapping xmlns:a="http://schemas.openxmlformats.org/drawingml/2006/main"/>
   </p:clrMapOvr>
 </p:notes>
 </file>
 
 <file path=ppt/slideLayouts/slideLayout1.xml><?xml version="1.0" encoding="utf-8"?>
-<p:sldLayout xmlns:a="http://schemas.openxmlformats.org/drawingml/2006/main" xmlns:r="http://schemas.openxmlformats.org/officeDocument/2006/relationships" xmlns:p="http://schemas.openxmlformats.org/presentationml/2006/main" type="title">
+<p:sldLayout xmlns:p="http://schemas.openxmlformats.org/presentationml/2006/main" type="title">
   <p:cSld name="Title Slide">
     <p:spTree>
       <p:nvGrpSpPr>
@@ -366,27 +573,19 @@
         <p:nvPr/>
       </p:nvGrpSpPr>
       <p:grpSpPr>
-        <a:xfrm>
-          <a:off x="0" y="0"/>
-          <a:ext cx="0" cy="0"/>
-          <a:chOff x="0" y="0"/>
-          <a:chExt cx="0" cy="0"/>
-        </a:xfrm>
+        <a:xfrm xmlns:a="http://schemas.openxmlformats.org/drawingml/2006/main"/>
       </p:grpSpPr>
     </p:spTree>
   </p:cSld>
-  <p:clrMapOvr>
-    <a:masterClrMapping/>
-  </p:clrMapOvr>
 </p:sldLayout>
 </file>
 
 <file path=ppt/slideMasters/slideMaster1.xml><?xml version="1.0" encoding="utf-8"?>
-<p:sldMaster xmlns:a="http://schemas.openxmlformats.org/drawingml/2006/main" xmlns:r="http://schemas.openxmlformats.org/officeDocument/2006/relationships" xmlns:p="http://schemas.openxmlformats.org/presentationml/2006/main">
+<p:sldMaster xmlns:p="http://schemas.openxmlformats.org/presentationml/2006/main">
   <p:cSld name="Master">
     <p:bg>
       <p:bgRef idx="1001">
-        <a:schemeClr val="bg1"/>
+        <a:schemeClr xmlns:a="http://schemas.openxmlformats.org/drawingml/2006/main" val="bg1"/>
       </p:bgRef>
     </p:bg>
     <p:spTree>
@@ -396,22 +595,17 @@
         <p:nvPr/>
       </p:nvGrpSpPr>
       <p:grpSpPr>
-        <a:xfrm>
-          <a:off x="0" y="0"/>
-          <a:ext cx="0" cy="0"/>
-          <a:chOff x="0" y="0"/>
-          <a:chExt cx="0" cy="0"/>
-        </a:xfrm>
+        <a:xfrm xmlns:a="http://schemas.openxmlformats.org/drawingml/2006/main"/>
       </p:grpSpPr>
     </p:spTree>
   </p:cSld>
   <p:clrMap bg1="lt1" tx1="dk1" bg2="lt2" tx2="dk2" accent1="accent1" accent2="accent2" accent3="accent3" accent4="accent4" accent5="accent5" accent6="accent6" hlink="hlink" folHlink="folHlink"/>
   <p:sldLayoutIdLst>
-    <p:sldLayoutId id="2147483649" r:id="rId1"/>
+    <p:sldLayoutId xmlns:r="http://schemas.openxmlformats.org/officeDocument/2006/relationships" id="2147483649" r:id="R79c3a7da8fc140ae"/>
   </p:sldLayoutIdLst>
   <p:txStyles>
     <p:titleStyle>
-      <a:lvl1pPr algn="l">
+      <a:lvl1pPr xmlns:a="http://schemas.openxmlformats.org/drawingml/2006/main" algn="l">
         <a:lnSpc>
           <a:spcPct val="90000"/>
         </a:lnSpc>
@@ -430,7 +624,7 @@
       </a:lvl1pPr>
     </p:titleStyle>
     <p:bodyStyle>
-      <a:lvl1pPr marL="228600" indent="-228600" algn="l">
+      <a:lvl1pPr xmlns:a="http://schemas.openxmlformats.org/drawingml/2006/main" marL="228600" indent="-228600" algn="l">
         <a:lnSpc>
           <a:spcPct val="90000"/>
         </a:lnSpc>
@@ -447,7 +641,7 @@
           <a:cs typeface="+mn-lt"/>
         </a:defRPr>
       </a:lvl1pPr>
-      <a:lvl2pPr marL="685800" indent="-228600" algn="l">
+      <a:lvl2pPr xmlns:a="http://schemas.openxmlformats.org/drawingml/2006/main" marL="685800" indent="-228600" algn="l">
         <a:lnSpc>
           <a:spcPct val="90000"/>
         </a:lnSpc>
@@ -464,7 +658,7 @@
           <a:cs typeface="+mn-lt"/>
         </a:defRPr>
       </a:lvl2pPr>
-      <a:lvl3pPr marL="1143000" indent="-228600" algn="l">
+      <a:lvl3pPr xmlns:a="http://schemas.openxmlformats.org/drawingml/2006/main" marL="1143000" indent="-228600" algn="l">
         <a:lnSpc>
           <a:spcPct val="90000"/>
         </a:lnSpc>
@@ -481,7 +675,7 @@
           <a:cs typeface="+mn-lt"/>
         </a:defRPr>
       </a:lvl3pPr>
-      <a:lvl4pPr marL="1600200" indent="-228600" algn="l">
+      <a:lvl4pPr xmlns:a="http://schemas.openxmlformats.org/drawingml/2006/main" marL="1600200" indent="-228600" algn="l">
         <a:lnSpc>
           <a:spcPct val="90000"/>
         </a:lnSpc>
@@ -498,7 +692,7 @@
           <a:cs typeface="+mn-lt"/>
         </a:defRPr>
       </a:lvl4pPr>
-      <a:lvl5pPr marL="2057400" indent="-228600" algn="l">
+      <a:lvl5pPr xmlns:a="http://schemas.openxmlformats.org/drawingml/2006/main" marL="2057400" indent="-228600" algn="l">
         <a:lnSpc>
           <a:spcPct val="90000"/>
         </a:lnSpc>
@@ -515,7 +709,7 @@
           <a:cs typeface="+mn-lt"/>
         </a:defRPr>
       </a:lvl5pPr>
-      <a:lvl6pPr marL="2514600" indent="-228600" algn="l">
+      <a:lvl6pPr xmlns:a="http://schemas.openxmlformats.org/drawingml/2006/main" marL="2514600" indent="-228600" algn="l">
         <a:lnSpc>
           <a:spcPct val="90000"/>
         </a:lnSpc>
@@ -532,7 +726,7 @@
           <a:cs typeface="+mn-lt"/>
         </a:defRPr>
       </a:lvl6pPr>
-      <a:lvl7pPr marL="2971800" indent="-228600" algn="l">
+      <a:lvl7pPr xmlns:a="http://schemas.openxmlformats.org/drawingml/2006/main" marL="2971800" indent="-228600" algn="l">
         <a:lnSpc>
           <a:spcPct val="90000"/>
         </a:lnSpc>
@@ -549,7 +743,7 @@
           <a:cs typeface="+mn-lt"/>
         </a:defRPr>
       </a:lvl7pPr>
-      <a:lvl8pPr marL="3429000" indent="-228600" algn="l">
+      <a:lvl8pPr xmlns:a="http://schemas.openxmlformats.org/drawingml/2006/main" marL="3429000" indent="-228600" algn="l">
         <a:lnSpc>
           <a:spcPct val="90000"/>
         </a:lnSpc>
@@ -566,7 +760,7 @@
           <a:cs typeface="+mn-lt"/>
         </a:defRPr>
       </a:lvl8pPr>
-      <a:lvl9pPr marL="3886200" indent="-228600" algn="l">
+      <a:lvl9pPr xmlns:a="http://schemas.openxmlformats.org/drawingml/2006/main" marL="3886200" indent="-228600" algn="l">
         <a:lnSpc>
           <a:spcPct val="90000"/>
         </a:lnSpc>
@@ -585,7 +779,7 @@
       </a:lvl9pPr>
     </p:bodyStyle>
     <p:otherStyle>
-      <a:lvl1pPr marL="0" algn="l">
+      <a:lvl1pPr xmlns:a="http://schemas.openxmlformats.org/drawingml/2006/main" marL="0" algn="l">
         <a:buNone/>
         <a:defRPr sz="1800">
           <a:solidFill>
@@ -596,7 +790,7 @@
           <a:cs typeface="+mn-lt"/>
         </a:defRPr>
       </a:lvl1pPr>
-      <a:lvl2pPr marL="457200" algn="l">
+      <a:lvl2pPr xmlns:a="http://schemas.openxmlformats.org/drawingml/2006/main" marL="457200" algn="l">
         <a:buNone/>
         <a:defRPr sz="1800">
           <a:solidFill>
@@ -607,7 +801,7 @@
           <a:cs typeface="+mn-lt"/>
         </a:defRPr>
       </a:lvl2pPr>
-      <a:lvl3pPr marL="914400" algn="l">
+      <a:lvl3pPr xmlns:a="http://schemas.openxmlformats.org/drawingml/2006/main" marL="914400" algn="l">
         <a:buNone/>
         <a:defRPr sz="1800">
           <a:solidFill>
@@ -618,7 +812,7 @@
           <a:cs typeface="+mn-lt"/>
         </a:defRPr>
       </a:lvl3pPr>
-      <a:lvl4pPr marL="1371600" algn="l">
+      <a:lvl4pPr xmlns:a="http://schemas.openxmlformats.org/drawingml/2006/main" marL="1371600" algn="l">
         <a:buNone/>
         <a:defRPr sz="1800">
           <a:solidFill>
@@ -629,7 +823,7 @@
           <a:cs typeface="+mn-lt"/>
         </a:defRPr>
       </a:lvl4pPr>
-      <a:lvl5pPr marL="1828800" algn="l">
+      <a:lvl5pPr xmlns:a="http://schemas.openxmlformats.org/drawingml/2006/main" marL="1828800" algn="l">
         <a:buNone/>
         <a:defRPr sz="1800">
           <a:solidFill>
@@ -640,7 +834,7 @@
           <a:cs typeface="+mn-lt"/>
         </a:defRPr>
       </a:lvl5pPr>
-      <a:lvl6pPr marL="2286000" algn="l">
+      <a:lvl6pPr xmlns:a="http://schemas.openxmlformats.org/drawingml/2006/main" marL="2286000" algn="l">
         <a:buNone/>
         <a:defRPr sz="1800">
           <a:solidFill>
@@ -651,7 +845,7 @@
           <a:cs typeface="+mn-lt"/>
         </a:defRPr>
       </a:lvl6pPr>
-      <a:lvl7pPr marL="2743200" algn="l">
+      <a:lvl7pPr xmlns:a="http://schemas.openxmlformats.org/drawingml/2006/main" marL="2743200" algn="l">
         <a:buNone/>
         <a:defRPr sz="1800">
           <a:solidFill>
@@ -662,7 +856,7 @@
           <a:cs typeface="+mn-lt"/>
         </a:defRPr>
       </a:lvl7pPr>
-      <a:lvl8pPr marL="3200400" algn="l">
+      <a:lvl8pPr xmlns:a="http://schemas.openxmlformats.org/drawingml/2006/main" marL="3200400" algn="l">
         <a:buNone/>
         <a:defRPr sz="1800">
           <a:solidFill>
@@ -673,7 +867,7 @@
           <a:cs typeface="+mn-lt"/>
         </a:defRPr>
       </a:lvl8pPr>
-      <a:lvl9pPr marL="3657600" algn="l">
+      <a:lvl9pPr xmlns:a="http://schemas.openxmlformats.org/drawingml/2006/main" marL="3657600" algn="l">
         <a:buNone/>
         <a:defRPr sz="1800">
           <a:solidFill>
@@ -689,15 +883,259 @@
 </p:sldMaster>
 </file>
 
+<file path=ppt/slideMasters/theme/theme2.xml><?xml version="1.0" encoding="utf-8"?>
+<a:theme xmlns:a="http://schemas.openxmlformats.org/drawingml/2006/main" name="ChatGPT">
+  <a:themeElements>
+    <a:clrScheme name="ChatGPT">
+      <a:dk1>
+        <a:srgbClr val="000000"/>
+      </a:dk1>
+      <a:lt1>
+        <a:srgbClr val="FFFFFF"/>
+      </a:lt1>
+      <a:dk2>
+        <a:srgbClr val="0E2841"/>
+      </a:dk2>
+      <a:lt2>
+        <a:srgbClr val="E8E8E8"/>
+      </a:lt2>
+      <a:accent1>
+        <a:srgbClr val="156082"/>
+      </a:accent1>
+      <a:accent2>
+        <a:srgbClr val="E97132"/>
+      </a:accent2>
+      <a:accent3>
+        <a:srgbClr val="196B24"/>
+      </a:accent3>
+      <a:accent4>
+        <a:srgbClr val="0F9ED5"/>
+      </a:accent4>
+      <a:accent5>
+        <a:srgbClr val="A02B93"/>
+      </a:accent5>
+      <a:accent6>
+        <a:srgbClr val="4EA72E"/>
+      </a:accent6>
+      <a:hlink>
+        <a:srgbClr val="467886"/>
+      </a:hlink>
+      <a:folHlink>
+        <a:srgbClr val="96607D"/>
+      </a:folHlink>
+    </a:clrScheme>
+    <a:fontScheme name="Office">
+      <a:majorFont>
+        <a:latin typeface="Calibri Light"/>
+        <a:ea typeface="Calibri Light"/>
+        <a:cs typeface="Calibri Light"/>
+      </a:majorFont>
+      <a:minorFont>
+        <a:latin typeface="Calibri"/>
+        <a:ea typeface="Calibri"/>
+        <a:cs typeface="Calibri"/>
+      </a:minorFont>
+    </a:fontScheme>
+    <a:fmtScheme name="ChatGPT">
+      <a:fillStyleLst>
+        <a:solidFill>
+          <a:schemeClr val="phClr"/>
+        </a:solidFill>
+        <a:gradFill>
+          <a:gsLst>
+            <a:gs pos="0">
+              <a:schemeClr val="phClr">
+                <a:tint val="67000"/>
+                <a:lumMod val="110000"/>
+                <a:satMod val="105000"/>
+              </a:schemeClr>
+            </a:gs>
+            <a:gs pos="50000">
+              <a:schemeClr val="phClr">
+                <a:tint val="73000"/>
+                <a:lumMod val="105000"/>
+                <a:satMod val="103000"/>
+              </a:schemeClr>
+            </a:gs>
+            <a:gs pos="100000">
+              <a:schemeClr val="phClr">
+                <a:tint val="81000"/>
+                <a:lumMod val="105000"/>
+                <a:satMod val="109000"/>
+              </a:schemeClr>
+            </a:gs>
+          </a:gsLst>
+          <a:lin ang="5400000" scaled="0"/>
+        </a:gradFill>
+        <a:gradFill>
+          <a:gsLst>
+            <a:gs pos="0">
+              <a:schemeClr val="phClr">
+                <a:tint val="94000"/>
+                <a:lumMod val="102000"/>
+                <a:satMod val="103000"/>
+              </a:schemeClr>
+            </a:gs>
+            <a:gs pos="50000">
+              <a:schemeClr val="phClr">
+                <a:shade val="100000"/>
+                <a:lumMod val="100000"/>
+                <a:satMod val="110000"/>
+              </a:schemeClr>
+            </a:gs>
+            <a:gs pos="100000">
+              <a:schemeClr val="phClr">
+                <a:shade val="78000"/>
+                <a:lumMod val="99000"/>
+                <a:satMod val="120000"/>
+              </a:schemeClr>
+            </a:gs>
+          </a:gsLst>
+          <a:lin ang="5400000" scaled="0"/>
+        </a:gradFill>
+      </a:fillStyleLst>
+      <a:lnStyleLst>
+        <a:ln w="12700">
+          <a:solidFill>
+            <a:schemeClr val="phClr"/>
+          </a:solidFill>
+          <a:prstDash val="solid"/>
+        </a:ln>
+        <a:ln w="19050">
+          <a:solidFill>
+            <a:schemeClr val="phClr"/>
+          </a:solidFill>
+          <a:prstDash val="solid"/>
+        </a:ln>
+        <a:ln w="25400">
+          <a:solidFill>
+            <a:schemeClr val="phClr"/>
+          </a:solidFill>
+          <a:prstDash val="solid"/>
+        </a:ln>
+      </a:lnStyleLst>
+      <a:effectStyleLst>
+        <a:effectStyle>
+          <a:effectLst/>
+        </a:effectStyle>
+        <a:effectStyle>
+          <a:effectLst/>
+        </a:effectStyle>
+        <a:effectStyle>
+          <a:effectLst>
+            <a:outerShdw blurRad="57150" dist="19050" dir="5400000">
+              <a:srgbClr val="000000">
+                <a:alpha val="16000"/>
+              </a:srgbClr>
+            </a:outerShdw>
+          </a:effectLst>
+        </a:effectStyle>
+        <a:effectStyle>
+          <a:effectLst>
+            <a:outerShdw blurRad="19050" dist="9525" dir="5400000">
+              <a:srgbClr val="000000">
+                <a:alpha val="6000"/>
+              </a:srgbClr>
+            </a:outerShdw>
+          </a:effectLst>
+        </a:effectStyle>
+        <a:effectStyle>
+          <a:effectLst>
+            <a:outerShdw blurRad="28575" dist="9525" dir="5400000">
+              <a:srgbClr val="000000">
+                <a:alpha val="8000"/>
+              </a:srgbClr>
+            </a:outerShdw>
+          </a:effectLst>
+        </a:effectStyle>
+        <a:effectStyle>
+          <a:effectLst>
+            <a:outerShdw blurRad="57150" dist="19050" dir="5400000">
+              <a:srgbClr val="000000">
+                <a:alpha val="10000"/>
+              </a:srgbClr>
+            </a:outerShdw>
+          </a:effectLst>
+        </a:effectStyle>
+        <a:effectStyle>
+          <a:effectLst>
+            <a:outerShdw blurRad="114300" dist="38100" dir="5400000">
+              <a:srgbClr val="000000">
+                <a:alpha val="12000"/>
+              </a:srgbClr>
+            </a:outerShdw>
+          </a:effectLst>
+        </a:effectStyle>
+        <a:effectStyle>
+          <a:effectLst>
+            <a:outerShdw blurRad="171450" dist="57150" dir="5400000">
+              <a:srgbClr val="000000">
+                <a:alpha val="16000"/>
+              </a:srgbClr>
+            </a:outerShdw>
+          </a:effectLst>
+        </a:effectStyle>
+        <a:effectStyle>
+          <a:effectLst>
+            <a:outerShdw blurRad="266700" dist="95250" dir="5400000">
+              <a:srgbClr val="000000">
+                <a:alpha val="24000"/>
+              </a:srgbClr>
+            </a:outerShdw>
+          </a:effectLst>
+        </a:effectStyle>
+      </a:effectStyleLst>
+      <a:bgFillStyleLst>
+        <a:solidFill>
+          <a:schemeClr val="phClr"/>
+        </a:solidFill>
+        <a:solidFill>
+          <a:schemeClr val="phClr">
+            <a:tint val="95000"/>
+            <a:satMod val="170000"/>
+          </a:schemeClr>
+        </a:solidFill>
+        <a:gradFill>
+          <a:gsLst>
+            <a:gs pos="0">
+              <a:schemeClr val="phClr">
+                <a:tint val="93000"/>
+                <a:shade val="98000"/>
+                <a:lumMod val="102000"/>
+                <a:satMod val="150000"/>
+              </a:schemeClr>
+            </a:gs>
+            <a:gs pos="50000">
+              <a:schemeClr val="phClr">
+                <a:tint val="98000"/>
+                <a:shade val="90000"/>
+                <a:lumMod val="103000"/>
+                <a:satMod val="130000"/>
+              </a:schemeClr>
+            </a:gs>
+            <a:gs pos="100000">
+              <a:schemeClr val="phClr">
+                <a:shade val="63000"/>
+                <a:satMod val="120000"/>
+              </a:schemeClr>
+            </a:gs>
+          </a:gsLst>
+          <a:lin ang="5400000" scaled="0"/>
+        </a:gradFill>
+      </a:bgFillStyleLst>
+    </a:fmtScheme>
+  </a:themeElements>
+</a:theme>
+</file>
+
 <file path=ppt/slides/slide1.xml><?xml version="1.0" encoding="utf-8"?>
-<p:sld xmlns:a="http://schemas.openxmlformats.org/drawingml/2006/main" xmlns:r="http://schemas.openxmlformats.org/officeDocument/2006/relationships" xmlns:p="http://schemas.openxmlformats.org/presentationml/2006/main">
+<p:sld xmlns:p="http://schemas.openxmlformats.org/presentationml/2006/main">
   <p:cSld>
     <p:bg>
       <p:bgPr>
-        <a:solidFill>
+        <a:solidFill xmlns:a="http://schemas.openxmlformats.org/drawingml/2006/main">
           <a:srgbClr val="FBF7ED"/>
         </a:solidFill>
-        <a:effectLst/>
       </p:bgPr>
     </p:bg>
     <p:spTree>
@@ -707,41 +1145,36 @@
         <p:nvPr/>
       </p:nvGrpSpPr>
       <p:grpSpPr>
-        <a:xfrm>
-          <a:off x="0" y="0"/>
-          <a:ext cx="0" cy="0"/>
-          <a:chOff x="0" y="0"/>
-          <a:chExt cx="0" cy="0"/>
-        </a:xfrm>
+        <a:xfrm xmlns:a="http://schemas.openxmlformats.org/drawingml/2006/main"/>
       </p:grpSpPr>
       <p:sp>
         <p:nvSpPr>
           <p:cNvPr id="43" name="keyword-panel">
-            <a:extLst>
+            <a:extLst xmlns:a="http://schemas.openxmlformats.org/drawingml/2006/main">
               <a:ext uri="{FF2B5EF4-FFF2-40B4-BE49-F238E27FC236}">
                 <a16:creationId xmlns:a16="http://schemas.microsoft.com/office/drawing/2014/main" id="{66786639-CF16-49A8-A963-46A92C33996D}"/>
               </a:ext>
             </a:extLst>
           </p:cNvPr>
           <p:cNvSpPr>
-            <a:spLocks noGrp="1"/>
-          </p:cNvSpPr>
-          <p:nvPr/>
-        </p:nvSpPr>
-        <p:spPr>
-          <a:xfrm>
+            <a:spLocks xmlns:a="http://schemas.openxmlformats.org/drawingml/2006/main" noGrp="1"/>
+          </p:cNvSpPr>
+          <p:nvPr/>
+        </p:nvSpPr>
+        <p:spPr>
+          <a:xfrm xmlns:a="http://schemas.openxmlformats.org/drawingml/2006/main">
             <a:off x="438150" y="400050"/>
             <a:ext cx="4953000" cy="4762500"/>
           </a:xfrm>
-          <a:prstGeom prst="roundRect">
+          <a:prstGeom xmlns:a="http://schemas.openxmlformats.org/drawingml/2006/main" prst="roundRect">
             <a:avLst>
               <a:gd name="adj" fmla="val 3600"/>
             </a:avLst>
           </a:prstGeom>
-          <a:solidFill>
+          <a:solidFill xmlns:a="http://schemas.openxmlformats.org/drawingml/2006/main">
             <a:srgbClr val="FFFAF0"/>
           </a:solidFill>
-          <a:ln w="19050">
+          <a:ln xmlns:a="http://schemas.openxmlformats.org/drawingml/2006/main" w="19050">
             <a:solidFill>
               <a:srgbClr val="D8C8A1"/>
             </a:solidFill>
@@ -749,41 +1182,39 @@
           </a:ln>
         </p:spPr>
         <p:txBody>
-          <a:bodyPr/>
-          <a:lstStyle/>
-          <a:p>
-            <a:endParaRPr lang="en-US"/>
-          </a:p>
+          <a:bodyPr xmlns:a="http://schemas.openxmlformats.org/drawingml/2006/main"/>
+          <a:lstStyle xmlns:a="http://schemas.openxmlformats.org/drawingml/2006/main"/>
+          <a:p xmlns:a="http://schemas.openxmlformats.org/drawingml/2006/main"/>
         </p:txBody>
       </p:sp>
       <p:sp>
         <p:nvSpPr>
           <p:cNvPr id="2" name="browse-panel">
-            <a:extLst>
+            <a:extLst xmlns:a="http://schemas.openxmlformats.org/drawingml/2006/main">
               <a:ext uri="{FF2B5EF4-FFF2-40B4-BE49-F238E27FC236}">
                 <a16:creationId xmlns:a16="http://schemas.microsoft.com/office/drawing/2014/main" id="{0A26D4B4-0CA9-4DDE-AD26-81604E36A6E6}"/>
               </a:ext>
             </a:extLst>
           </p:cNvPr>
           <p:cNvSpPr>
-            <a:spLocks noGrp="1"/>
-          </p:cNvSpPr>
-          <p:nvPr/>
-        </p:nvSpPr>
-        <p:spPr>
-          <a:xfrm>
+            <a:spLocks xmlns:a="http://schemas.openxmlformats.org/drawingml/2006/main" noGrp="1"/>
+          </p:cNvSpPr>
+          <p:nvPr/>
+        </p:nvSpPr>
+        <p:spPr>
+          <a:xfrm xmlns:a="http://schemas.openxmlformats.org/drawingml/2006/main">
             <a:off x="6038850" y="400050"/>
             <a:ext cx="4953000" cy="6572250"/>
           </a:xfrm>
-          <a:prstGeom prst="roundRect">
+          <a:prstGeom xmlns:a="http://schemas.openxmlformats.org/drawingml/2006/main" prst="roundRect">
             <a:avLst>
               <a:gd name="adj" fmla="val 3462"/>
             </a:avLst>
           </a:prstGeom>
-          <a:solidFill>
+          <a:solidFill xmlns:a="http://schemas.openxmlformats.org/drawingml/2006/main">
             <a:srgbClr val="FFFAF0"/>
           </a:solidFill>
-          <a:ln w="19050">
+          <a:ln xmlns:a="http://schemas.openxmlformats.org/drawingml/2006/main" w="19050">
             <a:solidFill>
               <a:srgbClr val="D8C8A1"/>
             </a:solidFill>
@@ -791,48 +1222,47 @@
           </a:ln>
         </p:spPr>
         <p:txBody>
-          <a:bodyPr/>
-          <a:lstStyle/>
-          <a:p>
-            <a:endParaRPr lang="en-US"/>
-          </a:p>
+          <a:bodyPr xmlns:a="http://schemas.openxmlformats.org/drawingml/2006/main"/>
+          <a:lstStyle xmlns:a="http://schemas.openxmlformats.org/drawingml/2006/main"/>
+          <a:p xmlns:a="http://schemas.openxmlformats.org/drawingml/2006/main"/>
         </p:txBody>
       </p:sp>
       <p:sp>
         <p:nvSpPr>
           <p:cNvPr id="3" name="keyword-panel-title">
-            <a:extLst>
+            <a:extLst xmlns:a="http://schemas.openxmlformats.org/drawingml/2006/main">
               <a:ext uri="{FF2B5EF4-FFF2-40B4-BE49-F238E27FC236}">
                 <a16:creationId xmlns:a16="http://schemas.microsoft.com/office/drawing/2014/main" id="{CD6C686C-A432-499A-BDEC-8709B95E5ADE}"/>
               </a:ext>
             </a:extLst>
           </p:cNvPr>
           <p:cNvSpPr>
-            <a:spLocks noGrp="1"/>
-          </p:cNvSpPr>
-          <p:nvPr/>
-        </p:nvSpPr>
-        <p:spPr>
-          <a:xfrm>
+            <a:spLocks xmlns:a="http://schemas.openxmlformats.org/drawingml/2006/main" noGrp="1"/>
+          </p:cNvSpPr>
+          <p:nvPr/>
+        </p:nvSpPr>
+        <p:spPr>
+          <a:xfrm xmlns:a="http://schemas.openxmlformats.org/drawingml/2006/main">
             <a:off x="762000" y="590550"/>
             <a:ext cx="4191000" cy="400050"/>
           </a:xfrm>
-          <a:prstGeom prst="rect">
-            <a:avLst/>
-          </a:prstGeom>
-          <a:noFill/>
-          <a:ln w="0">
+          <a:prstGeom xmlns:a="http://schemas.openxmlformats.org/drawingml/2006/main" prst="rect">
+            <a:avLst/>
+          </a:prstGeom>
+          <a:noFill xmlns:a="http://schemas.openxmlformats.org/drawingml/2006/main"/>
+          <a:ln xmlns:a="http://schemas.openxmlformats.org/drawingml/2006/main" w="0">
             <a:noFill/>
             <a:prstDash val="solid"/>
           </a:ln>
         </p:spPr>
         <p:txBody>
-          <a:bodyPr lIns="0" tIns="0" rIns="0" bIns="0" anchor="ctr">
+          <a:bodyPr xmlns:a="http://schemas.openxmlformats.org/drawingml/2006/main" lIns="0" tIns="0" rIns="0" bIns="0" anchor="ctr">
             <a:normAutofit/>
           </a:bodyPr>
-          <a:lstStyle/>
-          <a:p>
+          <a:lstStyle xmlns:a="http://schemas.openxmlformats.org/drawingml/2006/main"/>
+          <a:p xmlns:a="http://schemas.openxmlformats.org/drawingml/2006/main">
             <a:pPr algn="l">
+              <a:buNone/>
               <a:defRPr sz="2400" b="1">
                 <a:solidFill>
                   <a:srgbClr val="111111"/>
@@ -859,38 +1289,39 @@
       <p:sp>
         <p:nvSpPr>
           <p:cNvPr id="4" name="keyword-panel-description">
-            <a:extLst>
+            <a:extLst xmlns:a="http://schemas.openxmlformats.org/drawingml/2006/main">
               <a:ext uri="{FF2B5EF4-FFF2-40B4-BE49-F238E27FC236}">
                 <a16:creationId xmlns:a16="http://schemas.microsoft.com/office/drawing/2014/main" id="{6542CF4B-9D07-45E6-A4B0-1E534E62DB96}"/>
               </a:ext>
             </a:extLst>
           </p:cNvPr>
           <p:cNvSpPr>
-            <a:spLocks noGrp="1"/>
-          </p:cNvSpPr>
-          <p:nvPr/>
-        </p:nvSpPr>
-        <p:spPr>
-          <a:xfrm>
+            <a:spLocks xmlns:a="http://schemas.openxmlformats.org/drawingml/2006/main" noGrp="1"/>
+          </p:cNvSpPr>
+          <p:nvPr/>
+        </p:nvSpPr>
+        <p:spPr>
+          <a:xfrm xmlns:a="http://schemas.openxmlformats.org/drawingml/2006/main">
             <a:off x="762000" y="1066800"/>
             <a:ext cx="4191000" cy="1104900"/>
           </a:xfrm>
-          <a:prstGeom prst="rect">
-            <a:avLst/>
-          </a:prstGeom>
-          <a:noFill/>
-          <a:ln w="0">
+          <a:prstGeom xmlns:a="http://schemas.openxmlformats.org/drawingml/2006/main" prst="rect">
+            <a:avLst/>
+          </a:prstGeom>
+          <a:noFill xmlns:a="http://schemas.openxmlformats.org/drawingml/2006/main"/>
+          <a:ln xmlns:a="http://schemas.openxmlformats.org/drawingml/2006/main" w="0">
             <a:noFill/>
             <a:prstDash val="solid"/>
           </a:ln>
         </p:spPr>
         <p:txBody>
-          <a:bodyPr lIns="0" tIns="0" rIns="0" bIns="0" anchor="t">
+          <a:bodyPr xmlns:a="http://schemas.openxmlformats.org/drawingml/2006/main" lIns="0" tIns="0" rIns="0" bIns="0" anchor="t">
             <a:normAutofit fontScale="87879" lnSpcReduction="10000"/>
           </a:bodyPr>
-          <a:lstStyle/>
-          <a:p>
+          <a:lstStyle xmlns:a="http://schemas.openxmlformats.org/drawingml/2006/main"/>
+          <a:p xmlns:a="http://schemas.openxmlformats.org/drawingml/2006/main">
             <a:pPr algn="l">
+              <a:buNone/>
               <a:defRPr sz="1650">
                 <a:solidFill>
                   <a:srgbClr val="333333"/>
@@ -901,7 +1332,7 @@
               </a:defRPr>
             </a:pPr>
             <a:r>
-              <a:rPr sz="1650" dirty="0">
+              <a:rPr sz="1650">
                 <a:solidFill>
                   <a:srgbClr val="333333"/>
                 </a:solidFill>
@@ -912,18 +1343,10 @@
               <a:t>A reader searches for posts by using up to four keywords.</a:t>
             </a:r>
           </a:p>
-          <a:p>
-            <a:endParaRPr sz="1650" dirty="0">
-              <a:solidFill>
-                <a:srgbClr val="333333"/>
-              </a:solidFill>
-              <a:latin typeface="Arial"/>
-              <a:ea typeface="Arial"/>
-              <a:cs typeface="Arial"/>
-            </a:endParaRPr>
-          </a:p>
-          <a:p>
+          <a:p xmlns:a="http://schemas.openxmlformats.org/drawingml/2006/main"/>
+          <a:p xmlns:a="http://schemas.openxmlformats.org/drawingml/2006/main">
             <a:pPr algn="l">
+              <a:buNone/>
               <a:defRPr sz="1650">
                 <a:solidFill>
                   <a:srgbClr val="333333"/>
@@ -934,7 +1357,7 @@
               </a:defRPr>
             </a:pPr>
             <a:r>
-              <a:rPr sz="1650" dirty="0">
+              <a:rPr sz="1650">
                 <a:solidFill>
                   <a:srgbClr val="333333"/>
                 </a:solidFill>
@@ -950,38 +1373,39 @@
       <p:sp>
         <p:nvSpPr>
           <p:cNvPr id="5" name="browse-panel-title">
-            <a:extLst>
+            <a:extLst xmlns:a="http://schemas.openxmlformats.org/drawingml/2006/main">
               <a:ext uri="{FF2B5EF4-FFF2-40B4-BE49-F238E27FC236}">
                 <a16:creationId xmlns:a16="http://schemas.microsoft.com/office/drawing/2014/main" id="{EC3F7A36-21ED-4769-A913-9586D1D4851A}"/>
               </a:ext>
             </a:extLst>
           </p:cNvPr>
           <p:cNvSpPr>
-            <a:spLocks noGrp="1"/>
-          </p:cNvSpPr>
-          <p:nvPr/>
-        </p:nvSpPr>
-        <p:spPr>
-          <a:xfrm>
+            <a:spLocks xmlns:a="http://schemas.openxmlformats.org/drawingml/2006/main" noGrp="1"/>
+          </p:cNvSpPr>
+          <p:nvPr/>
+        </p:nvSpPr>
+        <p:spPr>
+          <a:xfrm xmlns:a="http://schemas.openxmlformats.org/drawingml/2006/main">
             <a:off x="6362700" y="590550"/>
             <a:ext cx="4191000" cy="400050"/>
           </a:xfrm>
-          <a:prstGeom prst="rect">
-            <a:avLst/>
-          </a:prstGeom>
-          <a:noFill/>
-          <a:ln w="0">
+          <a:prstGeom xmlns:a="http://schemas.openxmlformats.org/drawingml/2006/main" prst="rect">
+            <a:avLst/>
+          </a:prstGeom>
+          <a:noFill xmlns:a="http://schemas.openxmlformats.org/drawingml/2006/main"/>
+          <a:ln xmlns:a="http://schemas.openxmlformats.org/drawingml/2006/main" w="0">
             <a:noFill/>
             <a:prstDash val="solid"/>
           </a:ln>
         </p:spPr>
         <p:txBody>
-          <a:bodyPr lIns="0" tIns="0" rIns="0" bIns="0" anchor="ctr">
-            <a:normAutofit/>
+          <a:bodyPr xmlns:a="http://schemas.openxmlformats.org/drawingml/2006/main" lIns="0" tIns="0" rIns="0" bIns="0" anchor="ctr">
+            <a:normAutofit fontScale="100000"/>
           </a:bodyPr>
-          <a:lstStyle/>
-          <a:p>
+          <a:lstStyle xmlns:a="http://schemas.openxmlformats.org/drawingml/2006/main"/>
+          <a:p xmlns:a="http://schemas.openxmlformats.org/drawingml/2006/main">
             <a:pPr algn="l">
+              <a:buNone/>
               <a:defRPr sz="2400" b="1">
                 <a:solidFill>
                   <a:srgbClr val="111111"/>
@@ -1000,7 +1424,7 @@
                 <a:ea typeface="Arial"/>
                 <a:cs typeface="Arial"/>
               </a:rPr>
-              <a:t>Browse by Topic</a:t>
+              <a:t>Browse Topics</a:t>
             </a:r>
           </a:p>
         </p:txBody>
@@ -1008,38 +1432,39 @@
       <p:sp>
         <p:nvSpPr>
           <p:cNvPr id="6" name="browse-panel-description">
-            <a:extLst>
+            <a:extLst xmlns:a="http://schemas.openxmlformats.org/drawingml/2006/main">
               <a:ext uri="{FF2B5EF4-FFF2-40B4-BE49-F238E27FC236}">
                 <a16:creationId xmlns:a16="http://schemas.microsoft.com/office/drawing/2014/main" id="{D470D1FB-468B-404C-8DEA-43D8D7683069}"/>
               </a:ext>
             </a:extLst>
           </p:cNvPr>
           <p:cNvSpPr>
-            <a:spLocks noGrp="1"/>
-          </p:cNvSpPr>
-          <p:nvPr/>
-        </p:nvSpPr>
-        <p:spPr>
-          <a:xfrm>
+            <a:spLocks xmlns:a="http://schemas.openxmlformats.org/drawingml/2006/main" noGrp="1"/>
+          </p:cNvSpPr>
+          <p:nvPr/>
+        </p:nvSpPr>
+        <p:spPr>
+          <a:xfrm xmlns:a="http://schemas.openxmlformats.org/drawingml/2006/main">
             <a:off x="6362700" y="1066800"/>
             <a:ext cx="4191000" cy="514350"/>
           </a:xfrm>
-          <a:prstGeom prst="rect">
-            <a:avLst/>
-          </a:prstGeom>
-          <a:noFill/>
-          <a:ln w="0">
+          <a:prstGeom xmlns:a="http://schemas.openxmlformats.org/drawingml/2006/main" prst="rect">
+            <a:avLst/>
+          </a:prstGeom>
+          <a:noFill xmlns:a="http://schemas.openxmlformats.org/drawingml/2006/main"/>
+          <a:ln xmlns:a="http://schemas.openxmlformats.org/drawingml/2006/main" w="0">
             <a:noFill/>
             <a:prstDash val="solid"/>
           </a:ln>
         </p:spPr>
         <p:txBody>
-          <a:bodyPr lIns="0" tIns="0" rIns="0" bIns="0" anchor="t">
-            <a:normAutofit/>
+          <a:bodyPr xmlns:a="http://schemas.openxmlformats.org/drawingml/2006/main" lIns="0" tIns="0" rIns="0" bIns="0" anchor="t">
+            <a:normAutofit fontScale="100000"/>
           </a:bodyPr>
-          <a:lstStyle/>
-          <a:p>
+          <a:lstStyle xmlns:a="http://schemas.openxmlformats.org/drawingml/2006/main"/>
+          <a:p xmlns:a="http://schemas.openxmlformats.org/drawingml/2006/main">
             <a:pPr algn="l">
+              <a:buNone/>
               <a:defRPr sz="1650">
                 <a:solidFill>
                   <a:srgbClr val="333333"/>
@@ -1050,7 +1475,7 @@
               </a:defRPr>
             </a:pPr>
             <a:r>
-              <a:rPr sz="1500" dirty="0">
+              <a:rPr sz="1500">
                 <a:solidFill>
                   <a:srgbClr val="333333"/>
                 </a:solidFill>
@@ -1058,7 +1483,7 @@
                 <a:ea typeface="Arial"/>
                 <a:cs typeface="Arial"/>
               </a:rPr>
-              <a:t>A reader moves from broad subject areas to specific posts.</a:t>
+              <a:t>Two subject-area structures are being tested. One will be selected.</a:t>
             </a:r>
           </a:p>
         </p:txBody>
@@ -1066,31 +1491,31 @@
       <p:sp>
         <p:nvSpPr>
           <p:cNvPr id="7" name="subject-areas-node">
-            <a:extLst>
+            <a:extLst xmlns:a="http://schemas.openxmlformats.org/drawingml/2006/main">
               <a:ext uri="{FF2B5EF4-FFF2-40B4-BE49-F238E27FC236}">
                 <a16:creationId xmlns:a16="http://schemas.microsoft.com/office/drawing/2014/main" id="{B44DE2FF-4B38-4AA0-A8A9-5B79F2E56B75}"/>
               </a:ext>
             </a:extLst>
           </p:cNvPr>
           <p:cNvSpPr>
-            <a:spLocks noGrp="1"/>
-          </p:cNvSpPr>
-          <p:nvPr/>
-        </p:nvSpPr>
-        <p:spPr>
-          <a:xfrm>
+            <a:spLocks xmlns:a="http://schemas.openxmlformats.org/drawingml/2006/main" noGrp="1"/>
+          </p:cNvSpPr>
+          <p:nvPr/>
+        </p:nvSpPr>
+        <p:spPr>
+          <a:xfrm xmlns:a="http://schemas.openxmlformats.org/drawingml/2006/main">
             <a:off x="6419850" y="1714500"/>
             <a:ext cx="4191000" cy="857250"/>
           </a:xfrm>
-          <a:prstGeom prst="roundRect">
+          <a:prstGeom xmlns:a="http://schemas.openxmlformats.org/drawingml/2006/main" prst="roundRect">
             <a:avLst>
               <a:gd name="adj" fmla="val 15556"/>
             </a:avLst>
           </a:prstGeom>
-          <a:solidFill>
+          <a:solidFill xmlns:a="http://schemas.openxmlformats.org/drawingml/2006/main">
             <a:srgbClr val="F3D894"/>
           </a:solidFill>
-          <a:ln w="23813">
+          <a:ln xmlns:a="http://schemas.openxmlformats.org/drawingml/2006/main" w="23813">
             <a:solidFill>
               <a:srgbClr val="B98729"/>
             </a:solidFill>
@@ -1098,41 +1523,39 @@
           </a:ln>
         </p:spPr>
         <p:txBody>
-          <a:bodyPr/>
-          <a:lstStyle/>
-          <a:p>
-            <a:endParaRPr lang="en-US"/>
-          </a:p>
+          <a:bodyPr xmlns:a="http://schemas.openxmlformats.org/drawingml/2006/main"/>
+          <a:lstStyle xmlns:a="http://schemas.openxmlformats.org/drawingml/2006/main"/>
+          <a:p xmlns:a="http://schemas.openxmlformats.org/drawingml/2006/main"/>
         </p:txBody>
       </p:sp>
       <p:sp>
         <p:nvSpPr>
           <p:cNvPr id="8" name="categories-node">
-            <a:extLst>
+            <a:extLst xmlns:a="http://schemas.openxmlformats.org/drawingml/2006/main">
               <a:ext uri="{FF2B5EF4-FFF2-40B4-BE49-F238E27FC236}">
                 <a16:creationId xmlns:a16="http://schemas.microsoft.com/office/drawing/2014/main" id="{8E11B6A4-9520-4A78-97DD-C4417B4B8514}"/>
               </a:ext>
             </a:extLst>
           </p:cNvPr>
           <p:cNvSpPr>
-            <a:spLocks noGrp="1"/>
-          </p:cNvSpPr>
-          <p:nvPr/>
-        </p:nvSpPr>
-        <p:spPr>
-          <a:xfrm>
+            <a:spLocks xmlns:a="http://schemas.openxmlformats.org/drawingml/2006/main" noGrp="1"/>
+          </p:cNvSpPr>
+          <p:nvPr/>
+        </p:nvSpPr>
+        <p:spPr>
+          <a:xfrm xmlns:a="http://schemas.openxmlformats.org/drawingml/2006/main">
             <a:off x="6419850" y="3038475"/>
             <a:ext cx="4191000" cy="857250"/>
           </a:xfrm>
-          <a:prstGeom prst="roundRect">
+          <a:prstGeom xmlns:a="http://schemas.openxmlformats.org/drawingml/2006/main" prst="roundRect">
             <a:avLst>
               <a:gd name="adj" fmla="val 15556"/>
             </a:avLst>
           </a:prstGeom>
-          <a:solidFill>
+          <a:solidFill xmlns:a="http://schemas.openxmlformats.org/drawingml/2006/main">
             <a:srgbClr val="FFF4CF"/>
           </a:solidFill>
-          <a:ln w="23813">
+          <a:ln xmlns:a="http://schemas.openxmlformats.org/drawingml/2006/main" w="23813">
             <a:solidFill>
               <a:srgbClr val="CAA44F"/>
             </a:solidFill>
@@ -1140,41 +1563,39 @@
           </a:ln>
         </p:spPr>
         <p:txBody>
-          <a:bodyPr/>
-          <a:lstStyle/>
-          <a:p>
-            <a:endParaRPr lang="en-US"/>
-          </a:p>
+          <a:bodyPr xmlns:a="http://schemas.openxmlformats.org/drawingml/2006/main"/>
+          <a:lstStyle xmlns:a="http://schemas.openxmlformats.org/drawingml/2006/main"/>
+          <a:p xmlns:a="http://schemas.openxmlformats.org/drawingml/2006/main"/>
         </p:txBody>
       </p:sp>
       <p:sp>
         <p:nvSpPr>
           <p:cNvPr id="9" name="topics-node">
-            <a:extLst>
+            <a:extLst xmlns:a="http://schemas.openxmlformats.org/drawingml/2006/main">
               <a:ext uri="{FF2B5EF4-FFF2-40B4-BE49-F238E27FC236}">
                 <a16:creationId xmlns:a16="http://schemas.microsoft.com/office/drawing/2014/main" id="{45147D1D-6CDA-47A5-AB09-3BBECA29D196}"/>
               </a:ext>
             </a:extLst>
           </p:cNvPr>
           <p:cNvSpPr>
-            <a:spLocks noGrp="1"/>
-          </p:cNvSpPr>
-          <p:nvPr/>
-        </p:nvSpPr>
-        <p:spPr>
-          <a:xfrm>
+            <a:spLocks xmlns:a="http://schemas.openxmlformats.org/drawingml/2006/main" noGrp="1"/>
+          </p:cNvSpPr>
+          <p:nvPr/>
+        </p:nvSpPr>
+        <p:spPr>
+          <a:xfrm xmlns:a="http://schemas.openxmlformats.org/drawingml/2006/main">
             <a:off x="6419850" y="4362450"/>
             <a:ext cx="4191000" cy="857250"/>
           </a:xfrm>
-          <a:prstGeom prst="roundRect">
+          <a:prstGeom xmlns:a="http://schemas.openxmlformats.org/drawingml/2006/main" prst="roundRect">
             <a:avLst>
               <a:gd name="adj" fmla="val 15556"/>
             </a:avLst>
           </a:prstGeom>
-          <a:solidFill>
+          <a:solidFill xmlns:a="http://schemas.openxmlformats.org/drawingml/2006/main">
             <a:srgbClr val="E9F3FB"/>
           </a:solidFill>
-          <a:ln w="23813">
+          <a:ln xmlns:a="http://schemas.openxmlformats.org/drawingml/2006/main" w="23813">
             <a:solidFill>
               <a:srgbClr val="3D7FA6"/>
             </a:solidFill>
@@ -1182,41 +1603,39 @@
           </a:ln>
         </p:spPr>
         <p:txBody>
-          <a:bodyPr/>
-          <a:lstStyle/>
-          <a:p>
-            <a:endParaRPr lang="en-US"/>
-          </a:p>
+          <a:bodyPr xmlns:a="http://schemas.openxmlformats.org/drawingml/2006/main"/>
+          <a:lstStyle xmlns:a="http://schemas.openxmlformats.org/drawingml/2006/main"/>
+          <a:p xmlns:a="http://schemas.openxmlformats.org/drawingml/2006/main"/>
         </p:txBody>
       </p:sp>
       <p:sp>
         <p:nvSpPr>
           <p:cNvPr id="10" name="browse-posts-node">
-            <a:extLst>
+            <a:extLst xmlns:a="http://schemas.openxmlformats.org/drawingml/2006/main">
               <a:ext uri="{FF2B5EF4-FFF2-40B4-BE49-F238E27FC236}">
                 <a16:creationId xmlns:a16="http://schemas.microsoft.com/office/drawing/2014/main" id="{67F6984B-843B-4CE5-9C6E-E66709777A9F}"/>
               </a:ext>
             </a:extLst>
           </p:cNvPr>
           <p:cNvSpPr>
-            <a:spLocks noGrp="1"/>
-          </p:cNvSpPr>
-          <p:nvPr/>
-        </p:nvSpPr>
-        <p:spPr>
-          <a:xfrm>
+            <a:spLocks xmlns:a="http://schemas.openxmlformats.org/drawingml/2006/main" noGrp="1"/>
+          </p:cNvSpPr>
+          <p:nvPr/>
+        </p:nvSpPr>
+        <p:spPr>
+          <a:xfrm xmlns:a="http://schemas.openxmlformats.org/drawingml/2006/main">
             <a:off x="6419850" y="5686425"/>
             <a:ext cx="4191000" cy="857250"/>
           </a:xfrm>
-          <a:prstGeom prst="roundRect">
+          <a:prstGeom xmlns:a="http://schemas.openxmlformats.org/drawingml/2006/main" prst="roundRect">
             <a:avLst>
               <a:gd name="adj" fmla="val 15556"/>
             </a:avLst>
           </a:prstGeom>
-          <a:solidFill>
+          <a:solidFill xmlns:a="http://schemas.openxmlformats.org/drawingml/2006/main">
             <a:srgbClr val="E8F4E5"/>
           </a:solidFill>
-          <a:ln w="23813">
+          <a:ln xmlns:a="http://schemas.openxmlformats.org/drawingml/2006/main" w="23813">
             <a:solidFill>
               <a:srgbClr val="5B9351"/>
             </a:solidFill>
@@ -1224,41 +1643,39 @@
           </a:ln>
         </p:spPr>
         <p:txBody>
-          <a:bodyPr/>
-          <a:lstStyle/>
-          <a:p>
-            <a:endParaRPr lang="en-US"/>
-          </a:p>
+          <a:bodyPr xmlns:a="http://schemas.openxmlformats.org/drawingml/2006/main"/>
+          <a:lstStyle xmlns:a="http://schemas.openxmlformats.org/drawingml/2006/main"/>
+          <a:p xmlns:a="http://schemas.openxmlformats.org/drawingml/2006/main"/>
         </p:txBody>
       </p:sp>
       <p:sp>
         <p:nvSpPr>
           <p:cNvPr id="11" name="search-terms-node">
-            <a:extLst>
+            <a:extLst xmlns:a="http://schemas.openxmlformats.org/drawingml/2006/main">
               <a:ext uri="{FF2B5EF4-FFF2-40B4-BE49-F238E27FC236}">
                 <a16:creationId xmlns:a16="http://schemas.microsoft.com/office/drawing/2014/main" id="{7B911D94-11EE-4645-B54B-8CBF3E522938}"/>
               </a:ext>
             </a:extLst>
           </p:cNvPr>
           <p:cNvSpPr>
-            <a:spLocks noGrp="1"/>
-          </p:cNvSpPr>
-          <p:nvPr/>
-        </p:nvSpPr>
-        <p:spPr>
-          <a:xfrm>
+            <a:spLocks xmlns:a="http://schemas.openxmlformats.org/drawingml/2006/main" noGrp="1"/>
+          </p:cNvSpPr>
+          <p:nvPr/>
+        </p:nvSpPr>
+        <p:spPr>
+          <a:xfrm xmlns:a="http://schemas.openxmlformats.org/drawingml/2006/main">
             <a:off x="819150" y="2628900"/>
             <a:ext cx="4191000" cy="857250"/>
           </a:xfrm>
-          <a:prstGeom prst="roundRect">
+          <a:prstGeom xmlns:a="http://schemas.openxmlformats.org/drawingml/2006/main" prst="roundRect">
             <a:avLst>
               <a:gd name="adj" fmla="val 15556"/>
             </a:avLst>
           </a:prstGeom>
-          <a:solidFill>
+          <a:solidFill xmlns:a="http://schemas.openxmlformats.org/drawingml/2006/main">
             <a:srgbClr val="E9F3FB"/>
           </a:solidFill>
-          <a:ln w="23813">
+          <a:ln xmlns:a="http://schemas.openxmlformats.org/drawingml/2006/main" w="23813">
             <a:solidFill>
               <a:srgbClr val="6F6F6F"/>
             </a:solidFill>
@@ -1266,41 +1683,39 @@
           </a:ln>
         </p:spPr>
         <p:txBody>
-          <a:bodyPr/>
-          <a:lstStyle/>
-          <a:p>
-            <a:endParaRPr lang="en-US"/>
-          </a:p>
+          <a:bodyPr xmlns:a="http://schemas.openxmlformats.org/drawingml/2006/main"/>
+          <a:lstStyle xmlns:a="http://schemas.openxmlformats.org/drawingml/2006/main"/>
+          <a:p xmlns:a="http://schemas.openxmlformats.org/drawingml/2006/main"/>
         </p:txBody>
       </p:sp>
       <p:sp>
         <p:nvSpPr>
           <p:cNvPr id="12" name="secondary-keywords-fill">
-            <a:extLst>
+            <a:extLst xmlns:a="http://schemas.openxmlformats.org/drawingml/2006/main">
               <a:ext uri="{FF2B5EF4-FFF2-40B4-BE49-F238E27FC236}">
                 <a16:creationId xmlns:a16="http://schemas.microsoft.com/office/drawing/2014/main" id="{9CFC8154-69FF-4F95-B8F9-2EDBD5683FD0}"/>
               </a:ext>
             </a:extLst>
           </p:cNvPr>
           <p:cNvSpPr>
-            <a:spLocks noGrp="1"/>
-          </p:cNvSpPr>
-          <p:nvPr/>
-        </p:nvSpPr>
-        <p:spPr>
-          <a:xfrm>
+            <a:spLocks xmlns:a="http://schemas.openxmlformats.org/drawingml/2006/main" noGrp="1"/>
+          </p:cNvSpPr>
+          <p:nvPr/>
+        </p:nvSpPr>
+        <p:spPr>
+          <a:xfrm xmlns:a="http://schemas.openxmlformats.org/drawingml/2006/main">
             <a:off x="2914650" y="2628900"/>
             <a:ext cx="2095500" cy="857250"/>
           </a:xfrm>
-          <a:prstGeom prst="roundRect">
+          <a:prstGeom xmlns:a="http://schemas.openxmlformats.org/drawingml/2006/main" prst="roundRect">
             <a:avLst>
               <a:gd name="adj" fmla="val 15556"/>
             </a:avLst>
           </a:prstGeom>
-          <a:solidFill>
+          <a:solidFill xmlns:a="http://schemas.openxmlformats.org/drawingml/2006/main">
             <a:srgbClr val="F0EAF7"/>
           </a:solidFill>
-          <a:ln w="0">
+          <a:ln xmlns:a="http://schemas.openxmlformats.org/drawingml/2006/main" w="0">
             <a:solidFill>
               <a:srgbClr val="F0EAF7"/>
             </a:solidFill>
@@ -1308,39 +1723,37 @@
           </a:ln>
         </p:spPr>
         <p:txBody>
-          <a:bodyPr/>
-          <a:lstStyle/>
-          <a:p>
-            <a:endParaRPr lang="en-US"/>
-          </a:p>
+          <a:bodyPr xmlns:a="http://schemas.openxmlformats.org/drawingml/2006/main"/>
+          <a:lstStyle xmlns:a="http://schemas.openxmlformats.org/drawingml/2006/main"/>
+          <a:p xmlns:a="http://schemas.openxmlformats.org/drawingml/2006/main"/>
         </p:txBody>
       </p:sp>
       <p:sp>
         <p:nvSpPr>
           <p:cNvPr id="13" name="secondary-keywords-center-fill">
-            <a:extLst>
+            <a:extLst xmlns:a="http://schemas.openxmlformats.org/drawingml/2006/main">
               <a:ext uri="{FF2B5EF4-FFF2-40B4-BE49-F238E27FC236}">
                 <a16:creationId xmlns:a16="http://schemas.microsoft.com/office/drawing/2014/main" id="{A49212D4-8A4B-433F-9B6F-7C09050B8525}"/>
               </a:ext>
             </a:extLst>
           </p:cNvPr>
           <p:cNvSpPr>
-            <a:spLocks noGrp="1"/>
-          </p:cNvSpPr>
-          <p:nvPr/>
-        </p:nvSpPr>
-        <p:spPr>
-          <a:xfrm>
+            <a:spLocks xmlns:a="http://schemas.openxmlformats.org/drawingml/2006/main" noGrp="1"/>
+          </p:cNvSpPr>
+          <p:nvPr/>
+        </p:nvSpPr>
+        <p:spPr>
+          <a:xfrm xmlns:a="http://schemas.openxmlformats.org/drawingml/2006/main">
             <a:off x="2914650" y="2628900"/>
             <a:ext cx="209550" cy="857250"/>
           </a:xfrm>
-          <a:prstGeom prst="rect">
-            <a:avLst/>
-          </a:prstGeom>
-          <a:solidFill>
+          <a:prstGeom xmlns:a="http://schemas.openxmlformats.org/drawingml/2006/main" prst="rect">
+            <a:avLst/>
+          </a:prstGeom>
+          <a:solidFill xmlns:a="http://schemas.openxmlformats.org/drawingml/2006/main">
             <a:srgbClr val="F0EAF7"/>
           </a:solidFill>
-          <a:ln w="0">
+          <a:ln xmlns:a="http://schemas.openxmlformats.org/drawingml/2006/main" w="0">
             <a:solidFill>
               <a:srgbClr val="F0EAF7"/>
             </a:solidFill>
@@ -1348,39 +1761,37 @@
           </a:ln>
         </p:spPr>
         <p:txBody>
-          <a:bodyPr/>
-          <a:lstStyle/>
-          <a:p>
-            <a:endParaRPr lang="en-US"/>
-          </a:p>
+          <a:bodyPr xmlns:a="http://schemas.openxmlformats.org/drawingml/2006/main"/>
+          <a:lstStyle xmlns:a="http://schemas.openxmlformats.org/drawingml/2006/main"/>
+          <a:p xmlns:a="http://schemas.openxmlformats.org/drawingml/2006/main"/>
         </p:txBody>
       </p:sp>
       <p:sp>
         <p:nvSpPr>
           <p:cNvPr id="14" name="search-terms-outline">
-            <a:extLst>
+            <a:extLst xmlns:a="http://schemas.openxmlformats.org/drawingml/2006/main">
               <a:ext uri="{FF2B5EF4-FFF2-40B4-BE49-F238E27FC236}">
                 <a16:creationId xmlns:a16="http://schemas.microsoft.com/office/drawing/2014/main" id="{0BF5A886-194C-40DC-8F73-A921A26B67BA}"/>
               </a:ext>
             </a:extLst>
           </p:cNvPr>
           <p:cNvSpPr>
-            <a:spLocks noGrp="1"/>
-          </p:cNvSpPr>
-          <p:nvPr/>
-        </p:nvSpPr>
-        <p:spPr>
-          <a:xfrm>
+            <a:spLocks xmlns:a="http://schemas.openxmlformats.org/drawingml/2006/main" noGrp="1"/>
+          </p:cNvSpPr>
+          <p:nvPr/>
+        </p:nvSpPr>
+        <p:spPr>
+          <a:xfrm xmlns:a="http://schemas.openxmlformats.org/drawingml/2006/main">
             <a:off x="819150" y="2628900"/>
             <a:ext cx="4191000" cy="857250"/>
           </a:xfrm>
-          <a:prstGeom prst="roundRect">
+          <a:prstGeom xmlns:a="http://schemas.openxmlformats.org/drawingml/2006/main" prst="roundRect">
             <a:avLst>
               <a:gd name="adj" fmla="val 15556"/>
             </a:avLst>
           </a:prstGeom>
-          <a:noFill/>
-          <a:ln w="23813">
+          <a:noFill xmlns:a="http://schemas.openxmlformats.org/drawingml/2006/main"/>
+          <a:ln xmlns:a="http://schemas.openxmlformats.org/drawingml/2006/main" w="23813">
             <a:solidFill>
               <a:srgbClr val="6F6F6F"/>
             </a:solidFill>
@@ -1388,37 +1799,35 @@
           </a:ln>
         </p:spPr>
         <p:txBody>
-          <a:bodyPr/>
-          <a:lstStyle/>
-          <a:p>
-            <a:endParaRPr lang="en-US"/>
-          </a:p>
+          <a:bodyPr xmlns:a="http://schemas.openxmlformats.org/drawingml/2006/main"/>
+          <a:lstStyle xmlns:a="http://schemas.openxmlformats.org/drawingml/2006/main"/>
+          <a:p xmlns:a="http://schemas.openxmlformats.org/drawingml/2006/main"/>
         </p:txBody>
       </p:sp>
       <p:sp>
         <p:nvSpPr>
           <p:cNvPr id="15" name="search-terms-divider">
-            <a:extLst>
+            <a:extLst xmlns:a="http://schemas.openxmlformats.org/drawingml/2006/main">
               <a:ext uri="{FF2B5EF4-FFF2-40B4-BE49-F238E27FC236}">
                 <a16:creationId xmlns:a16="http://schemas.microsoft.com/office/drawing/2014/main" id="{72522897-0730-46E1-ABA4-9425190869E7}"/>
               </a:ext>
             </a:extLst>
           </p:cNvPr>
           <p:cNvSpPr>
-            <a:spLocks noGrp="1"/>
-          </p:cNvSpPr>
-          <p:nvPr/>
-        </p:nvSpPr>
-        <p:spPr>
-          <a:xfrm>
+            <a:spLocks xmlns:a="http://schemas.openxmlformats.org/drawingml/2006/main" noGrp="1"/>
+          </p:cNvSpPr>
+          <p:nvPr/>
+        </p:nvSpPr>
+        <p:spPr>
+          <a:xfrm xmlns:a="http://schemas.openxmlformats.org/drawingml/2006/main">
             <a:off x="2914650" y="2628900"/>
             <a:ext cx="0" cy="857250"/>
           </a:xfrm>
-          <a:prstGeom prst="line">
-            <a:avLst/>
-          </a:prstGeom>
-          <a:noFill/>
-          <a:ln w="19050">
+          <a:prstGeom xmlns:a="http://schemas.openxmlformats.org/drawingml/2006/main" prst="line">
+            <a:avLst/>
+          </a:prstGeom>
+          <a:noFill xmlns:a="http://schemas.openxmlformats.org/drawingml/2006/main"/>
+          <a:ln xmlns:a="http://schemas.openxmlformats.org/drawingml/2006/main" w="19050">
             <a:solidFill>
               <a:srgbClr val="6F6F6F"/>
             </a:solidFill>
@@ -1426,41 +1835,39 @@
           </a:ln>
         </p:spPr>
         <p:txBody>
-          <a:bodyPr/>
-          <a:lstStyle/>
-          <a:p>
-            <a:endParaRPr lang="en-US"/>
-          </a:p>
+          <a:bodyPr xmlns:a="http://schemas.openxmlformats.org/drawingml/2006/main"/>
+          <a:lstStyle xmlns:a="http://schemas.openxmlformats.org/drawingml/2006/main"/>
+          <a:p xmlns:a="http://schemas.openxmlformats.org/drawingml/2006/main"/>
         </p:txBody>
       </p:sp>
       <p:sp>
         <p:nvSpPr>
           <p:cNvPr id="16" name="search-posts-node">
-            <a:extLst>
+            <a:extLst xmlns:a="http://schemas.openxmlformats.org/drawingml/2006/main">
               <a:ext uri="{FF2B5EF4-FFF2-40B4-BE49-F238E27FC236}">
                 <a16:creationId xmlns:a16="http://schemas.microsoft.com/office/drawing/2014/main" id="{366B400F-508A-4215-9F1B-852F204F8B14}"/>
               </a:ext>
             </a:extLst>
           </p:cNvPr>
           <p:cNvSpPr>
-            <a:spLocks noGrp="1"/>
-          </p:cNvSpPr>
-          <p:nvPr/>
-        </p:nvSpPr>
-        <p:spPr>
-          <a:xfrm>
+            <a:spLocks xmlns:a="http://schemas.openxmlformats.org/drawingml/2006/main" noGrp="1"/>
+          </p:cNvSpPr>
+          <p:nvPr/>
+        </p:nvSpPr>
+        <p:spPr>
+          <a:xfrm xmlns:a="http://schemas.openxmlformats.org/drawingml/2006/main">
             <a:off x="819150" y="3943350"/>
             <a:ext cx="4191000" cy="857250"/>
           </a:xfrm>
-          <a:prstGeom prst="roundRect">
+          <a:prstGeom xmlns:a="http://schemas.openxmlformats.org/drawingml/2006/main" prst="roundRect">
             <a:avLst>
               <a:gd name="adj" fmla="val 15556"/>
             </a:avLst>
           </a:prstGeom>
-          <a:solidFill>
+          <a:solidFill xmlns:a="http://schemas.openxmlformats.org/drawingml/2006/main">
             <a:srgbClr val="E8F4E5"/>
           </a:solidFill>
-          <a:ln w="23813">
+          <a:ln xmlns:a="http://schemas.openxmlformats.org/drawingml/2006/main" w="23813">
             <a:solidFill>
               <a:srgbClr val="5B9351"/>
             </a:solidFill>
@@ -1468,31 +1875,29 @@
           </a:ln>
         </p:spPr>
         <p:txBody>
-          <a:bodyPr/>
-          <a:lstStyle/>
-          <a:p>
-            <a:endParaRPr lang="en-US"/>
-          </a:p>
+          <a:bodyPr xmlns:a="http://schemas.openxmlformats.org/drawingml/2006/main"/>
+          <a:lstStyle xmlns:a="http://schemas.openxmlformats.org/drawingml/2006/main"/>
+          <a:p xmlns:a="http://schemas.openxmlformats.org/drawingml/2006/main"/>
         </p:txBody>
       </p:sp>
       <p:cxnSp>
         <p:nvCxnSpPr>
-          <p:cNvPr id="59" name="Straight Arrow Connector 58"/>
+          <p:cNvPr id="102" name="Straight Arrow Connector 58"/>
           <p:cNvCxnSpPr>
-            <a:stCxn id="7" idx="2"/>
-            <a:endCxn id="8" idx="0"/>
+            <a:stCxn xmlns:a="http://schemas.openxmlformats.org/drawingml/2006/main" id="7" idx="2"/>
+            <a:endCxn xmlns:a="http://schemas.openxmlformats.org/drawingml/2006/main" id="8" idx="0"/>
           </p:cNvCxnSpPr>
           <p:nvPr/>
         </p:nvCxnSpPr>
         <p:spPr>
-          <a:xfrm>
+          <a:xfrm xmlns:a="http://schemas.openxmlformats.org/drawingml/2006/main">
             <a:off x="8515350" y="2571750"/>
             <a:ext cx="0" cy="466725"/>
           </a:xfrm>
-          <a:prstGeom prst="straightConnector1">
-            <a:avLst/>
-          </a:prstGeom>
-          <a:ln w="23813">
+          <a:prstGeom xmlns:a="http://schemas.openxmlformats.org/drawingml/2006/main" prst="straightConnector1">
+            <a:avLst/>
+          </a:prstGeom>
+          <a:ln xmlns:a="http://schemas.openxmlformats.org/drawingml/2006/main" w="23813">
             <a:solidFill>
               <a:srgbClr val="7B1F1B"/>
             </a:solidFill>
@@ -1503,22 +1908,22 @@
       </p:cxnSp>
       <p:cxnSp>
         <p:nvCxnSpPr>
-          <p:cNvPr id="60" name="Straight Arrow Connector 59"/>
+          <p:cNvPr id="103" name="Straight Arrow Connector 59"/>
           <p:cNvCxnSpPr>
-            <a:stCxn id="8" idx="2"/>
-            <a:endCxn id="9" idx="0"/>
+            <a:stCxn xmlns:a="http://schemas.openxmlformats.org/drawingml/2006/main" id="8" idx="2"/>
+            <a:endCxn xmlns:a="http://schemas.openxmlformats.org/drawingml/2006/main" id="9" idx="0"/>
           </p:cNvCxnSpPr>
           <p:nvPr/>
         </p:nvCxnSpPr>
         <p:spPr>
-          <a:xfrm>
+          <a:xfrm xmlns:a="http://schemas.openxmlformats.org/drawingml/2006/main">
             <a:off x="8515350" y="3895725"/>
             <a:ext cx="0" cy="466725"/>
           </a:xfrm>
-          <a:prstGeom prst="straightConnector1">
-            <a:avLst/>
-          </a:prstGeom>
-          <a:ln w="23813">
+          <a:prstGeom xmlns:a="http://schemas.openxmlformats.org/drawingml/2006/main" prst="straightConnector1">
+            <a:avLst/>
+          </a:prstGeom>
+          <a:ln xmlns:a="http://schemas.openxmlformats.org/drawingml/2006/main" w="23813">
             <a:solidFill>
               <a:srgbClr val="7B1F1B"/>
             </a:solidFill>
@@ -1529,22 +1934,22 @@
       </p:cxnSp>
       <p:cxnSp>
         <p:nvCxnSpPr>
-          <p:cNvPr id="61" name="Straight Arrow Connector 60"/>
+          <p:cNvPr id="104" name="Straight Arrow Connector 60"/>
           <p:cNvCxnSpPr>
-            <a:stCxn id="9" idx="2"/>
-            <a:endCxn id="10" idx="0"/>
+            <a:stCxn xmlns:a="http://schemas.openxmlformats.org/drawingml/2006/main" id="9" idx="2"/>
+            <a:endCxn xmlns:a="http://schemas.openxmlformats.org/drawingml/2006/main" id="10" idx="0"/>
           </p:cNvCxnSpPr>
           <p:nvPr/>
         </p:nvCxnSpPr>
         <p:spPr>
-          <a:xfrm>
+          <a:xfrm xmlns:a="http://schemas.openxmlformats.org/drawingml/2006/main">
             <a:off x="8515350" y="5219700"/>
             <a:ext cx="0" cy="466725"/>
           </a:xfrm>
-          <a:prstGeom prst="straightConnector1">
-            <a:avLst/>
-          </a:prstGeom>
-          <a:ln w="23813">
+          <a:prstGeom xmlns:a="http://schemas.openxmlformats.org/drawingml/2006/main" prst="straightConnector1">
+            <a:avLst/>
+          </a:prstGeom>
+          <a:ln xmlns:a="http://schemas.openxmlformats.org/drawingml/2006/main" w="23813">
             <a:solidFill>
               <a:srgbClr val="7B1F1B"/>
             </a:solidFill>
@@ -1555,22 +1960,22 @@
       </p:cxnSp>
       <p:cxnSp>
         <p:nvCxnSpPr>
-          <p:cNvPr id="62" name="Straight Arrow Connector 61"/>
+          <p:cNvPr id="105" name="Straight Arrow Connector 61"/>
           <p:cNvCxnSpPr>
-            <a:stCxn id="11" idx="2"/>
-            <a:endCxn id="16" idx="0"/>
+            <a:stCxn xmlns:a="http://schemas.openxmlformats.org/drawingml/2006/main" id="11" idx="2"/>
+            <a:endCxn xmlns:a="http://schemas.openxmlformats.org/drawingml/2006/main" id="16" idx="0"/>
           </p:cNvCxnSpPr>
           <p:nvPr/>
         </p:nvCxnSpPr>
         <p:spPr>
-          <a:xfrm>
+          <a:xfrm xmlns:a="http://schemas.openxmlformats.org/drawingml/2006/main">
             <a:off x="2914650" y="3486150"/>
             <a:ext cx="0" cy="457200"/>
           </a:xfrm>
-          <a:prstGeom prst="straightConnector1">
-            <a:avLst/>
-          </a:prstGeom>
-          <a:ln w="23813">
+          <a:prstGeom xmlns:a="http://schemas.openxmlformats.org/drawingml/2006/main" prst="straightConnector1">
+            <a:avLst/>
+          </a:prstGeom>
+          <a:ln xmlns:a="http://schemas.openxmlformats.org/drawingml/2006/main" w="23813">
             <a:solidFill>
               <a:srgbClr val="7B1F1B"/>
             </a:solidFill>
@@ -1582,38 +1987,39 @@
       <p:sp>
         <p:nvSpPr>
           <p:cNvPr id="21" name="search-topics-title">
-            <a:extLst>
+            <a:extLst xmlns:a="http://schemas.openxmlformats.org/drawingml/2006/main">
               <a:ext uri="{FF2B5EF4-FFF2-40B4-BE49-F238E27FC236}">
                 <a16:creationId xmlns:a16="http://schemas.microsoft.com/office/drawing/2014/main" id="{ACD22332-7FCD-4440-9DD0-260582926B9C}"/>
               </a:ext>
             </a:extLst>
           </p:cNvPr>
           <p:cNvSpPr>
-            <a:spLocks noGrp="1"/>
-          </p:cNvSpPr>
-          <p:nvPr/>
-        </p:nvSpPr>
-        <p:spPr>
-          <a:xfrm>
+            <a:spLocks xmlns:a="http://schemas.openxmlformats.org/drawingml/2006/main" noGrp="1"/>
+          </p:cNvSpPr>
+          <p:nvPr/>
+        </p:nvSpPr>
+        <p:spPr>
+          <a:xfrm xmlns:a="http://schemas.openxmlformats.org/drawingml/2006/main">
             <a:off x="866775" y="2752725"/>
             <a:ext cx="2000250" cy="323850"/>
           </a:xfrm>
-          <a:prstGeom prst="rect">
-            <a:avLst/>
-          </a:prstGeom>
-          <a:noFill/>
-          <a:ln w="0">
+          <a:prstGeom xmlns:a="http://schemas.openxmlformats.org/drawingml/2006/main" prst="rect">
+            <a:avLst/>
+          </a:prstGeom>
+          <a:noFill xmlns:a="http://schemas.openxmlformats.org/drawingml/2006/main"/>
+          <a:ln xmlns:a="http://schemas.openxmlformats.org/drawingml/2006/main" w="0">
             <a:noFill/>
             <a:prstDash val="solid"/>
           </a:ln>
         </p:spPr>
         <p:txBody>
-          <a:bodyPr lIns="0" tIns="0" rIns="0" bIns="0" anchor="ctr">
+          <a:bodyPr xmlns:a="http://schemas.openxmlformats.org/drawingml/2006/main" lIns="0" tIns="0" rIns="0" bIns="0" anchor="ctr">
             <a:normAutofit/>
           </a:bodyPr>
-          <a:lstStyle/>
-          <a:p>
+          <a:lstStyle xmlns:a="http://schemas.openxmlformats.org/drawingml/2006/main"/>
+          <a:p xmlns:a="http://schemas.openxmlformats.org/drawingml/2006/main">
             <a:pPr algn="ctr">
+              <a:buNone/>
               <a:defRPr sz="1875" b="1">
                 <a:solidFill>
                   <a:srgbClr val="111111"/>
@@ -1640,38 +2046,39 @@
       <p:sp>
         <p:nvSpPr>
           <p:cNvPr id="22" name="search-topics-count">
-            <a:extLst>
+            <a:extLst xmlns:a="http://schemas.openxmlformats.org/drawingml/2006/main">
               <a:ext uri="{FF2B5EF4-FFF2-40B4-BE49-F238E27FC236}">
                 <a16:creationId xmlns:a16="http://schemas.microsoft.com/office/drawing/2014/main" id="{B690A045-FB30-44D9-A6C7-7E5D72C6C7AC}"/>
               </a:ext>
             </a:extLst>
           </p:cNvPr>
           <p:cNvSpPr>
-            <a:spLocks noGrp="1"/>
-          </p:cNvSpPr>
-          <p:nvPr/>
-        </p:nvSpPr>
-        <p:spPr>
-          <a:xfrm>
+            <a:spLocks xmlns:a="http://schemas.openxmlformats.org/drawingml/2006/main" noGrp="1"/>
+          </p:cNvSpPr>
+          <p:nvPr/>
+        </p:nvSpPr>
+        <p:spPr>
+          <a:xfrm xmlns:a="http://schemas.openxmlformats.org/drawingml/2006/main">
             <a:off x="866775" y="3086100"/>
             <a:ext cx="2000250" cy="266700"/>
           </a:xfrm>
-          <a:prstGeom prst="rect">
-            <a:avLst/>
-          </a:prstGeom>
-          <a:noFill/>
-          <a:ln w="0">
+          <a:prstGeom xmlns:a="http://schemas.openxmlformats.org/drawingml/2006/main" prst="rect">
+            <a:avLst/>
+          </a:prstGeom>
+          <a:noFill xmlns:a="http://schemas.openxmlformats.org/drawingml/2006/main"/>
+          <a:ln xmlns:a="http://schemas.openxmlformats.org/drawingml/2006/main" w="0">
             <a:noFill/>
             <a:prstDash val="solid"/>
           </a:ln>
         </p:spPr>
         <p:txBody>
-          <a:bodyPr lIns="0" tIns="0" rIns="0" bIns="0" anchor="ctr">
+          <a:bodyPr xmlns:a="http://schemas.openxmlformats.org/drawingml/2006/main" lIns="0" tIns="0" rIns="0" bIns="0" anchor="ctr">
             <a:normAutofit/>
           </a:bodyPr>
-          <a:lstStyle/>
-          <a:p>
+          <a:lstStyle xmlns:a="http://schemas.openxmlformats.org/drawingml/2006/main"/>
+          <a:p xmlns:a="http://schemas.openxmlformats.org/drawingml/2006/main">
             <a:pPr algn="ctr">
+              <a:buNone/>
               <a:defRPr sz="1650">
                 <a:solidFill>
                   <a:srgbClr val="333333"/>
@@ -1698,38 +2105,39 @@
       <p:sp>
         <p:nvSpPr>
           <p:cNvPr id="23" name="secondary-keywords-title">
-            <a:extLst>
+            <a:extLst xmlns:a="http://schemas.openxmlformats.org/drawingml/2006/main">
               <a:ext uri="{FF2B5EF4-FFF2-40B4-BE49-F238E27FC236}">
                 <a16:creationId xmlns:a16="http://schemas.microsoft.com/office/drawing/2014/main" id="{654B5223-4D6E-4CD5-9E77-05D138B51148}"/>
               </a:ext>
             </a:extLst>
           </p:cNvPr>
           <p:cNvSpPr>
-            <a:spLocks noGrp="1"/>
-          </p:cNvSpPr>
-          <p:nvPr/>
-        </p:nvSpPr>
-        <p:spPr>
-          <a:xfrm>
+            <a:spLocks xmlns:a="http://schemas.openxmlformats.org/drawingml/2006/main" noGrp="1"/>
+          </p:cNvSpPr>
+          <p:nvPr/>
+        </p:nvSpPr>
+        <p:spPr>
+          <a:xfrm xmlns:a="http://schemas.openxmlformats.org/drawingml/2006/main">
             <a:off x="2962275" y="2752725"/>
             <a:ext cx="2000250" cy="323850"/>
           </a:xfrm>
-          <a:prstGeom prst="rect">
-            <a:avLst/>
-          </a:prstGeom>
-          <a:noFill/>
-          <a:ln w="0">
+          <a:prstGeom xmlns:a="http://schemas.openxmlformats.org/drawingml/2006/main" prst="rect">
+            <a:avLst/>
+          </a:prstGeom>
+          <a:noFill xmlns:a="http://schemas.openxmlformats.org/drawingml/2006/main"/>
+          <a:ln xmlns:a="http://schemas.openxmlformats.org/drawingml/2006/main" w="0">
             <a:noFill/>
             <a:prstDash val="solid"/>
           </a:ln>
         </p:spPr>
         <p:txBody>
-          <a:bodyPr lIns="0" tIns="0" rIns="0" bIns="0" anchor="ctr">
+          <a:bodyPr xmlns:a="http://schemas.openxmlformats.org/drawingml/2006/main" lIns="0" tIns="0" rIns="0" bIns="0" anchor="ctr">
             <a:normAutofit fontScale="93670"/>
           </a:bodyPr>
-          <a:lstStyle/>
-          <a:p>
+          <a:lstStyle xmlns:a="http://schemas.openxmlformats.org/drawingml/2006/main"/>
+          <a:p xmlns:a="http://schemas.openxmlformats.org/drawingml/2006/main">
             <a:pPr algn="ctr">
+              <a:buNone/>
               <a:defRPr sz="1650" b="1">
                 <a:solidFill>
                   <a:srgbClr val="111111"/>
@@ -1756,38 +2164,39 @@
       <p:sp>
         <p:nvSpPr>
           <p:cNvPr id="24" name="secondary-keywords-count">
-            <a:extLst>
+            <a:extLst xmlns:a="http://schemas.openxmlformats.org/drawingml/2006/main">
               <a:ext uri="{FF2B5EF4-FFF2-40B4-BE49-F238E27FC236}">
                 <a16:creationId xmlns:a16="http://schemas.microsoft.com/office/drawing/2014/main" id="{735C6B87-2BCF-4932-91B7-EF07EB48A10E}"/>
               </a:ext>
             </a:extLst>
           </p:cNvPr>
           <p:cNvSpPr>
-            <a:spLocks noGrp="1"/>
-          </p:cNvSpPr>
-          <p:nvPr/>
-        </p:nvSpPr>
-        <p:spPr>
-          <a:xfrm>
+            <a:spLocks xmlns:a="http://schemas.openxmlformats.org/drawingml/2006/main" noGrp="1"/>
+          </p:cNvSpPr>
+          <p:nvPr/>
+        </p:nvSpPr>
+        <p:spPr>
+          <a:xfrm xmlns:a="http://schemas.openxmlformats.org/drawingml/2006/main">
             <a:off x="2962275" y="3086100"/>
             <a:ext cx="2000250" cy="266700"/>
           </a:xfrm>
-          <a:prstGeom prst="rect">
-            <a:avLst/>
-          </a:prstGeom>
-          <a:noFill/>
-          <a:ln w="0">
+          <a:prstGeom xmlns:a="http://schemas.openxmlformats.org/drawingml/2006/main" prst="rect">
+            <a:avLst/>
+          </a:prstGeom>
+          <a:noFill xmlns:a="http://schemas.openxmlformats.org/drawingml/2006/main"/>
+          <a:ln xmlns:a="http://schemas.openxmlformats.org/drawingml/2006/main" w="0">
             <a:noFill/>
             <a:prstDash val="solid"/>
           </a:ln>
         </p:spPr>
         <p:txBody>
-          <a:bodyPr lIns="0" tIns="0" rIns="0" bIns="0" anchor="ctr">
-            <a:normAutofit/>
+          <a:bodyPr xmlns:a="http://schemas.openxmlformats.org/drawingml/2006/main" lIns="0" tIns="0" rIns="0" bIns="0" anchor="ctr">
+            <a:normAutofit fontScale="100000"/>
           </a:bodyPr>
-          <a:lstStyle/>
-          <a:p>
+          <a:lstStyle xmlns:a="http://schemas.openxmlformats.org/drawingml/2006/main"/>
+          <a:p xmlns:a="http://schemas.openxmlformats.org/drawingml/2006/main">
             <a:pPr algn="ctr">
+              <a:buNone/>
               <a:defRPr sz="1650">
                 <a:solidFill>
                   <a:srgbClr val="333333"/>
@@ -1806,7 +2215,7 @@
                 <a:ea typeface="Arial"/>
                 <a:cs typeface="Arial"/>
               </a:rPr>
-              <a:t>(1,624 keywords)</a:t>
+              <a:t>(1,472 keywords)</a:t>
             </a:r>
           </a:p>
         </p:txBody>
@@ -1814,38 +2223,39 @@
       <p:sp>
         <p:nvSpPr>
           <p:cNvPr id="25" name="search-posts-title">
-            <a:extLst>
+            <a:extLst xmlns:a="http://schemas.openxmlformats.org/drawingml/2006/main">
               <a:ext uri="{FF2B5EF4-FFF2-40B4-BE49-F238E27FC236}">
                 <a16:creationId xmlns:a16="http://schemas.microsoft.com/office/drawing/2014/main" id="{3D05D054-C7FA-4FEB-9AC1-AD9411CBB480}"/>
               </a:ext>
             </a:extLst>
           </p:cNvPr>
           <p:cNvSpPr>
-            <a:spLocks noGrp="1"/>
-          </p:cNvSpPr>
-          <p:nvPr/>
-        </p:nvSpPr>
-        <p:spPr>
-          <a:xfrm>
+            <a:spLocks xmlns:a="http://schemas.openxmlformats.org/drawingml/2006/main" noGrp="1"/>
+          </p:cNvSpPr>
+          <p:nvPr/>
+        </p:nvSpPr>
+        <p:spPr>
+          <a:xfrm xmlns:a="http://schemas.openxmlformats.org/drawingml/2006/main">
             <a:off x="990600" y="4067175"/>
             <a:ext cx="3848100" cy="323850"/>
           </a:xfrm>
-          <a:prstGeom prst="rect">
-            <a:avLst/>
-          </a:prstGeom>
-          <a:noFill/>
-          <a:ln w="0">
+          <a:prstGeom xmlns:a="http://schemas.openxmlformats.org/drawingml/2006/main" prst="rect">
+            <a:avLst/>
+          </a:prstGeom>
+          <a:noFill xmlns:a="http://schemas.openxmlformats.org/drawingml/2006/main"/>
+          <a:ln xmlns:a="http://schemas.openxmlformats.org/drawingml/2006/main" w="0">
             <a:noFill/>
             <a:prstDash val="solid"/>
           </a:ln>
         </p:spPr>
         <p:txBody>
-          <a:bodyPr lIns="0" tIns="0" rIns="0" bIns="0" anchor="ctr">
+          <a:bodyPr xmlns:a="http://schemas.openxmlformats.org/drawingml/2006/main" lIns="0" tIns="0" rIns="0" bIns="0" anchor="ctr">
             <a:normAutofit/>
           </a:bodyPr>
-          <a:lstStyle/>
-          <a:p>
+          <a:lstStyle xmlns:a="http://schemas.openxmlformats.org/drawingml/2006/main"/>
+          <a:p xmlns:a="http://schemas.openxmlformats.org/drawingml/2006/main">
             <a:pPr algn="ctr">
+              <a:buNone/>
               <a:defRPr sz="2100" b="1">
                 <a:solidFill>
                   <a:srgbClr val="111111"/>
@@ -1872,38 +2282,39 @@
       <p:sp>
         <p:nvSpPr>
           <p:cNvPr id="26" name="search-posts-detail">
-            <a:extLst>
+            <a:extLst xmlns:a="http://schemas.openxmlformats.org/drawingml/2006/main">
               <a:ext uri="{FF2B5EF4-FFF2-40B4-BE49-F238E27FC236}">
                 <a16:creationId xmlns:a16="http://schemas.microsoft.com/office/drawing/2014/main" id="{361A3AA9-4F61-45F4-A420-09158AAB1B5A}"/>
               </a:ext>
             </a:extLst>
           </p:cNvPr>
           <p:cNvSpPr>
-            <a:spLocks noGrp="1"/>
-          </p:cNvSpPr>
-          <p:nvPr/>
-        </p:nvSpPr>
-        <p:spPr>
-          <a:xfrm>
+            <a:spLocks xmlns:a="http://schemas.openxmlformats.org/drawingml/2006/main" noGrp="1"/>
+          </p:cNvSpPr>
+          <p:nvPr/>
+        </p:nvSpPr>
+        <p:spPr>
+          <a:xfrm xmlns:a="http://schemas.openxmlformats.org/drawingml/2006/main">
             <a:off x="990600" y="4400550"/>
             <a:ext cx="3848100" cy="266700"/>
           </a:xfrm>
-          <a:prstGeom prst="rect">
-            <a:avLst/>
-          </a:prstGeom>
-          <a:noFill/>
-          <a:ln w="0">
+          <a:prstGeom xmlns:a="http://schemas.openxmlformats.org/drawingml/2006/main" prst="rect">
+            <a:avLst/>
+          </a:prstGeom>
+          <a:noFill xmlns:a="http://schemas.openxmlformats.org/drawingml/2006/main"/>
+          <a:ln xmlns:a="http://schemas.openxmlformats.org/drawingml/2006/main" w="0">
             <a:noFill/>
             <a:prstDash val="solid"/>
           </a:ln>
         </p:spPr>
         <p:txBody>
-          <a:bodyPr lIns="0" tIns="0" rIns="0" bIns="0" anchor="ctr">
-            <a:normAutofit/>
+          <a:bodyPr xmlns:a="http://schemas.openxmlformats.org/drawingml/2006/main" lIns="0" tIns="0" rIns="0" bIns="0" anchor="ctr">
+            <a:normAutofit fontScale="100000"/>
           </a:bodyPr>
-          <a:lstStyle/>
-          <a:p>
+          <a:lstStyle xmlns:a="http://schemas.openxmlformats.org/drawingml/2006/main"/>
+          <a:p xmlns:a="http://schemas.openxmlformats.org/drawingml/2006/main">
             <a:pPr algn="ctr">
+              <a:buNone/>
               <a:defRPr sz="1650">
                 <a:solidFill>
                   <a:srgbClr val="333333"/>
@@ -1914,7 +2325,7 @@
               </a:defRPr>
             </a:pPr>
             <a:r>
-              <a:rPr lang="en-US" sz="1650" dirty="0">
+              <a:rPr sz="1650">
                 <a:solidFill>
                   <a:srgbClr val="333333"/>
                 </a:solidFill>
@@ -1922,7 +2333,7 @@
                 <a:ea typeface="Arial"/>
                 <a:cs typeface="Arial"/>
               </a:rPr>
-              <a:t> (4,300+ posts)</a:t>
+              <a:t> (4,381 posts)</a:t>
             </a:r>
           </a:p>
         </p:txBody>
@@ -1930,38 +2341,39 @@
       <p:sp>
         <p:nvSpPr>
           <p:cNvPr id="27" name="definition-subject-areas-label">
-            <a:extLst>
+            <a:extLst xmlns:a="http://schemas.openxmlformats.org/drawingml/2006/main">
               <a:ext uri="{FF2B5EF4-FFF2-40B4-BE49-F238E27FC236}">
                 <a16:creationId xmlns:a16="http://schemas.microsoft.com/office/drawing/2014/main" id="{0AF6DD74-1B74-4EF2-8C3D-A7CFF9489366}"/>
               </a:ext>
             </a:extLst>
           </p:cNvPr>
           <p:cNvSpPr>
-            <a:spLocks noGrp="1"/>
-          </p:cNvSpPr>
-          <p:nvPr/>
-        </p:nvSpPr>
-        <p:spPr>
-          <a:xfrm>
+            <a:spLocks xmlns:a="http://schemas.openxmlformats.org/drawingml/2006/main" noGrp="1"/>
+          </p:cNvSpPr>
+          <p:nvPr/>
+        </p:nvSpPr>
+        <p:spPr>
+          <a:xfrm xmlns:a="http://schemas.openxmlformats.org/drawingml/2006/main">
             <a:off x="571500" y="5391150"/>
             <a:ext cx="1066800" cy="323850"/>
           </a:xfrm>
-          <a:prstGeom prst="rect">
-            <a:avLst/>
-          </a:prstGeom>
-          <a:noFill/>
-          <a:ln w="0">
+          <a:prstGeom xmlns:a="http://schemas.openxmlformats.org/drawingml/2006/main" prst="rect">
+            <a:avLst/>
+          </a:prstGeom>
+          <a:noFill xmlns:a="http://schemas.openxmlformats.org/drawingml/2006/main"/>
+          <a:ln xmlns:a="http://schemas.openxmlformats.org/drawingml/2006/main" w="0">
             <a:noFill/>
             <a:prstDash val="solid"/>
           </a:ln>
         </p:spPr>
         <p:txBody>
-          <a:bodyPr lIns="0" tIns="0" rIns="0" bIns="0" anchor="t">
+          <a:bodyPr xmlns:a="http://schemas.openxmlformats.org/drawingml/2006/main" lIns="0" tIns="0" rIns="0" bIns="0" anchor="t">
             <a:normAutofit/>
           </a:bodyPr>
-          <a:lstStyle/>
-          <a:p>
+          <a:lstStyle xmlns:a="http://schemas.openxmlformats.org/drawingml/2006/main"/>
+          <a:p xmlns:a="http://schemas.openxmlformats.org/drawingml/2006/main">
             <a:pPr algn="l">
+              <a:buNone/>
               <a:defRPr sz="1200" b="1">
                 <a:solidFill>
                   <a:srgbClr val="111111"/>
@@ -1972,7 +2384,7 @@
               </a:defRPr>
             </a:pPr>
             <a:r>
-              <a:rPr sz="1200" b="1" dirty="0">
+              <a:rPr sz="1200" b="1">
                 <a:solidFill>
                   <a:srgbClr val="111111"/>
                 </a:solidFill>
@@ -1988,38 +2400,39 @@
       <p:sp>
         <p:nvSpPr>
           <p:cNvPr id="28" name="definition-subject-areas-detail">
-            <a:extLst>
+            <a:extLst xmlns:a="http://schemas.openxmlformats.org/drawingml/2006/main">
               <a:ext uri="{FF2B5EF4-FFF2-40B4-BE49-F238E27FC236}">
                 <a16:creationId xmlns:a16="http://schemas.microsoft.com/office/drawing/2014/main" id="{00DC7FD3-C452-474A-BE9E-C3FB723F3CB7}"/>
               </a:ext>
             </a:extLst>
           </p:cNvPr>
           <p:cNvSpPr>
-            <a:spLocks noGrp="1"/>
-          </p:cNvSpPr>
-          <p:nvPr/>
-        </p:nvSpPr>
-        <p:spPr>
-          <a:xfrm>
+            <a:spLocks xmlns:a="http://schemas.openxmlformats.org/drawingml/2006/main" noGrp="1"/>
+          </p:cNvSpPr>
+          <p:nvPr/>
+        </p:nvSpPr>
+        <p:spPr>
+          <a:xfrm xmlns:a="http://schemas.openxmlformats.org/drawingml/2006/main">
             <a:off x="1714500" y="5391150"/>
             <a:ext cx="3619500" cy="361950"/>
           </a:xfrm>
-          <a:prstGeom prst="rect">
-            <a:avLst/>
-          </a:prstGeom>
-          <a:noFill/>
-          <a:ln w="0">
+          <a:prstGeom xmlns:a="http://schemas.openxmlformats.org/drawingml/2006/main" prst="rect">
+            <a:avLst/>
+          </a:prstGeom>
+          <a:noFill xmlns:a="http://schemas.openxmlformats.org/drawingml/2006/main"/>
+          <a:ln xmlns:a="http://schemas.openxmlformats.org/drawingml/2006/main" w="0">
             <a:noFill/>
             <a:prstDash val="solid"/>
           </a:ln>
         </p:spPr>
         <p:txBody>
-          <a:bodyPr lIns="0" tIns="0" rIns="0" bIns="0" anchor="t">
+          <a:bodyPr xmlns:a="http://schemas.openxmlformats.org/drawingml/2006/main" lIns="0" tIns="0" rIns="0" bIns="0" anchor="t">
             <a:normAutofit/>
           </a:bodyPr>
-          <a:lstStyle/>
-          <a:p>
+          <a:lstStyle xmlns:a="http://schemas.openxmlformats.org/drawingml/2006/main"/>
+          <a:p xmlns:a="http://schemas.openxmlformats.org/drawingml/2006/main">
             <a:pPr algn="l">
+              <a:buNone/>
               <a:defRPr sz="1200">
                 <a:solidFill>
                   <a:srgbClr val="333333"/>
@@ -2030,7 +2443,7 @@
               </a:defRPr>
             </a:pPr>
             <a:r>
-              <a:rPr sz="1200" dirty="0">
+              <a:rPr sz="1200">
                 <a:solidFill>
                   <a:srgbClr val="333333"/>
                 </a:solidFill>
@@ -2046,38 +2459,39 @@
       <p:sp>
         <p:nvSpPr>
           <p:cNvPr id="29" name="definition-categories-label">
-            <a:extLst>
+            <a:extLst xmlns:a="http://schemas.openxmlformats.org/drawingml/2006/main">
               <a:ext uri="{FF2B5EF4-FFF2-40B4-BE49-F238E27FC236}">
                 <a16:creationId xmlns:a16="http://schemas.microsoft.com/office/drawing/2014/main" id="{7C33C4BB-D71B-43D7-947B-435CBCD7108F}"/>
               </a:ext>
             </a:extLst>
           </p:cNvPr>
           <p:cNvSpPr>
-            <a:spLocks noGrp="1"/>
-          </p:cNvSpPr>
-          <p:nvPr/>
-        </p:nvSpPr>
-        <p:spPr>
-          <a:xfrm>
+            <a:spLocks xmlns:a="http://schemas.openxmlformats.org/drawingml/2006/main" noGrp="1"/>
+          </p:cNvSpPr>
+          <p:nvPr/>
+        </p:nvSpPr>
+        <p:spPr>
+          <a:xfrm xmlns:a="http://schemas.openxmlformats.org/drawingml/2006/main">
             <a:off x="571500" y="5791200"/>
             <a:ext cx="838200" cy="323850"/>
           </a:xfrm>
-          <a:prstGeom prst="rect">
-            <a:avLst/>
-          </a:prstGeom>
-          <a:noFill/>
-          <a:ln w="0">
+          <a:prstGeom xmlns:a="http://schemas.openxmlformats.org/drawingml/2006/main" prst="rect">
+            <a:avLst/>
+          </a:prstGeom>
+          <a:noFill xmlns:a="http://schemas.openxmlformats.org/drawingml/2006/main"/>
+          <a:ln xmlns:a="http://schemas.openxmlformats.org/drawingml/2006/main" w="0">
             <a:noFill/>
             <a:prstDash val="solid"/>
           </a:ln>
         </p:spPr>
         <p:txBody>
-          <a:bodyPr lIns="0" tIns="0" rIns="0" bIns="0" anchor="t">
+          <a:bodyPr xmlns:a="http://schemas.openxmlformats.org/drawingml/2006/main" lIns="0" tIns="0" rIns="0" bIns="0" anchor="t">
             <a:normAutofit/>
           </a:bodyPr>
-          <a:lstStyle/>
-          <a:p>
+          <a:lstStyle xmlns:a="http://schemas.openxmlformats.org/drawingml/2006/main"/>
+          <a:p xmlns:a="http://schemas.openxmlformats.org/drawingml/2006/main">
             <a:pPr algn="l">
+              <a:buNone/>
               <a:defRPr sz="1200" b="1">
                 <a:solidFill>
                   <a:srgbClr val="111111"/>
@@ -2104,38 +2518,39 @@
       <p:sp>
         <p:nvSpPr>
           <p:cNvPr id="30" name="definition-categories-detail">
-            <a:extLst>
+            <a:extLst xmlns:a="http://schemas.openxmlformats.org/drawingml/2006/main">
               <a:ext uri="{FF2B5EF4-FFF2-40B4-BE49-F238E27FC236}">
                 <a16:creationId xmlns:a16="http://schemas.microsoft.com/office/drawing/2014/main" id="{C58CC294-E5EC-4912-8A75-7FD3DB842D51}"/>
               </a:ext>
             </a:extLst>
           </p:cNvPr>
           <p:cNvSpPr>
-            <a:spLocks noGrp="1"/>
-          </p:cNvSpPr>
-          <p:nvPr/>
-        </p:nvSpPr>
-        <p:spPr>
-          <a:xfrm>
+            <a:spLocks xmlns:a="http://schemas.openxmlformats.org/drawingml/2006/main" noGrp="1"/>
+          </p:cNvSpPr>
+          <p:nvPr/>
+        </p:nvSpPr>
+        <p:spPr>
+          <a:xfrm xmlns:a="http://schemas.openxmlformats.org/drawingml/2006/main">
             <a:off x="1485900" y="5791200"/>
             <a:ext cx="3848100" cy="361950"/>
           </a:xfrm>
-          <a:prstGeom prst="rect">
-            <a:avLst/>
-          </a:prstGeom>
-          <a:noFill/>
-          <a:ln w="0">
+          <a:prstGeom xmlns:a="http://schemas.openxmlformats.org/drawingml/2006/main" prst="rect">
+            <a:avLst/>
+          </a:prstGeom>
+          <a:noFill xmlns:a="http://schemas.openxmlformats.org/drawingml/2006/main"/>
+          <a:ln xmlns:a="http://schemas.openxmlformats.org/drawingml/2006/main" w="0">
             <a:noFill/>
             <a:prstDash val="solid"/>
           </a:ln>
         </p:spPr>
         <p:txBody>
-          <a:bodyPr lIns="0" tIns="0" rIns="0" bIns="0" anchor="t">
+          <a:bodyPr xmlns:a="http://schemas.openxmlformats.org/drawingml/2006/main" lIns="0" tIns="0" rIns="0" bIns="0" anchor="t">
             <a:normAutofit/>
           </a:bodyPr>
-          <a:lstStyle/>
-          <a:p>
+          <a:lstStyle xmlns:a="http://schemas.openxmlformats.org/drawingml/2006/main"/>
+          <a:p xmlns:a="http://schemas.openxmlformats.org/drawingml/2006/main">
             <a:pPr algn="l">
+              <a:buNone/>
               <a:defRPr sz="1200">
                 <a:solidFill>
                   <a:srgbClr val="333333"/>
@@ -2146,7 +2561,7 @@
               </a:defRPr>
             </a:pPr>
             <a:r>
-              <a:rPr sz="1200" dirty="0">
+              <a:rPr sz="1200">
                 <a:solidFill>
                   <a:srgbClr val="333333"/>
                 </a:solidFill>
@@ -2162,38 +2577,39 @@
       <p:sp>
         <p:nvSpPr>
           <p:cNvPr id="31" name="definition-topics-label">
-            <a:extLst>
+            <a:extLst xmlns:a="http://schemas.openxmlformats.org/drawingml/2006/main">
               <a:ext uri="{FF2B5EF4-FFF2-40B4-BE49-F238E27FC236}">
                 <a16:creationId xmlns:a16="http://schemas.microsoft.com/office/drawing/2014/main" id="{ACF0B6A8-DA26-4B78-86D5-1283579A9471}"/>
               </a:ext>
             </a:extLst>
           </p:cNvPr>
           <p:cNvSpPr>
-            <a:spLocks noGrp="1"/>
-          </p:cNvSpPr>
-          <p:nvPr/>
-        </p:nvSpPr>
-        <p:spPr>
-          <a:xfrm>
+            <a:spLocks xmlns:a="http://schemas.openxmlformats.org/drawingml/2006/main" noGrp="1"/>
+          </p:cNvSpPr>
+          <p:nvPr/>
+        </p:nvSpPr>
+        <p:spPr>
+          <a:xfrm xmlns:a="http://schemas.openxmlformats.org/drawingml/2006/main">
             <a:off x="571500" y="6191250"/>
             <a:ext cx="590550" cy="323850"/>
           </a:xfrm>
-          <a:prstGeom prst="rect">
-            <a:avLst/>
-          </a:prstGeom>
-          <a:noFill/>
-          <a:ln w="0">
+          <a:prstGeom xmlns:a="http://schemas.openxmlformats.org/drawingml/2006/main" prst="rect">
+            <a:avLst/>
+          </a:prstGeom>
+          <a:noFill xmlns:a="http://schemas.openxmlformats.org/drawingml/2006/main"/>
+          <a:ln xmlns:a="http://schemas.openxmlformats.org/drawingml/2006/main" w="0">
             <a:noFill/>
             <a:prstDash val="solid"/>
           </a:ln>
         </p:spPr>
         <p:txBody>
-          <a:bodyPr lIns="0" tIns="0" rIns="0" bIns="0" anchor="t">
+          <a:bodyPr xmlns:a="http://schemas.openxmlformats.org/drawingml/2006/main" lIns="0" tIns="0" rIns="0" bIns="0" anchor="t">
             <a:normAutofit/>
           </a:bodyPr>
-          <a:lstStyle/>
-          <a:p>
+          <a:lstStyle xmlns:a="http://schemas.openxmlformats.org/drawingml/2006/main"/>
+          <a:p xmlns:a="http://schemas.openxmlformats.org/drawingml/2006/main">
             <a:pPr algn="l">
+              <a:buNone/>
               <a:defRPr sz="1200" b="1">
                 <a:solidFill>
                   <a:srgbClr val="111111"/>
@@ -2204,7 +2620,7 @@
               </a:defRPr>
             </a:pPr>
             <a:r>
-              <a:rPr sz="1200" b="1" dirty="0">
+              <a:rPr sz="1200" b="1">
                 <a:solidFill>
                   <a:srgbClr val="111111"/>
                 </a:solidFill>
@@ -2220,38 +2636,39 @@
       <p:sp>
         <p:nvSpPr>
           <p:cNvPr id="32" name="definition-topics-detail">
-            <a:extLst>
+            <a:extLst xmlns:a="http://schemas.openxmlformats.org/drawingml/2006/main">
               <a:ext uri="{FF2B5EF4-FFF2-40B4-BE49-F238E27FC236}">
                 <a16:creationId xmlns:a16="http://schemas.microsoft.com/office/drawing/2014/main" id="{2C60B3E1-AC15-4F99-AC36-0A4E8DE37BA9}"/>
               </a:ext>
             </a:extLst>
           </p:cNvPr>
           <p:cNvSpPr>
-            <a:spLocks noGrp="1"/>
-          </p:cNvSpPr>
-          <p:nvPr/>
-        </p:nvSpPr>
-        <p:spPr>
-          <a:xfrm>
+            <a:spLocks xmlns:a="http://schemas.openxmlformats.org/drawingml/2006/main" noGrp="1"/>
+          </p:cNvSpPr>
+          <p:nvPr/>
+        </p:nvSpPr>
+        <p:spPr>
+          <a:xfrm xmlns:a="http://schemas.openxmlformats.org/drawingml/2006/main">
             <a:off x="1162050" y="6191250"/>
             <a:ext cx="4095750" cy="361950"/>
           </a:xfrm>
-          <a:prstGeom prst="rect">
-            <a:avLst/>
-          </a:prstGeom>
-          <a:noFill/>
-          <a:ln w="0">
+          <a:prstGeom xmlns:a="http://schemas.openxmlformats.org/drawingml/2006/main" prst="rect">
+            <a:avLst/>
+          </a:prstGeom>
+          <a:noFill xmlns:a="http://schemas.openxmlformats.org/drawingml/2006/main"/>
+          <a:ln xmlns:a="http://schemas.openxmlformats.org/drawingml/2006/main" w="0">
             <a:noFill/>
             <a:prstDash val="solid"/>
           </a:ln>
         </p:spPr>
         <p:txBody>
-          <a:bodyPr lIns="0" tIns="0" rIns="0" bIns="0" anchor="t">
+          <a:bodyPr xmlns:a="http://schemas.openxmlformats.org/drawingml/2006/main" lIns="0" tIns="0" rIns="0" bIns="0" anchor="t">
             <a:normAutofit/>
           </a:bodyPr>
-          <a:lstStyle/>
-          <a:p>
+          <a:lstStyle xmlns:a="http://schemas.openxmlformats.org/drawingml/2006/main"/>
+          <a:p xmlns:a="http://schemas.openxmlformats.org/drawingml/2006/main">
             <a:pPr algn="l">
+              <a:buNone/>
               <a:defRPr sz="1200">
                 <a:solidFill>
                   <a:srgbClr val="333333"/>
@@ -2262,7 +2679,7 @@
               </a:defRPr>
             </a:pPr>
             <a:r>
-              <a:rPr sz="1200" dirty="0">
+              <a:rPr sz="1200">
                 <a:solidFill>
                   <a:srgbClr val="333333"/>
                 </a:solidFill>
@@ -2278,38 +2695,39 @@
       <p:sp>
         <p:nvSpPr>
           <p:cNvPr id="33" name="definition-secondary-keywords-label">
-            <a:extLst>
+            <a:extLst xmlns:a="http://schemas.openxmlformats.org/drawingml/2006/main">
               <a:ext uri="{FF2B5EF4-FFF2-40B4-BE49-F238E27FC236}">
                 <a16:creationId xmlns:a16="http://schemas.microsoft.com/office/drawing/2014/main" id="{E95C92F6-0FC5-44E1-8720-AF667BD0A830}"/>
               </a:ext>
             </a:extLst>
           </p:cNvPr>
           <p:cNvSpPr>
-            <a:spLocks noGrp="1"/>
-          </p:cNvSpPr>
-          <p:nvPr/>
-        </p:nvSpPr>
-        <p:spPr>
-          <a:xfrm>
+            <a:spLocks xmlns:a="http://schemas.openxmlformats.org/drawingml/2006/main" noGrp="1"/>
+          </p:cNvSpPr>
+          <p:nvPr/>
+        </p:nvSpPr>
+        <p:spPr>
+          <a:xfrm xmlns:a="http://schemas.openxmlformats.org/drawingml/2006/main">
             <a:off x="571499" y="6591300"/>
             <a:ext cx="1675589" cy="323850"/>
           </a:xfrm>
-          <a:prstGeom prst="rect">
-            <a:avLst/>
-          </a:prstGeom>
-          <a:noFill/>
-          <a:ln w="0">
+          <a:prstGeom xmlns:a="http://schemas.openxmlformats.org/drawingml/2006/main" prst="rect">
+            <a:avLst/>
+          </a:prstGeom>
+          <a:noFill xmlns:a="http://schemas.openxmlformats.org/drawingml/2006/main"/>
+          <a:ln xmlns:a="http://schemas.openxmlformats.org/drawingml/2006/main" w="0">
             <a:noFill/>
             <a:prstDash val="solid"/>
           </a:ln>
         </p:spPr>
         <p:txBody>
-          <a:bodyPr lIns="0" tIns="0" rIns="0" bIns="0" anchor="t">
+          <a:bodyPr xmlns:a="http://schemas.openxmlformats.org/drawingml/2006/main" lIns="0" tIns="0" rIns="0" bIns="0" anchor="t">
             <a:noAutofit/>
           </a:bodyPr>
-          <a:lstStyle/>
-          <a:p>
+          <a:lstStyle xmlns:a="http://schemas.openxmlformats.org/drawingml/2006/main"/>
+          <a:p xmlns:a="http://schemas.openxmlformats.org/drawingml/2006/main">
             <a:pPr algn="l">
+              <a:buNone/>
               <a:defRPr sz="1200" b="1">
                 <a:solidFill>
                   <a:srgbClr val="111111"/>
@@ -2320,7 +2738,7 @@
               </a:defRPr>
             </a:pPr>
             <a:r>
-              <a:rPr sz="1200" b="1" dirty="0">
+              <a:rPr sz="1200" b="1">
                 <a:solidFill>
                   <a:srgbClr val="111111"/>
                 </a:solidFill>
@@ -2336,38 +2754,39 @@
       <p:sp>
         <p:nvSpPr>
           <p:cNvPr id="34" name="definition-secondary-keywords-detail">
-            <a:extLst>
+            <a:extLst xmlns:a="http://schemas.openxmlformats.org/drawingml/2006/main">
               <a:ext uri="{FF2B5EF4-FFF2-40B4-BE49-F238E27FC236}">
                 <a16:creationId xmlns:a16="http://schemas.microsoft.com/office/drawing/2014/main" id="{84F6749A-FCE3-4AC9-B9C3-E1677A518C9F}"/>
               </a:ext>
             </a:extLst>
           </p:cNvPr>
           <p:cNvSpPr>
-            <a:spLocks noGrp="1"/>
-          </p:cNvSpPr>
-          <p:nvPr/>
-        </p:nvSpPr>
-        <p:spPr>
-          <a:xfrm>
+            <a:spLocks xmlns:a="http://schemas.openxmlformats.org/drawingml/2006/main" noGrp="1"/>
+          </p:cNvSpPr>
+          <p:nvPr/>
+        </p:nvSpPr>
+        <p:spPr>
+          <a:xfrm xmlns:a="http://schemas.openxmlformats.org/drawingml/2006/main">
             <a:off x="2247088" y="6572250"/>
             <a:ext cx="3181350" cy="361950"/>
           </a:xfrm>
-          <a:prstGeom prst="rect">
-            <a:avLst/>
-          </a:prstGeom>
-          <a:noFill/>
-          <a:ln w="0">
+          <a:prstGeom xmlns:a="http://schemas.openxmlformats.org/drawingml/2006/main" prst="rect">
+            <a:avLst/>
+          </a:prstGeom>
+          <a:noFill xmlns:a="http://schemas.openxmlformats.org/drawingml/2006/main"/>
+          <a:ln xmlns:a="http://schemas.openxmlformats.org/drawingml/2006/main" w="0">
             <a:noFill/>
             <a:prstDash val="solid"/>
           </a:ln>
         </p:spPr>
         <p:txBody>
-          <a:bodyPr lIns="0" tIns="0" rIns="0" bIns="0" anchor="t">
+          <a:bodyPr xmlns:a="http://schemas.openxmlformats.org/drawingml/2006/main" lIns="0" tIns="0" rIns="0" bIns="0" anchor="t">
             <a:normAutofit/>
           </a:bodyPr>
-          <a:lstStyle/>
-          <a:p>
+          <a:lstStyle xmlns:a="http://schemas.openxmlformats.org/drawingml/2006/main"/>
+          <a:p xmlns:a="http://schemas.openxmlformats.org/drawingml/2006/main">
             <a:pPr algn="l">
+              <a:buNone/>
               <a:defRPr sz="1200">
                 <a:solidFill>
                   <a:srgbClr val="333333"/>
@@ -2378,7 +2797,7 @@
               </a:defRPr>
             </a:pPr>
             <a:r>
-              <a:rPr sz="1200" dirty="0">
+              <a:rPr sz="1200">
                 <a:solidFill>
                   <a:srgbClr val="333333"/>
                 </a:solidFill>
@@ -2394,38 +2813,179 @@
       <p:sp>
         <p:nvSpPr>
           <p:cNvPr id="35" name="subject-areas-title">
-            <a:extLst>
+            <a:extLst xmlns:a="http://schemas.openxmlformats.org/drawingml/2006/main">
               <a:ext uri="{FF2B5EF4-FFF2-40B4-BE49-F238E27FC236}">
                 <a16:creationId xmlns:a16="http://schemas.microsoft.com/office/drawing/2014/main" id="{BF3AE88F-90B2-4B7C-8ABB-29602A0F1BC5}"/>
               </a:ext>
             </a:extLst>
           </p:cNvPr>
           <p:cNvSpPr>
-            <a:spLocks noGrp="1"/>
-          </p:cNvSpPr>
-          <p:nvPr/>
-        </p:nvSpPr>
-        <p:spPr>
-          <a:xfrm>
-            <a:off x="6591300" y="1838325"/>
+            <a:spLocks xmlns:a="http://schemas.openxmlformats.org/drawingml/2006/main" noGrp="1"/>
+          </p:cNvSpPr>
+          <p:nvPr/>
+        </p:nvSpPr>
+        <p:spPr>
+          <a:xfrm xmlns:a="http://schemas.openxmlformats.org/drawingml/2006/main">
+            <a:off x="6515100" y="1838325"/>
+            <a:ext cx="1905000" cy="323850"/>
+          </a:xfrm>
+          <a:prstGeom xmlns:a="http://schemas.openxmlformats.org/drawingml/2006/main" prst="rect">
+            <a:avLst/>
+          </a:prstGeom>
+          <a:noFill xmlns:a="http://schemas.openxmlformats.org/drawingml/2006/main"/>
+          <a:ln xmlns:a="http://schemas.openxmlformats.org/drawingml/2006/main" w="0">
+            <a:noFill/>
+            <a:prstDash val="solid"/>
+          </a:ln>
+        </p:spPr>
+        <p:txBody>
+          <a:bodyPr xmlns:a="http://schemas.openxmlformats.org/drawingml/2006/main" lIns="0" tIns="0" rIns="0" bIns="0" anchor="ctr">
+            <a:normAutofit fontScale="100000"/>
+          </a:bodyPr>
+          <a:lstStyle xmlns:a="http://schemas.openxmlformats.org/drawingml/2006/main"/>
+          <a:p xmlns:a="http://schemas.openxmlformats.org/drawingml/2006/main">
+            <a:pPr algn="ctr">
+              <a:buNone/>
+              <a:defRPr sz="1800" b="1">
+                <a:solidFill>
+                  <a:srgbClr val="111111"/>
+                </a:solidFill>
+                <a:latin typeface="Arial"/>
+                <a:ea typeface="Arial"/>
+                <a:cs typeface="Arial"/>
+              </a:defRPr>
+            </a:pPr>
+            <a:r>
+              <a:rPr sz="1800" b="1">
+                <a:solidFill>
+                  <a:srgbClr val="111111"/>
+                </a:solidFill>
+                <a:latin typeface="Arial"/>
+                <a:ea typeface="Arial"/>
+                <a:cs typeface="Arial"/>
+              </a:rPr>
+              <a:t>Browse Topics 1</a:t>
+            </a:r>
+          </a:p>
+        </p:txBody>
+      </p:sp>
+      <p:sp>
+        <p:nvSpPr>
+          <p:cNvPr id="36" name="subject-areas-detail">
+            <a:extLst xmlns:a="http://schemas.openxmlformats.org/drawingml/2006/main">
+              <a:ext uri="{FF2B5EF4-FFF2-40B4-BE49-F238E27FC236}">
+                <a16:creationId xmlns:a16="http://schemas.microsoft.com/office/drawing/2014/main" id="{8F0D9F53-2EB0-41D7-AE2D-A0194EE09765}"/>
+              </a:ext>
+            </a:extLst>
+          </p:cNvPr>
+          <p:cNvSpPr>
+            <a:spLocks xmlns:a="http://schemas.openxmlformats.org/drawingml/2006/main" noGrp="1"/>
+          </p:cNvSpPr>
+          <p:nvPr/>
+        </p:nvSpPr>
+        <p:spPr>
+          <a:xfrm xmlns:a="http://schemas.openxmlformats.org/drawingml/2006/main">
+            <a:off x="6515100" y="2171700"/>
+            <a:ext cx="1905000" cy="266700"/>
+          </a:xfrm>
+          <a:prstGeom xmlns:a="http://schemas.openxmlformats.org/drawingml/2006/main" prst="rect">
+            <a:avLst/>
+          </a:prstGeom>
+          <a:noFill xmlns:a="http://schemas.openxmlformats.org/drawingml/2006/main"/>
+          <a:ln xmlns:a="http://schemas.openxmlformats.org/drawingml/2006/main" w="0">
+            <a:noFill/>
+            <a:prstDash val="solid"/>
+          </a:ln>
+        </p:spPr>
+        <p:txBody>
+          <a:bodyPr xmlns:a="http://schemas.openxmlformats.org/drawingml/2006/main" lIns="0" tIns="0" rIns="0" bIns="0" anchor="ctr">
+            <a:normAutofit fontScale="100000"/>
+          </a:bodyPr>
+          <a:lstStyle xmlns:a="http://schemas.openxmlformats.org/drawingml/2006/main"/>
+          <a:p xmlns:a="http://schemas.openxmlformats.org/drawingml/2006/main">
+            <a:pPr algn="ctr">
+              <a:buNone/>
+              <a:defRPr sz="1350">
+                <a:solidFill>
+                  <a:srgbClr val="333333"/>
+                </a:solidFill>
+                <a:latin typeface="Arial"/>
+                <a:ea typeface="Arial"/>
+                <a:cs typeface="Arial"/>
+              </a:defRPr>
+            </a:pPr>
+            <a:r>
+              <a:rPr sz="1350">
+                <a:solidFill>
+                  <a:srgbClr val="333333"/>
+                </a:solidFill>
+                <a:latin typeface="Arial"/>
+                <a:ea typeface="Arial"/>
+                <a:cs typeface="Arial"/>
+              </a:rPr>
+              <a:t> (11 </a:t>
+            </a:r>
+            <a:r>
+              <a:rPr sz="1350">
+                <a:solidFill>
+                  <a:srgbClr val="333333"/>
+                </a:solidFill>
+                <a:latin typeface="Arial"/>
+                <a:ea typeface="Arial"/>
+                <a:cs typeface="Arial"/>
+              </a:rPr>
+              <a:t>subject </a:t>
+            </a:r>
+            <a:r>
+              <a:rPr sz="1350">
+                <a:solidFill>
+                  <a:srgbClr val="333333"/>
+                </a:solidFill>
+                <a:latin typeface="Arial"/>
+                <a:ea typeface="Arial"/>
+                <a:cs typeface="Arial"/>
+              </a:rPr>
+              <a:t>areas)</a:t>
+            </a:r>
+          </a:p>
+        </p:txBody>
+      </p:sp>
+      <p:sp>
+        <p:nvSpPr>
+          <p:cNvPr id="37" name="categories-title">
+            <a:extLst xmlns:a="http://schemas.openxmlformats.org/drawingml/2006/main">
+              <a:ext uri="{FF2B5EF4-FFF2-40B4-BE49-F238E27FC236}">
+                <a16:creationId xmlns:a16="http://schemas.microsoft.com/office/drawing/2014/main" id="{2E511F9A-A9D9-44A3-B149-672D2417033B}"/>
+              </a:ext>
+            </a:extLst>
+          </p:cNvPr>
+          <p:cNvSpPr>
+            <a:spLocks xmlns:a="http://schemas.openxmlformats.org/drawingml/2006/main" noGrp="1"/>
+          </p:cNvSpPr>
+          <p:nvPr/>
+        </p:nvSpPr>
+        <p:spPr>
+          <a:xfrm xmlns:a="http://schemas.openxmlformats.org/drawingml/2006/main">
+            <a:off x="6591300" y="3162300"/>
             <a:ext cx="3848100" cy="323850"/>
           </a:xfrm>
-          <a:prstGeom prst="rect">
-            <a:avLst/>
-          </a:prstGeom>
-          <a:noFill/>
-          <a:ln w="0">
+          <a:prstGeom xmlns:a="http://schemas.openxmlformats.org/drawingml/2006/main" prst="rect">
+            <a:avLst/>
+          </a:prstGeom>
+          <a:noFill xmlns:a="http://schemas.openxmlformats.org/drawingml/2006/main"/>
+          <a:ln xmlns:a="http://schemas.openxmlformats.org/drawingml/2006/main" w="0">
             <a:noFill/>
             <a:prstDash val="solid"/>
           </a:ln>
         </p:spPr>
         <p:txBody>
-          <a:bodyPr lIns="0" tIns="0" rIns="0" bIns="0" anchor="ctr">
+          <a:bodyPr xmlns:a="http://schemas.openxmlformats.org/drawingml/2006/main" lIns="0" tIns="0" rIns="0" bIns="0" anchor="ctr">
             <a:normAutofit/>
           </a:bodyPr>
-          <a:lstStyle/>
-          <a:p>
+          <a:lstStyle xmlns:a="http://schemas.openxmlformats.org/drawingml/2006/main"/>
+          <a:p xmlns:a="http://schemas.openxmlformats.org/drawingml/2006/main">
             <a:pPr algn="ctr">
+              <a:buNone/>
               <a:defRPr sz="2100" b="1">
                 <a:solidFill>
                   <a:srgbClr val="111111"/>
@@ -2444,46 +3004,47 @@
                 <a:ea typeface="Arial"/>
                 <a:cs typeface="Arial"/>
               </a:rPr>
-              <a:t>Subject Areas</a:t>
+              <a:t>Categories</a:t>
             </a:r>
           </a:p>
         </p:txBody>
       </p:sp>
       <p:sp>
         <p:nvSpPr>
-          <p:cNvPr id="36" name="subject-areas-detail">
-            <a:extLst>
-              <a:ext uri="{FF2B5EF4-FFF2-40B4-BE49-F238E27FC236}">
-                <a16:creationId xmlns:a16="http://schemas.microsoft.com/office/drawing/2014/main" id="{8F0D9F53-2EB0-41D7-AE2D-A0194EE09765}"/>
-              </a:ext>
-            </a:extLst>
-          </p:cNvPr>
-          <p:cNvSpPr>
-            <a:spLocks noGrp="1"/>
-          </p:cNvSpPr>
-          <p:nvPr/>
-        </p:nvSpPr>
-        <p:spPr>
-          <a:xfrm>
-            <a:off x="6591300" y="2171700"/>
+          <p:cNvPr id="38" name="categories-detail">
+            <a:extLst xmlns:a="http://schemas.openxmlformats.org/drawingml/2006/main">
+              <a:ext uri="{FF2B5EF4-FFF2-40B4-BE49-F238E27FC236}">
+                <a16:creationId xmlns:a16="http://schemas.microsoft.com/office/drawing/2014/main" id="{A4E0D989-2AE5-4778-932A-F899A51115E8}"/>
+              </a:ext>
+            </a:extLst>
+          </p:cNvPr>
+          <p:cNvSpPr>
+            <a:spLocks xmlns:a="http://schemas.openxmlformats.org/drawingml/2006/main" noGrp="1"/>
+          </p:cNvSpPr>
+          <p:nvPr/>
+        </p:nvSpPr>
+        <p:spPr>
+          <a:xfrm xmlns:a="http://schemas.openxmlformats.org/drawingml/2006/main">
+            <a:off x="6591300" y="3495675"/>
             <a:ext cx="3848100" cy="266700"/>
           </a:xfrm>
-          <a:prstGeom prst="rect">
-            <a:avLst/>
-          </a:prstGeom>
-          <a:noFill/>
-          <a:ln w="0">
+          <a:prstGeom xmlns:a="http://schemas.openxmlformats.org/drawingml/2006/main" prst="rect">
+            <a:avLst/>
+          </a:prstGeom>
+          <a:noFill xmlns:a="http://schemas.openxmlformats.org/drawingml/2006/main"/>
+          <a:ln xmlns:a="http://schemas.openxmlformats.org/drawingml/2006/main" w="0">
             <a:noFill/>
             <a:prstDash val="solid"/>
           </a:ln>
         </p:spPr>
         <p:txBody>
-          <a:bodyPr lIns="0" tIns="0" rIns="0" bIns="0" anchor="ctr">
+          <a:bodyPr xmlns:a="http://schemas.openxmlformats.org/drawingml/2006/main" lIns="0" tIns="0" rIns="0" bIns="0" anchor="ctr">
             <a:normAutofit/>
           </a:bodyPr>
-          <a:lstStyle/>
-          <a:p>
+          <a:lstStyle xmlns:a="http://schemas.openxmlformats.org/drawingml/2006/main"/>
+          <a:p xmlns:a="http://schemas.openxmlformats.org/drawingml/2006/main">
             <a:pPr algn="ctr">
+              <a:buNone/>
               <a:defRPr sz="1650">
                 <a:solidFill>
                   <a:srgbClr val="333333"/>
@@ -2494,7 +3055,7 @@
               </a:defRPr>
             </a:pPr>
             <a:r>
-              <a:rPr sz="1650" dirty="0">
+              <a:rPr sz="1650">
                 <a:solidFill>
                   <a:srgbClr val="333333"/>
                 </a:solidFill>
@@ -2502,68 +3063,47 @@
                 <a:ea typeface="Arial"/>
                 <a:cs typeface="Arial"/>
               </a:rPr>
-              <a:t> (11 </a:t>
-            </a:r>
-            <a:r>
-              <a:rPr lang="en-US" sz="1650" dirty="0">
-                <a:solidFill>
-                  <a:srgbClr val="333333"/>
-                </a:solidFill>
-                <a:latin typeface="Arial"/>
-                <a:ea typeface="Arial"/>
-                <a:cs typeface="Arial"/>
-              </a:rPr>
-              <a:t>subject </a:t>
-            </a:r>
-            <a:r>
-              <a:rPr sz="1650" dirty="0">
-                <a:solidFill>
-                  <a:srgbClr val="333333"/>
-                </a:solidFill>
-                <a:latin typeface="Arial"/>
-                <a:ea typeface="Arial"/>
-                <a:cs typeface="Arial"/>
-              </a:rPr>
-              <a:t>areas)</a:t>
+              <a:t> (41 categories)</a:t>
             </a:r>
           </a:p>
         </p:txBody>
       </p:sp>
       <p:sp>
         <p:nvSpPr>
-          <p:cNvPr id="37" name="categories-title">
-            <a:extLst>
-              <a:ext uri="{FF2B5EF4-FFF2-40B4-BE49-F238E27FC236}">
-                <a16:creationId xmlns:a16="http://schemas.microsoft.com/office/drawing/2014/main" id="{2E511F9A-A9D9-44A3-B149-672D2417033B}"/>
-              </a:ext>
-            </a:extLst>
-          </p:cNvPr>
-          <p:cNvSpPr>
-            <a:spLocks noGrp="1"/>
-          </p:cNvSpPr>
-          <p:nvPr/>
-        </p:nvSpPr>
-        <p:spPr>
-          <a:xfrm>
-            <a:off x="6591300" y="3162300"/>
+          <p:cNvPr id="39" name="topics-title">
+            <a:extLst xmlns:a="http://schemas.openxmlformats.org/drawingml/2006/main">
+              <a:ext uri="{FF2B5EF4-FFF2-40B4-BE49-F238E27FC236}">
+                <a16:creationId xmlns:a16="http://schemas.microsoft.com/office/drawing/2014/main" id="{EB2AD788-89E5-4039-A02C-BE16A2EC4B60}"/>
+              </a:ext>
+            </a:extLst>
+          </p:cNvPr>
+          <p:cNvSpPr>
+            <a:spLocks xmlns:a="http://schemas.openxmlformats.org/drawingml/2006/main" noGrp="1"/>
+          </p:cNvSpPr>
+          <p:nvPr/>
+        </p:nvSpPr>
+        <p:spPr>
+          <a:xfrm xmlns:a="http://schemas.openxmlformats.org/drawingml/2006/main">
+            <a:off x="6591300" y="4486275"/>
             <a:ext cx="3848100" cy="323850"/>
           </a:xfrm>
-          <a:prstGeom prst="rect">
-            <a:avLst/>
-          </a:prstGeom>
-          <a:noFill/>
-          <a:ln w="0">
+          <a:prstGeom xmlns:a="http://schemas.openxmlformats.org/drawingml/2006/main" prst="rect">
+            <a:avLst/>
+          </a:prstGeom>
+          <a:noFill xmlns:a="http://schemas.openxmlformats.org/drawingml/2006/main"/>
+          <a:ln xmlns:a="http://schemas.openxmlformats.org/drawingml/2006/main" w="0">
             <a:noFill/>
             <a:prstDash val="solid"/>
           </a:ln>
         </p:spPr>
         <p:txBody>
-          <a:bodyPr lIns="0" tIns="0" rIns="0" bIns="0" anchor="ctr">
+          <a:bodyPr xmlns:a="http://schemas.openxmlformats.org/drawingml/2006/main" lIns="0" tIns="0" rIns="0" bIns="0" anchor="ctr">
             <a:normAutofit/>
           </a:bodyPr>
-          <a:lstStyle/>
-          <a:p>
+          <a:lstStyle xmlns:a="http://schemas.openxmlformats.org/drawingml/2006/main"/>
+          <a:p xmlns:a="http://schemas.openxmlformats.org/drawingml/2006/main">
             <a:pPr algn="ctr">
+              <a:buNone/>
               <a:defRPr sz="2100" b="1">
                 <a:solidFill>
                   <a:srgbClr val="111111"/>
@@ -2582,46 +3122,47 @@
                 <a:ea typeface="Arial"/>
                 <a:cs typeface="Arial"/>
               </a:rPr>
-              <a:t>Categories</a:t>
+              <a:t>Topics</a:t>
             </a:r>
           </a:p>
         </p:txBody>
       </p:sp>
       <p:sp>
         <p:nvSpPr>
-          <p:cNvPr id="38" name="categories-detail">
-            <a:extLst>
-              <a:ext uri="{FF2B5EF4-FFF2-40B4-BE49-F238E27FC236}">
-                <a16:creationId xmlns:a16="http://schemas.microsoft.com/office/drawing/2014/main" id="{A4E0D989-2AE5-4778-932A-F899A51115E8}"/>
-              </a:ext>
-            </a:extLst>
-          </p:cNvPr>
-          <p:cNvSpPr>
-            <a:spLocks noGrp="1"/>
-          </p:cNvSpPr>
-          <p:nvPr/>
-        </p:nvSpPr>
-        <p:spPr>
-          <a:xfrm>
-            <a:off x="6591300" y="3495675"/>
+          <p:cNvPr id="40" name="topics-detail">
+            <a:extLst xmlns:a="http://schemas.openxmlformats.org/drawingml/2006/main">
+              <a:ext uri="{FF2B5EF4-FFF2-40B4-BE49-F238E27FC236}">
+                <a16:creationId xmlns:a16="http://schemas.microsoft.com/office/drawing/2014/main" id="{867A19FD-319E-4FF4-9445-1A4746871D69}"/>
+              </a:ext>
+            </a:extLst>
+          </p:cNvPr>
+          <p:cNvSpPr>
+            <a:spLocks xmlns:a="http://schemas.openxmlformats.org/drawingml/2006/main" noGrp="1"/>
+          </p:cNvSpPr>
+          <p:nvPr/>
+        </p:nvSpPr>
+        <p:spPr>
+          <a:xfrm xmlns:a="http://schemas.openxmlformats.org/drawingml/2006/main">
+            <a:off x="6591300" y="4819650"/>
             <a:ext cx="3848100" cy="266700"/>
           </a:xfrm>
-          <a:prstGeom prst="rect">
-            <a:avLst/>
-          </a:prstGeom>
-          <a:noFill/>
-          <a:ln w="0">
+          <a:prstGeom xmlns:a="http://schemas.openxmlformats.org/drawingml/2006/main" prst="rect">
+            <a:avLst/>
+          </a:prstGeom>
+          <a:noFill xmlns:a="http://schemas.openxmlformats.org/drawingml/2006/main"/>
+          <a:ln xmlns:a="http://schemas.openxmlformats.org/drawingml/2006/main" w="0">
             <a:noFill/>
             <a:prstDash val="solid"/>
           </a:ln>
         </p:spPr>
         <p:txBody>
-          <a:bodyPr lIns="0" tIns="0" rIns="0" bIns="0" anchor="ctr">
+          <a:bodyPr xmlns:a="http://schemas.openxmlformats.org/drawingml/2006/main" lIns="0" tIns="0" rIns="0" bIns="0" anchor="ctr">
             <a:normAutofit/>
           </a:bodyPr>
-          <a:lstStyle/>
-          <a:p>
+          <a:lstStyle xmlns:a="http://schemas.openxmlformats.org/drawingml/2006/main"/>
+          <a:p xmlns:a="http://schemas.openxmlformats.org/drawingml/2006/main">
             <a:pPr algn="ctr">
+              <a:buNone/>
               <a:defRPr sz="1650">
                 <a:solidFill>
                   <a:srgbClr val="333333"/>
@@ -2632,7 +3173,7 @@
               </a:defRPr>
             </a:pPr>
             <a:r>
-              <a:rPr sz="1650" dirty="0">
+              <a:rPr sz="1650">
                 <a:solidFill>
                   <a:srgbClr val="333333"/>
                 </a:solidFill>
@@ -2640,46 +3181,47 @@
                 <a:ea typeface="Arial"/>
                 <a:cs typeface="Arial"/>
               </a:rPr>
-              <a:t> (41 categories)</a:t>
+              <a:t> (251 topics)</a:t>
             </a:r>
           </a:p>
         </p:txBody>
       </p:sp>
       <p:sp>
         <p:nvSpPr>
-          <p:cNvPr id="39" name="topics-title">
-            <a:extLst>
-              <a:ext uri="{FF2B5EF4-FFF2-40B4-BE49-F238E27FC236}">
-                <a16:creationId xmlns:a16="http://schemas.microsoft.com/office/drawing/2014/main" id="{EB2AD788-89E5-4039-A02C-BE16A2EC4B60}"/>
-              </a:ext>
-            </a:extLst>
-          </p:cNvPr>
-          <p:cNvSpPr>
-            <a:spLocks noGrp="1"/>
-          </p:cNvSpPr>
-          <p:nvPr/>
-        </p:nvSpPr>
-        <p:spPr>
-          <a:xfrm>
-            <a:off x="6591300" y="4486275"/>
+          <p:cNvPr id="41" name="browse-posts-title">
+            <a:extLst xmlns:a="http://schemas.openxmlformats.org/drawingml/2006/main">
+              <a:ext uri="{FF2B5EF4-FFF2-40B4-BE49-F238E27FC236}">
+                <a16:creationId xmlns:a16="http://schemas.microsoft.com/office/drawing/2014/main" id="{8116EA9F-B048-43E3-A80D-22EDAC9578F5}"/>
+              </a:ext>
+            </a:extLst>
+          </p:cNvPr>
+          <p:cNvSpPr>
+            <a:spLocks xmlns:a="http://schemas.openxmlformats.org/drawingml/2006/main" noGrp="1"/>
+          </p:cNvSpPr>
+          <p:nvPr/>
+        </p:nvSpPr>
+        <p:spPr>
+          <a:xfrm xmlns:a="http://schemas.openxmlformats.org/drawingml/2006/main">
+            <a:off x="6591300" y="5810250"/>
             <a:ext cx="3848100" cy="323850"/>
           </a:xfrm>
-          <a:prstGeom prst="rect">
-            <a:avLst/>
-          </a:prstGeom>
-          <a:noFill/>
-          <a:ln w="0">
+          <a:prstGeom xmlns:a="http://schemas.openxmlformats.org/drawingml/2006/main" prst="rect">
+            <a:avLst/>
+          </a:prstGeom>
+          <a:noFill xmlns:a="http://schemas.openxmlformats.org/drawingml/2006/main"/>
+          <a:ln xmlns:a="http://schemas.openxmlformats.org/drawingml/2006/main" w="0">
             <a:noFill/>
             <a:prstDash val="solid"/>
           </a:ln>
         </p:spPr>
         <p:txBody>
-          <a:bodyPr lIns="0" tIns="0" rIns="0" bIns="0" anchor="ctr">
+          <a:bodyPr xmlns:a="http://schemas.openxmlformats.org/drawingml/2006/main" lIns="0" tIns="0" rIns="0" bIns="0" anchor="ctr">
             <a:normAutofit/>
           </a:bodyPr>
-          <a:lstStyle/>
-          <a:p>
+          <a:lstStyle xmlns:a="http://schemas.openxmlformats.org/drawingml/2006/main"/>
+          <a:p xmlns:a="http://schemas.openxmlformats.org/drawingml/2006/main">
             <a:pPr algn="ctr">
+              <a:buNone/>
               <a:defRPr sz="2100" b="1">
                 <a:solidFill>
                   <a:srgbClr val="111111"/>
@@ -2698,46 +3240,47 @@
                 <a:ea typeface="Arial"/>
                 <a:cs typeface="Arial"/>
               </a:rPr>
-              <a:t>Topics</a:t>
+              <a:t>Posts</a:t>
             </a:r>
           </a:p>
         </p:txBody>
       </p:sp>
       <p:sp>
         <p:nvSpPr>
-          <p:cNvPr id="40" name="topics-detail">
-            <a:extLst>
-              <a:ext uri="{FF2B5EF4-FFF2-40B4-BE49-F238E27FC236}">
-                <a16:creationId xmlns:a16="http://schemas.microsoft.com/office/drawing/2014/main" id="{867A19FD-319E-4FF4-9445-1A4746871D69}"/>
-              </a:ext>
-            </a:extLst>
-          </p:cNvPr>
-          <p:cNvSpPr>
-            <a:spLocks noGrp="1"/>
-          </p:cNvSpPr>
-          <p:nvPr/>
-        </p:nvSpPr>
-        <p:spPr>
-          <a:xfrm>
-            <a:off x="6591300" y="4819650"/>
+          <p:cNvPr id="42" name="browse-posts-detail">
+            <a:extLst xmlns:a="http://schemas.openxmlformats.org/drawingml/2006/main">
+              <a:ext uri="{FF2B5EF4-FFF2-40B4-BE49-F238E27FC236}">
+                <a16:creationId xmlns:a16="http://schemas.microsoft.com/office/drawing/2014/main" id="{219D03BF-B12B-4305-86D8-24B5FB2F62A3}"/>
+              </a:ext>
+            </a:extLst>
+          </p:cNvPr>
+          <p:cNvSpPr>
+            <a:spLocks xmlns:a="http://schemas.openxmlformats.org/drawingml/2006/main" noGrp="1"/>
+          </p:cNvSpPr>
+          <p:nvPr/>
+        </p:nvSpPr>
+        <p:spPr>
+          <a:xfrm xmlns:a="http://schemas.openxmlformats.org/drawingml/2006/main">
+            <a:off x="6591300" y="6143625"/>
             <a:ext cx="3848100" cy="266700"/>
           </a:xfrm>
-          <a:prstGeom prst="rect">
-            <a:avLst/>
-          </a:prstGeom>
-          <a:noFill/>
-          <a:ln w="0">
+          <a:prstGeom xmlns:a="http://schemas.openxmlformats.org/drawingml/2006/main" prst="rect">
+            <a:avLst/>
+          </a:prstGeom>
+          <a:noFill xmlns:a="http://schemas.openxmlformats.org/drawingml/2006/main"/>
+          <a:ln xmlns:a="http://schemas.openxmlformats.org/drawingml/2006/main" w="0">
             <a:noFill/>
             <a:prstDash val="solid"/>
           </a:ln>
         </p:spPr>
         <p:txBody>
-          <a:bodyPr lIns="0" tIns="0" rIns="0" bIns="0" anchor="ctr">
-            <a:normAutofit/>
+          <a:bodyPr xmlns:a="http://schemas.openxmlformats.org/drawingml/2006/main" lIns="0" tIns="0" rIns="0" bIns="0" anchor="ctr">
+            <a:normAutofit fontScale="100000"/>
           </a:bodyPr>
-          <a:lstStyle/>
-          <a:p>
+          <a:lstStyle xmlns:a="http://schemas.openxmlformats.org/drawingml/2006/main"/>
+          <a:p xmlns:a="http://schemas.openxmlformats.org/drawingml/2006/main">
             <a:pPr algn="ctr">
+              <a:buNone/>
               <a:defRPr sz="1650">
                 <a:solidFill>
                   <a:srgbClr val="333333"/>
@@ -2748,7 +3291,7 @@
               </a:defRPr>
             </a:pPr>
             <a:r>
-              <a:rPr sz="1650" dirty="0">
+              <a:rPr sz="1650">
                 <a:solidFill>
                   <a:srgbClr val="333333"/>
                 </a:solidFill>
@@ -2756,47 +3299,78 @@
                 <a:ea typeface="Arial"/>
                 <a:cs typeface="Arial"/>
               </a:rPr>
-              <a:t> (251 topics)</a:t>
+              <a:t> (4,381 posts)</a:t>
             </a:r>
           </a:p>
         </p:txBody>
       </p:sp>
       <p:sp>
         <p:nvSpPr>
-          <p:cNvPr id="41" name="browse-posts-title">
-            <a:extLst>
-              <a:ext uri="{FF2B5EF4-FFF2-40B4-BE49-F238E27FC236}">
-                <a16:creationId xmlns:a16="http://schemas.microsoft.com/office/drawing/2014/main" id="{8116EA9F-B048-43E3-A80D-22EDAC9578F5}"/>
-              </a:ext>
-            </a:extLst>
-          </p:cNvPr>
-          <p:cNvSpPr>
-            <a:spLocks noGrp="1"/>
-          </p:cNvSpPr>
-          <p:nvPr/>
-        </p:nvSpPr>
-        <p:spPr>
-          <a:xfrm>
-            <a:off x="6591300" y="5810250"/>
-            <a:ext cx="3848100" cy="323850"/>
-          </a:xfrm>
-          <a:prstGeom prst="rect">
-            <a:avLst/>
-          </a:prstGeom>
-          <a:noFill/>
-          <a:ln w="0">
+          <p:cNvPr id="83" name="browse-options-divider">
+            <a:extLst xmlns:a="http://schemas.openxmlformats.org/drawingml/2006/main">
+              <a:ext uri="{FF2B5EF4-FFF2-40B4-BE49-F238E27FC236}">
+                <a16:creationId xmlns:a16="http://schemas.microsoft.com/office/drawing/2014/main" id="{9C1A0C7E-D342-4699-B8C4-88A4CA53D3CB}"/>
+              </a:ext>
+            </a:extLst>
+          </p:cNvPr>
+          <p:cNvSpPr>
+            <a:spLocks xmlns:a="http://schemas.openxmlformats.org/drawingml/2006/main" noGrp="1"/>
+          </p:cNvSpPr>
+          <p:nvPr/>
+        </p:nvSpPr>
+        <p:spPr>
+          <a:xfrm xmlns:a="http://schemas.openxmlformats.org/drawingml/2006/main">
+            <a:off x="8515350" y="1714500"/>
+            <a:ext cx="0" cy="857250"/>
+          </a:xfrm>
+          <a:prstGeom xmlns:a="http://schemas.openxmlformats.org/drawingml/2006/main" prst="line">
+            <a:avLst/>
+          </a:prstGeom>
+          <a:noFill xmlns:a="http://schemas.openxmlformats.org/drawingml/2006/main"/>
+          <a:ln xmlns:a="http://schemas.openxmlformats.org/drawingml/2006/main" w="14288">
+            <a:solidFill>
+              <a:srgbClr val="B98729"/>
+            </a:solidFill>
+            <a:prstDash val="solid"/>
+          </a:ln>
+        </p:spPr>
+      </p:sp>
+      <p:sp>
+        <p:nvSpPr>
+          <p:cNvPr id="84" name="browse-topics-2-title">
+            <a:extLst xmlns:a="http://schemas.openxmlformats.org/drawingml/2006/main">
+              <a:ext uri="{FF2B5EF4-FFF2-40B4-BE49-F238E27FC236}">
+                <a16:creationId xmlns:a16="http://schemas.microsoft.com/office/drawing/2014/main" id="{8F57D405-CDF0-468D-A642-B69B5EC5D457}"/>
+              </a:ext>
+            </a:extLst>
+          </p:cNvPr>
+          <p:cNvSpPr>
+            <a:spLocks xmlns:a="http://schemas.openxmlformats.org/drawingml/2006/main" noGrp="1"/>
+          </p:cNvSpPr>
+          <p:nvPr/>
+        </p:nvSpPr>
+        <p:spPr>
+          <a:xfrm xmlns:a="http://schemas.openxmlformats.org/drawingml/2006/main">
+            <a:off x="8610600" y="1838325"/>
+            <a:ext cx="1905000" cy="323850"/>
+          </a:xfrm>
+          <a:prstGeom xmlns:a="http://schemas.openxmlformats.org/drawingml/2006/main" prst="rect">
+            <a:avLst/>
+          </a:prstGeom>
+          <a:noFill xmlns:a="http://schemas.openxmlformats.org/drawingml/2006/main"/>
+          <a:ln xmlns:a="http://schemas.openxmlformats.org/drawingml/2006/main" w="0">
             <a:noFill/>
             <a:prstDash val="solid"/>
           </a:ln>
         </p:spPr>
         <p:txBody>
-          <a:bodyPr lIns="0" tIns="0" rIns="0" bIns="0" anchor="ctr">
-            <a:normAutofit/>
+          <a:bodyPr xmlns:a="http://schemas.openxmlformats.org/drawingml/2006/main" lIns="0" tIns="0" rIns="0" bIns="0" anchor="ctr">
+            <a:normAutofit fontScale="100000"/>
           </a:bodyPr>
-          <a:lstStyle/>
-          <a:p>
+          <a:lstStyle xmlns:a="http://schemas.openxmlformats.org/drawingml/2006/main"/>
+          <a:p xmlns:a="http://schemas.openxmlformats.org/drawingml/2006/main">
             <a:pPr algn="ctr">
-              <a:defRPr sz="2100" b="1">
+              <a:defRPr sz="1800" b="1">
                 <a:solidFill>
                   <a:srgbClr val="111111"/>
                 </a:solidFill>
@@ -2806,7 +3380,7 @@
               </a:defRPr>
             </a:pPr>
             <a:r>
-              <a:rPr sz="2100" b="1">
+              <a:rPr sz="1800" b="1">
                 <a:solidFill>
                   <a:srgbClr val="111111"/>
                 </a:solidFill>
@@ -2814,47 +3388,47 @@
                 <a:ea typeface="Arial"/>
                 <a:cs typeface="Arial"/>
               </a:rPr>
-              <a:t>Posts</a:t>
+              <a:t>Browse Topics 2</a:t>
             </a:r>
           </a:p>
         </p:txBody>
       </p:sp>
       <p:sp>
         <p:nvSpPr>
-          <p:cNvPr id="42" name="browse-posts-detail">
-            <a:extLst>
-              <a:ext uri="{FF2B5EF4-FFF2-40B4-BE49-F238E27FC236}">
-                <a16:creationId xmlns:a16="http://schemas.microsoft.com/office/drawing/2014/main" id="{219D03BF-B12B-4305-86D8-24B5FB2F62A3}"/>
-              </a:ext>
-            </a:extLst>
-          </p:cNvPr>
-          <p:cNvSpPr>
-            <a:spLocks noGrp="1"/>
-          </p:cNvSpPr>
-          <p:nvPr/>
-        </p:nvSpPr>
-        <p:spPr>
-          <a:xfrm>
-            <a:off x="6591300" y="6143625"/>
-            <a:ext cx="3848100" cy="266700"/>
-          </a:xfrm>
-          <a:prstGeom prst="rect">
-            <a:avLst/>
-          </a:prstGeom>
-          <a:noFill/>
-          <a:ln w="0">
+          <p:cNvPr id="85" name="browse-topics-2-detail">
+            <a:extLst xmlns:a="http://schemas.openxmlformats.org/drawingml/2006/main">
+              <a:ext uri="{FF2B5EF4-FFF2-40B4-BE49-F238E27FC236}">
+                <a16:creationId xmlns:a16="http://schemas.microsoft.com/office/drawing/2014/main" id="{2A89314D-ACAB-48A0-BE6C-CE174C0A1979}"/>
+              </a:ext>
+            </a:extLst>
+          </p:cNvPr>
+          <p:cNvSpPr>
+            <a:spLocks xmlns:a="http://schemas.openxmlformats.org/drawingml/2006/main" noGrp="1"/>
+          </p:cNvSpPr>
+          <p:nvPr/>
+        </p:nvSpPr>
+        <p:spPr>
+          <a:xfrm xmlns:a="http://schemas.openxmlformats.org/drawingml/2006/main">
+            <a:off x="8610600" y="2171700"/>
+            <a:ext cx="1905000" cy="266700"/>
+          </a:xfrm>
+          <a:prstGeom xmlns:a="http://schemas.openxmlformats.org/drawingml/2006/main" prst="rect">
+            <a:avLst/>
+          </a:prstGeom>
+          <a:noFill xmlns:a="http://schemas.openxmlformats.org/drawingml/2006/main"/>
+          <a:ln xmlns:a="http://schemas.openxmlformats.org/drawingml/2006/main" w="0">
             <a:noFill/>
             <a:prstDash val="solid"/>
           </a:ln>
         </p:spPr>
         <p:txBody>
-          <a:bodyPr lIns="0" tIns="0" rIns="0" bIns="0" anchor="ctr">
-            <a:normAutofit/>
+          <a:bodyPr xmlns:a="http://schemas.openxmlformats.org/drawingml/2006/main" lIns="0" tIns="0" rIns="0" bIns="0" anchor="ctr">
+            <a:normAutofit fontScale="100000"/>
           </a:bodyPr>
-          <a:lstStyle/>
-          <a:p>
+          <a:lstStyle xmlns:a="http://schemas.openxmlformats.org/drawingml/2006/main"/>
+          <a:p xmlns:a="http://schemas.openxmlformats.org/drawingml/2006/main">
             <a:pPr algn="ctr">
-              <a:defRPr sz="1650">
+              <a:defRPr sz="1350">
                 <a:solidFill>
                   <a:srgbClr val="333333"/>
                 </a:solidFill>
@@ -2864,7 +3438,7 @@
               </a:defRPr>
             </a:pPr>
             <a:r>
-              <a:rPr sz="1650" dirty="0">
+              <a:rPr sz="1350">
                 <a:solidFill>
                   <a:srgbClr val="333333"/>
                 </a:solidFill>
@@ -2872,29 +3446,7 @@
                 <a:ea typeface="Arial"/>
                 <a:cs typeface="Arial"/>
               </a:rPr>
-              <a:t> (4,3</a:t>
-            </a:r>
-            <a:r>
-              <a:rPr lang="en-US" sz="1650" dirty="0">
-                <a:solidFill>
-                  <a:srgbClr val="333333"/>
-                </a:solidFill>
-                <a:latin typeface="Arial"/>
-                <a:ea typeface="Arial"/>
-                <a:cs typeface="Arial"/>
-              </a:rPr>
-              <a:t>00+</a:t>
-            </a:r>
-            <a:r>
-              <a:rPr sz="1650" dirty="0">
-                <a:solidFill>
-                  <a:srgbClr val="333333"/>
-                </a:solidFill>
-                <a:latin typeface="Arial"/>
-                <a:ea typeface="Arial"/>
-                <a:cs typeface="Arial"/>
-              </a:rPr>
-              <a:t> posts)</a:t>
+              <a:t> (9 subject areas)</a:t>
             </a:r>
           </a:p>
         </p:txBody>
@@ -2906,9 +3458,6 @@
       </p:ext>
     </p:extLst>
   </p:cSld>
-  <p:clrMapOvr>
-    <a:masterClrMapping/>
-  </p:clrMapOvr>
 </p:sld>
 </file>
 
@@ -3154,254 +3703,5 @@
       </a:bgFillStyleLst>
     </a:fmtScheme>
   </a:themeElements>
-  <a:objectDefaults/>
-  <a:extraClrSchemeLst/>
-</a:theme>
-</file>
-
-<file path=ppt/theme/theme2.xml><?xml version="1.0" encoding="utf-8"?>
-<a:theme xmlns:a="http://schemas.openxmlformats.org/drawingml/2006/main" name="ChatGPT">
-  <a:themeElements>
-    <a:clrScheme name="ChatGPT">
-      <a:dk1>
-        <a:srgbClr val="000000"/>
-      </a:dk1>
-      <a:lt1>
-        <a:srgbClr val="FFFFFF"/>
-      </a:lt1>
-      <a:dk2>
-        <a:srgbClr val="0E2841"/>
-      </a:dk2>
-      <a:lt2>
-        <a:srgbClr val="E8E8E8"/>
-      </a:lt2>
-      <a:accent1>
-        <a:srgbClr val="156082"/>
-      </a:accent1>
-      <a:accent2>
-        <a:srgbClr val="E97132"/>
-      </a:accent2>
-      <a:accent3>
-        <a:srgbClr val="196B24"/>
-      </a:accent3>
-      <a:accent4>
-        <a:srgbClr val="0F9ED5"/>
-      </a:accent4>
-      <a:accent5>
-        <a:srgbClr val="A02B93"/>
-      </a:accent5>
-      <a:accent6>
-        <a:srgbClr val="4EA72E"/>
-      </a:accent6>
-      <a:hlink>
-        <a:srgbClr val="467886"/>
-      </a:hlink>
-      <a:folHlink>
-        <a:srgbClr val="96607D"/>
-      </a:folHlink>
-    </a:clrScheme>
-    <a:fontScheme name="Office">
-      <a:majorFont>
-        <a:latin typeface="Calibri Light"/>
-        <a:ea typeface="Calibri Light"/>
-        <a:cs typeface="Calibri Light"/>
-      </a:majorFont>
-      <a:minorFont>
-        <a:latin typeface="Calibri"/>
-        <a:ea typeface="Calibri"/>
-        <a:cs typeface="Calibri"/>
-      </a:minorFont>
-    </a:fontScheme>
-    <a:fmtScheme name="ChatGPT">
-      <a:fillStyleLst>
-        <a:solidFill>
-          <a:schemeClr val="phClr"/>
-        </a:solidFill>
-        <a:gradFill>
-          <a:gsLst>
-            <a:gs pos="0">
-              <a:schemeClr val="phClr">
-                <a:tint val="67000"/>
-                <a:lumMod val="110000"/>
-                <a:satMod val="105000"/>
-              </a:schemeClr>
-            </a:gs>
-            <a:gs pos="50000">
-              <a:schemeClr val="phClr">
-                <a:tint val="73000"/>
-                <a:lumMod val="105000"/>
-                <a:satMod val="103000"/>
-              </a:schemeClr>
-            </a:gs>
-            <a:gs pos="100000">
-              <a:schemeClr val="phClr">
-                <a:tint val="81000"/>
-                <a:lumMod val="105000"/>
-                <a:satMod val="109000"/>
-              </a:schemeClr>
-            </a:gs>
-          </a:gsLst>
-          <a:lin ang="5400000" scaled="0"/>
-        </a:gradFill>
-        <a:gradFill>
-          <a:gsLst>
-            <a:gs pos="0">
-              <a:schemeClr val="phClr">
-                <a:tint val="94000"/>
-                <a:lumMod val="102000"/>
-                <a:satMod val="103000"/>
-              </a:schemeClr>
-            </a:gs>
-            <a:gs pos="50000">
-              <a:schemeClr val="phClr">
-                <a:shade val="100000"/>
-                <a:lumMod val="100000"/>
-                <a:satMod val="110000"/>
-              </a:schemeClr>
-            </a:gs>
-            <a:gs pos="100000">
-              <a:schemeClr val="phClr">
-                <a:shade val="78000"/>
-                <a:lumMod val="99000"/>
-                <a:satMod val="120000"/>
-              </a:schemeClr>
-            </a:gs>
-          </a:gsLst>
-          <a:lin ang="5400000" scaled="0"/>
-        </a:gradFill>
-      </a:fillStyleLst>
-      <a:lnStyleLst>
-        <a:ln w="12700">
-          <a:solidFill>
-            <a:schemeClr val="phClr"/>
-          </a:solidFill>
-          <a:prstDash val="solid"/>
-        </a:ln>
-        <a:ln w="19050">
-          <a:solidFill>
-            <a:schemeClr val="phClr"/>
-          </a:solidFill>
-          <a:prstDash val="solid"/>
-        </a:ln>
-        <a:ln w="25400">
-          <a:solidFill>
-            <a:schemeClr val="phClr"/>
-          </a:solidFill>
-          <a:prstDash val="solid"/>
-        </a:ln>
-      </a:lnStyleLst>
-      <a:effectStyleLst>
-        <a:effectStyle>
-          <a:effectLst/>
-        </a:effectStyle>
-        <a:effectStyle>
-          <a:effectLst/>
-        </a:effectStyle>
-        <a:effectStyle>
-          <a:effectLst>
-            <a:outerShdw blurRad="57150" dist="19050" dir="5400000">
-              <a:srgbClr val="000000">
-                <a:alpha val="16000"/>
-              </a:srgbClr>
-            </a:outerShdw>
-          </a:effectLst>
-        </a:effectStyle>
-        <a:effectStyle>
-          <a:effectLst>
-            <a:outerShdw blurRad="19050" dist="9525" dir="5400000">
-              <a:srgbClr val="000000">
-                <a:alpha val="6000"/>
-              </a:srgbClr>
-            </a:outerShdw>
-          </a:effectLst>
-        </a:effectStyle>
-        <a:effectStyle>
-          <a:effectLst>
-            <a:outerShdw blurRad="28575" dist="9525" dir="5400000">
-              <a:srgbClr val="000000">
-                <a:alpha val="8000"/>
-              </a:srgbClr>
-            </a:outerShdw>
-          </a:effectLst>
-        </a:effectStyle>
-        <a:effectStyle>
-          <a:effectLst>
-            <a:outerShdw blurRad="57150" dist="19050" dir="5400000">
-              <a:srgbClr val="000000">
-                <a:alpha val="10000"/>
-              </a:srgbClr>
-            </a:outerShdw>
-          </a:effectLst>
-        </a:effectStyle>
-        <a:effectStyle>
-          <a:effectLst>
-            <a:outerShdw blurRad="114300" dist="38100" dir="5400000">
-              <a:srgbClr val="000000">
-                <a:alpha val="12000"/>
-              </a:srgbClr>
-            </a:outerShdw>
-          </a:effectLst>
-        </a:effectStyle>
-        <a:effectStyle>
-          <a:effectLst>
-            <a:outerShdw blurRad="171450" dist="57150" dir="5400000">
-              <a:srgbClr val="000000">
-                <a:alpha val="16000"/>
-              </a:srgbClr>
-            </a:outerShdw>
-          </a:effectLst>
-        </a:effectStyle>
-        <a:effectStyle>
-          <a:effectLst>
-            <a:outerShdw blurRad="266700" dist="95250" dir="5400000">
-              <a:srgbClr val="000000">
-                <a:alpha val="24000"/>
-              </a:srgbClr>
-            </a:outerShdw>
-          </a:effectLst>
-        </a:effectStyle>
-      </a:effectStyleLst>
-      <a:bgFillStyleLst>
-        <a:solidFill>
-          <a:schemeClr val="phClr"/>
-        </a:solidFill>
-        <a:solidFill>
-          <a:schemeClr val="phClr">
-            <a:tint val="95000"/>
-            <a:satMod val="170000"/>
-          </a:schemeClr>
-        </a:solidFill>
-        <a:gradFill>
-          <a:gsLst>
-            <a:gs pos="0">
-              <a:schemeClr val="phClr">
-                <a:tint val="93000"/>
-                <a:shade val="98000"/>
-                <a:lumMod val="102000"/>
-                <a:satMod val="150000"/>
-              </a:schemeClr>
-            </a:gs>
-            <a:gs pos="50000">
-              <a:schemeClr val="phClr">
-                <a:tint val="98000"/>
-                <a:shade val="90000"/>
-                <a:lumMod val="103000"/>
-                <a:satMod val="130000"/>
-              </a:schemeClr>
-            </a:gs>
-            <a:gs pos="100000">
-              <a:schemeClr val="phClr">
-                <a:shade val="63000"/>
-                <a:satMod val="120000"/>
-              </a:schemeClr>
-            </a:gs>
-          </a:gsLst>
-          <a:lin ang="5400000" scaled="0"/>
-        </a:gradFill>
-      </a:bgFillStyleLst>
-    </a:fmtScheme>
-  </a:themeElements>
-  <a:objectDefaults/>
-  <a:extraClrSchemeLst/>
 </a:theme>
 </file>
</xml_diff>

<commit_message>
Consolidate primary subject areas
</commit_message>
<xml_diff>
--- a/docs/ehrman_search_methods_editable.pptx
+++ b/docs/ehrman_search_methods_editable.pptx
@@ -2,111 +2,16 @@
 <file path=ppt/presentation.xml><?xml version="1.0" encoding="utf-8"?>
 <p:presentation xmlns:p="http://schemas.openxmlformats.org/presentationml/2006/main">
   <p:sldMasterIdLst>
-    <p:sldMasterId xmlns:r="http://schemas.openxmlformats.org/officeDocument/2006/relationships" id="2147483648" r:id="Rd50737dae8b34df4"/>
+    <p:sldMasterId xmlns:r="http://schemas.openxmlformats.org/officeDocument/2006/relationships" id="2147483648" r:id="Ra063641749444f2d"/>
   </p:sldMasterIdLst>
   <p:notesMasterIdLst>
-    <p:notesMasterId xmlns:r="http://schemas.openxmlformats.org/officeDocument/2006/relationships" r:id="R3dc4d0e1cb3643ec"/>
+    <p:notesMasterId xmlns:r="http://schemas.openxmlformats.org/officeDocument/2006/relationships" r:id="R1f9d5183e49b4019"/>
   </p:notesMasterIdLst>
   <p:sldIdLst>
-    <p:sldId xmlns:r="http://schemas.openxmlformats.org/officeDocument/2006/relationships" id="256" r:id="Re9303360b01b437a"/>
+    <p:sldId xmlns:r="http://schemas.openxmlformats.org/officeDocument/2006/relationships" id="256" r:id="Rfc3291510435472b"/>
   </p:sldIdLst>
   <p:sldSz cx="11430000" cy="7334250"/>
   <p:notesSz cx="6858000" cy="9144000"/>
-  <p:defaultTextStyle>
-    <a:defPPr xmlns:a="http://schemas.openxmlformats.org/drawingml/2006/main">
-      <a:defRPr lang="en-US"/>
-    </a:defPPr>
-    <a:lvl1pPr xmlns:a="http://schemas.openxmlformats.org/drawingml/2006/main" marL="0" indent="0" algn="l" defTabSz="914400">
-      <a:defRPr sz="1800" kern="1200">
-        <a:solidFill>
-          <a:schemeClr val="tx1"/>
-        </a:solidFill>
-        <a:latin typeface="+mn-lt"/>
-        <a:ea typeface="+mn-ea"/>
-        <a:cs typeface="+mn-cs"/>
-      </a:defRPr>
-    </a:lvl1pPr>
-    <a:lvl2pPr xmlns:a="http://schemas.openxmlformats.org/drawingml/2006/main" marL="457200" indent="0" algn="l" defTabSz="914400">
-      <a:defRPr sz="1800" kern="1200">
-        <a:solidFill>
-          <a:schemeClr val="tx1"/>
-        </a:solidFill>
-        <a:latin typeface="+mn-lt"/>
-        <a:ea typeface="+mn-ea"/>
-        <a:cs typeface="+mn-cs"/>
-      </a:defRPr>
-    </a:lvl2pPr>
-    <a:lvl3pPr xmlns:a="http://schemas.openxmlformats.org/drawingml/2006/main" marL="914400" indent="0" algn="l" defTabSz="914400">
-      <a:defRPr sz="1800" kern="1200">
-        <a:solidFill>
-          <a:schemeClr val="tx1"/>
-        </a:solidFill>
-        <a:latin typeface="+mn-lt"/>
-        <a:ea typeface="+mn-ea"/>
-        <a:cs typeface="+mn-cs"/>
-      </a:defRPr>
-    </a:lvl3pPr>
-    <a:lvl4pPr xmlns:a="http://schemas.openxmlformats.org/drawingml/2006/main" marL="1371600" indent="0" algn="l" defTabSz="914400">
-      <a:defRPr sz="1800" kern="1200">
-        <a:solidFill>
-          <a:schemeClr val="tx1"/>
-        </a:solidFill>
-        <a:latin typeface="+mn-lt"/>
-        <a:ea typeface="+mn-ea"/>
-        <a:cs typeface="+mn-cs"/>
-      </a:defRPr>
-    </a:lvl4pPr>
-    <a:lvl5pPr xmlns:a="http://schemas.openxmlformats.org/drawingml/2006/main" marL="1828800" indent="0" algn="l" defTabSz="914400">
-      <a:defRPr sz="1800" kern="1200">
-        <a:solidFill>
-          <a:schemeClr val="tx1"/>
-        </a:solidFill>
-        <a:latin typeface="+mn-lt"/>
-        <a:ea typeface="+mn-ea"/>
-        <a:cs typeface="+mn-cs"/>
-      </a:defRPr>
-    </a:lvl5pPr>
-    <a:lvl6pPr xmlns:a="http://schemas.openxmlformats.org/drawingml/2006/main" marL="2286000" indent="0" algn="l" defTabSz="914400">
-      <a:defRPr sz="1800" kern="1200">
-        <a:solidFill>
-          <a:schemeClr val="tx1"/>
-        </a:solidFill>
-        <a:latin typeface="+mn-lt"/>
-        <a:ea typeface="+mn-ea"/>
-        <a:cs typeface="+mn-cs"/>
-      </a:defRPr>
-    </a:lvl6pPr>
-    <a:lvl7pPr xmlns:a="http://schemas.openxmlformats.org/drawingml/2006/main" marL="2743200" indent="0" algn="l" defTabSz="914400">
-      <a:defRPr sz="1800" kern="1200">
-        <a:solidFill>
-          <a:schemeClr val="tx1"/>
-        </a:solidFill>
-        <a:latin typeface="+mn-lt"/>
-        <a:ea typeface="+mn-ea"/>
-        <a:cs typeface="+mn-cs"/>
-      </a:defRPr>
-    </a:lvl7pPr>
-    <a:lvl8pPr xmlns:a="http://schemas.openxmlformats.org/drawingml/2006/main" marL="3200400" indent="0" algn="l" defTabSz="914400">
-      <a:defRPr sz="1800" kern="1200">
-        <a:solidFill>
-          <a:schemeClr val="tx1"/>
-        </a:solidFill>
-        <a:latin typeface="+mn-lt"/>
-        <a:ea typeface="+mn-ea"/>
-        <a:cs typeface="+mn-cs"/>
-      </a:defRPr>
-    </a:lvl8pPr>
-    <a:lvl9pPr xmlns:a="http://schemas.openxmlformats.org/drawingml/2006/main" marL="3657600" indent="0" algn="l" defTabSz="914400">
-      <a:defRPr sz="1800" kern="1200">
-        <a:solidFill>
-          <a:schemeClr val="tx1"/>
-        </a:solidFill>
-        <a:latin typeface="+mn-lt"/>
-        <a:ea typeface="+mn-ea"/>
-        <a:cs typeface="+mn-cs"/>
-      </a:defRPr>
-    </a:lvl9pPr>
-  </p:defaultTextStyle>
 </p:presentation>
 </file>
 
@@ -601,7 +506,7 @@
   </p:cSld>
   <p:clrMap bg1="lt1" tx1="dk1" bg2="lt2" tx2="dk2" accent1="accent1" accent2="accent2" accent3="accent3" accent4="accent4" accent5="accent5" accent6="accent6" hlink="hlink" folHlink="folHlink"/>
   <p:sldLayoutIdLst>
-    <p:sldLayoutId xmlns:r="http://schemas.openxmlformats.org/officeDocument/2006/relationships" id="2147483649" r:id="R79c3a7da8fc140ae"/>
+    <p:sldLayoutId xmlns:r="http://schemas.openxmlformats.org/officeDocument/2006/relationships" id="2147483649" r:id="R2957b382451c4951"/>
   </p:sldLayoutIdLst>
   <p:txStyles>
     <p:titleStyle>
@@ -1882,7 +1787,7 @@
       </p:sp>
       <p:cxnSp>
         <p:nvCxnSpPr>
-          <p:cNvPr id="102" name="Straight Arrow Connector 58"/>
+          <p:cNvPr id="122" name="Straight Arrow Connector 58"/>
           <p:cNvCxnSpPr>
             <a:stCxn xmlns:a="http://schemas.openxmlformats.org/drawingml/2006/main" id="7" idx="2"/>
             <a:endCxn xmlns:a="http://schemas.openxmlformats.org/drawingml/2006/main" id="8" idx="0"/>
@@ -1908,7 +1813,7 @@
       </p:cxnSp>
       <p:cxnSp>
         <p:nvCxnSpPr>
-          <p:cNvPr id="103" name="Straight Arrow Connector 59"/>
+          <p:cNvPr id="123" name="Straight Arrow Connector 59"/>
           <p:cNvCxnSpPr>
             <a:stCxn xmlns:a="http://schemas.openxmlformats.org/drawingml/2006/main" id="8" idx="2"/>
             <a:endCxn xmlns:a="http://schemas.openxmlformats.org/drawingml/2006/main" id="9" idx="0"/>
@@ -1934,7 +1839,7 @@
       </p:cxnSp>
       <p:cxnSp>
         <p:nvCxnSpPr>
-          <p:cNvPr id="104" name="Straight Arrow Connector 60"/>
+          <p:cNvPr id="124" name="Straight Arrow Connector 60"/>
           <p:cNvCxnSpPr>
             <a:stCxn xmlns:a="http://schemas.openxmlformats.org/drawingml/2006/main" id="9" idx="2"/>
             <a:endCxn xmlns:a="http://schemas.openxmlformats.org/drawingml/2006/main" id="10" idx="0"/>
@@ -1960,7 +1865,7 @@
       </p:cxnSp>
       <p:cxnSp>
         <p:nvCxnSpPr>
-          <p:cNvPr id="105" name="Straight Arrow Connector 61"/>
+          <p:cNvPr id="125" name="Straight Arrow Connector 61"/>
           <p:cNvCxnSpPr>
             <a:stCxn xmlns:a="http://schemas.openxmlformats.org/drawingml/2006/main" id="11" idx="2"/>
             <a:endCxn xmlns:a="http://schemas.openxmlformats.org/drawingml/2006/main" id="16" idx="0"/>
@@ -2923,7 +2828,7 @@
                 <a:ea typeface="Arial"/>
                 <a:cs typeface="Arial"/>
               </a:rPr>
-              <a:t> (11 </a:t>
+              <a:t> (</a:t>
             </a:r>
             <a:r>
               <a:rPr sz="1350">
@@ -2934,7 +2839,7 @@
                 <a:ea typeface="Arial"/>
                 <a:cs typeface="Arial"/>
               </a:rPr>
-              <a:t>subject </a:t>
+              <a:t>10 subject areas</a:t>
             </a:r>
             <a:r>
               <a:rPr sz="1350">
@@ -2945,7 +2850,7 @@
                 <a:ea typeface="Arial"/>
                 <a:cs typeface="Arial"/>
               </a:rPr>
-              <a:t>areas)</a:t>
+              <a:t>)</a:t>
             </a:r>
           </a:p>
         </p:txBody>
@@ -3370,6 +3275,7 @@
           <a:lstStyle xmlns:a="http://schemas.openxmlformats.org/drawingml/2006/main"/>
           <a:p xmlns:a="http://schemas.openxmlformats.org/drawingml/2006/main">
             <a:pPr algn="ctr">
+              <a:buNone/>
               <a:defRPr sz="1800" b="1">
                 <a:solidFill>
                   <a:srgbClr val="111111"/>
@@ -3428,6 +3334,7 @@
           <a:lstStyle xmlns:a="http://schemas.openxmlformats.org/drawingml/2006/main"/>
           <a:p xmlns:a="http://schemas.openxmlformats.org/drawingml/2006/main">
             <a:pPr algn="ctr">
+              <a:buNone/>
               <a:defRPr sz="1350">
                 <a:solidFill>
                   <a:srgbClr val="333333"/>

</xml_diff>

<commit_message>
Expand biblical book topics and refresh demo
</commit_message>
<xml_diff>
--- a/docs/ehrman_search_methods_editable.pptx
+++ b/docs/ehrman_search_methods_editable.pptx
@@ -2,13 +2,13 @@
 <file path=ppt/presentation.xml><?xml version="1.0" encoding="utf-8"?>
 <p:presentation xmlns:p="http://schemas.openxmlformats.org/presentationml/2006/main">
   <p:sldMasterIdLst>
-    <p:sldMasterId xmlns:r="http://schemas.openxmlformats.org/officeDocument/2006/relationships" id="2147483648" r:id="Ra063641749444f2d"/>
+    <p:sldMasterId xmlns:r="http://schemas.openxmlformats.org/officeDocument/2006/relationships" id="2147483648" r:id="Re4a0e4834c654e69"/>
   </p:sldMasterIdLst>
   <p:notesMasterIdLst>
-    <p:notesMasterId xmlns:r="http://schemas.openxmlformats.org/officeDocument/2006/relationships" r:id="R1f9d5183e49b4019"/>
+    <p:notesMasterId xmlns:r="http://schemas.openxmlformats.org/officeDocument/2006/relationships" r:id="R9dde9e35d80542a3"/>
   </p:notesMasterIdLst>
   <p:sldIdLst>
-    <p:sldId xmlns:r="http://schemas.openxmlformats.org/officeDocument/2006/relationships" id="256" r:id="Rfc3291510435472b"/>
+    <p:sldId xmlns:r="http://schemas.openxmlformats.org/officeDocument/2006/relationships" id="256" r:id="R13a191995d134373"/>
   </p:sldIdLst>
   <p:sldSz cx="11430000" cy="7334250"/>
   <p:notesSz cx="6858000" cy="9144000"/>
@@ -506,7 +506,7 @@
   </p:cSld>
   <p:clrMap bg1="lt1" tx1="dk1" bg2="lt2" tx2="dk2" accent1="accent1" accent2="accent2" accent3="accent3" accent4="accent4" accent5="accent5" accent6="accent6" hlink="hlink" folHlink="folHlink"/>
   <p:sldLayoutIdLst>
-    <p:sldLayoutId xmlns:r="http://schemas.openxmlformats.org/officeDocument/2006/relationships" id="2147483649" r:id="R2957b382451c4951"/>
+    <p:sldLayoutId xmlns:r="http://schemas.openxmlformats.org/officeDocument/2006/relationships" id="2147483649" r:id="Rde12c41aafac4cdf"/>
   </p:sldLayoutIdLst>
   <p:txStyles>
     <p:titleStyle>
@@ -1787,7 +1787,7 @@
       </p:sp>
       <p:cxnSp>
         <p:nvCxnSpPr>
-          <p:cNvPr id="122" name="Straight Arrow Connector 58"/>
+          <p:cNvPr id="142" name="Straight Arrow Connector 58"/>
           <p:cNvCxnSpPr>
             <a:stCxn xmlns:a="http://schemas.openxmlformats.org/drawingml/2006/main" id="7" idx="2"/>
             <a:endCxn xmlns:a="http://schemas.openxmlformats.org/drawingml/2006/main" id="8" idx="0"/>
@@ -1813,7 +1813,7 @@
       </p:cxnSp>
       <p:cxnSp>
         <p:nvCxnSpPr>
-          <p:cNvPr id="123" name="Straight Arrow Connector 59"/>
+          <p:cNvPr id="143" name="Straight Arrow Connector 59"/>
           <p:cNvCxnSpPr>
             <a:stCxn xmlns:a="http://schemas.openxmlformats.org/drawingml/2006/main" id="8" idx="2"/>
             <a:endCxn xmlns:a="http://schemas.openxmlformats.org/drawingml/2006/main" id="9" idx="0"/>
@@ -1839,7 +1839,7 @@
       </p:cxnSp>
       <p:cxnSp>
         <p:nvCxnSpPr>
-          <p:cNvPr id="124" name="Straight Arrow Connector 60"/>
+          <p:cNvPr id="144" name="Straight Arrow Connector 60"/>
           <p:cNvCxnSpPr>
             <a:stCxn xmlns:a="http://schemas.openxmlformats.org/drawingml/2006/main" id="9" idx="2"/>
             <a:endCxn xmlns:a="http://schemas.openxmlformats.org/drawingml/2006/main" id="10" idx="0"/>
@@ -1865,7 +1865,7 @@
       </p:cxnSp>
       <p:cxnSp>
         <p:nvCxnSpPr>
-          <p:cNvPr id="125" name="Straight Arrow Connector 61"/>
+          <p:cNvPr id="145" name="Straight Arrow Connector 61"/>
           <p:cNvCxnSpPr>
             <a:stCxn xmlns:a="http://schemas.openxmlformats.org/drawingml/2006/main" id="11" idx="2"/>
             <a:endCxn xmlns:a="http://schemas.openxmlformats.org/drawingml/2006/main" id="16" idx="0"/>
@@ -1978,7 +1978,7 @@
         </p:spPr>
         <p:txBody>
           <a:bodyPr xmlns:a="http://schemas.openxmlformats.org/drawingml/2006/main" lIns="0" tIns="0" rIns="0" bIns="0" anchor="ctr">
-            <a:normAutofit/>
+            <a:normAutofit fontScale="100000"/>
           </a:bodyPr>
           <a:lstStyle xmlns:a="http://schemas.openxmlformats.org/drawingml/2006/main"/>
           <a:p xmlns:a="http://schemas.openxmlformats.org/drawingml/2006/main">
@@ -2002,7 +2002,29 @@
                 <a:ea typeface="Arial"/>
                 <a:cs typeface="Arial"/>
               </a:rPr>
-              <a:t>(251 topics)</a:t>
+              <a:t>(</a:t>
+            </a:r>
+            <a:r>
+              <a:rPr sz="1650">
+                <a:solidFill>
+                  <a:srgbClr val="333333"/>
+                </a:solidFill>
+                <a:latin typeface="Arial"/>
+                <a:ea typeface="Arial"/>
+                <a:cs typeface="Arial"/>
+              </a:rPr>
+              <a:t>270</a:t>
+            </a:r>
+            <a:r>
+              <a:rPr sz="1650">
+                <a:solidFill>
+                  <a:srgbClr val="333333"/>
+                </a:solidFill>
+                <a:latin typeface="Arial"/>
+                <a:ea typeface="Arial"/>
+                <a:cs typeface="Arial"/>
+              </a:rPr>
+              <a:t> topics)</a:t>
             </a:r>
           </a:p>
         </p:txBody>
@@ -2120,7 +2142,29 @@
                 <a:ea typeface="Arial"/>
                 <a:cs typeface="Arial"/>
               </a:rPr>
-              <a:t>(1,472 keywords)</a:t>
+              <a:t>(</a:t>
+            </a:r>
+            <a:r>
+              <a:rPr sz="1650">
+                <a:solidFill>
+                  <a:srgbClr val="333333"/>
+                </a:solidFill>
+                <a:latin typeface="Arial"/>
+                <a:ea typeface="Arial"/>
+                <a:cs typeface="Arial"/>
+              </a:rPr>
+              <a:t>1,473</a:t>
+            </a:r>
+            <a:r>
+              <a:rPr sz="1650">
+                <a:solidFill>
+                  <a:srgbClr val="333333"/>
+                </a:solidFill>
+                <a:latin typeface="Arial"/>
+                <a:ea typeface="Arial"/>
+                <a:cs typeface="Arial"/>
+              </a:rPr>
+              <a:t> keywords)</a:t>
             </a:r>
           </a:p>
         </p:txBody>
@@ -3062,7 +3106,7 @@
         </p:spPr>
         <p:txBody>
           <a:bodyPr xmlns:a="http://schemas.openxmlformats.org/drawingml/2006/main" lIns="0" tIns="0" rIns="0" bIns="0" anchor="ctr">
-            <a:normAutofit/>
+            <a:normAutofit fontScale="100000"/>
           </a:bodyPr>
           <a:lstStyle xmlns:a="http://schemas.openxmlformats.org/drawingml/2006/main"/>
           <a:p xmlns:a="http://schemas.openxmlformats.org/drawingml/2006/main">
@@ -3086,7 +3130,29 @@
                 <a:ea typeface="Arial"/>
                 <a:cs typeface="Arial"/>
               </a:rPr>
-              <a:t> (251 topics)</a:t>
+              <a:t> (</a:t>
+            </a:r>
+            <a:r>
+              <a:rPr sz="1650">
+                <a:solidFill>
+                  <a:srgbClr val="333333"/>
+                </a:solidFill>
+                <a:latin typeface="Arial"/>
+                <a:ea typeface="Arial"/>
+                <a:cs typeface="Arial"/>
+              </a:rPr>
+              <a:t>270</a:t>
+            </a:r>
+            <a:r>
+              <a:rPr sz="1650">
+                <a:solidFill>
+                  <a:srgbClr val="333333"/>
+                </a:solidFill>
+                <a:latin typeface="Arial"/>
+                <a:ea typeface="Arial"/>
+                <a:cs typeface="Arial"/>
+              </a:rPr>
+              <a:t> topics)</a:t>
             </a:r>
           </a:p>
         </p:txBody>

</xml_diff>

<commit_message>
Add Peter topic and refresh demos
</commit_message>
<xml_diff>
--- a/docs/ehrman_search_methods_editable.pptx
+++ b/docs/ehrman_search_methods_editable.pptx
@@ -2,13 +2,13 @@
 <file path=ppt/presentation.xml><?xml version="1.0" encoding="utf-8"?>
 <p:presentation xmlns:p="http://schemas.openxmlformats.org/presentationml/2006/main">
   <p:sldMasterIdLst>
-    <p:sldMasterId xmlns:r="http://schemas.openxmlformats.org/officeDocument/2006/relationships" id="2147483648" r:id="Re4a0e4834c654e69"/>
+    <p:sldMasterId xmlns:r="http://schemas.openxmlformats.org/officeDocument/2006/relationships" id="2147483648" r:id="R91e0085fcf3b4e4e"/>
   </p:sldMasterIdLst>
   <p:notesMasterIdLst>
-    <p:notesMasterId xmlns:r="http://schemas.openxmlformats.org/officeDocument/2006/relationships" r:id="R9dde9e35d80542a3"/>
+    <p:notesMasterId xmlns:r="http://schemas.openxmlformats.org/officeDocument/2006/relationships" r:id="R4439e6f202614089"/>
   </p:notesMasterIdLst>
   <p:sldIdLst>
-    <p:sldId xmlns:r="http://schemas.openxmlformats.org/officeDocument/2006/relationships" id="256" r:id="R13a191995d134373"/>
+    <p:sldId xmlns:r="http://schemas.openxmlformats.org/officeDocument/2006/relationships" id="256" r:id="R312dbbfd24594a9e"/>
   </p:sldIdLst>
   <p:sldSz cx="11430000" cy="7334250"/>
   <p:notesSz cx="6858000" cy="9144000"/>
@@ -506,7 +506,7 @@
   </p:cSld>
   <p:clrMap bg1="lt1" tx1="dk1" bg2="lt2" tx2="dk2" accent1="accent1" accent2="accent2" accent3="accent3" accent4="accent4" accent5="accent5" accent6="accent6" hlink="hlink" folHlink="folHlink"/>
   <p:sldLayoutIdLst>
-    <p:sldLayoutId xmlns:r="http://schemas.openxmlformats.org/officeDocument/2006/relationships" id="2147483649" r:id="Rde12c41aafac4cdf"/>
+    <p:sldLayoutId xmlns:r="http://schemas.openxmlformats.org/officeDocument/2006/relationships" id="2147483649" r:id="R239f1357883b43fc"/>
   </p:sldLayoutIdLst>
   <p:txStyles>
     <p:titleStyle>
@@ -1787,7 +1787,7 @@
       </p:sp>
       <p:cxnSp>
         <p:nvCxnSpPr>
-          <p:cNvPr id="142" name="Straight Arrow Connector 58"/>
+          <p:cNvPr id="162" name="Straight Arrow Connector 58"/>
           <p:cNvCxnSpPr>
             <a:stCxn xmlns:a="http://schemas.openxmlformats.org/drawingml/2006/main" id="7" idx="2"/>
             <a:endCxn xmlns:a="http://schemas.openxmlformats.org/drawingml/2006/main" id="8" idx="0"/>
@@ -1813,7 +1813,7 @@
       </p:cxnSp>
       <p:cxnSp>
         <p:nvCxnSpPr>
-          <p:cNvPr id="143" name="Straight Arrow Connector 59"/>
+          <p:cNvPr id="163" name="Straight Arrow Connector 59"/>
           <p:cNvCxnSpPr>
             <a:stCxn xmlns:a="http://schemas.openxmlformats.org/drawingml/2006/main" id="8" idx="2"/>
             <a:endCxn xmlns:a="http://schemas.openxmlformats.org/drawingml/2006/main" id="9" idx="0"/>
@@ -1839,7 +1839,7 @@
       </p:cxnSp>
       <p:cxnSp>
         <p:nvCxnSpPr>
-          <p:cNvPr id="144" name="Straight Arrow Connector 60"/>
+          <p:cNvPr id="164" name="Straight Arrow Connector 60"/>
           <p:cNvCxnSpPr>
             <a:stCxn xmlns:a="http://schemas.openxmlformats.org/drawingml/2006/main" id="9" idx="2"/>
             <a:endCxn xmlns:a="http://schemas.openxmlformats.org/drawingml/2006/main" id="10" idx="0"/>
@@ -1865,7 +1865,7 @@
       </p:cxnSp>
       <p:cxnSp>
         <p:nvCxnSpPr>
-          <p:cNvPr id="145" name="Straight Arrow Connector 61"/>
+          <p:cNvPr id="165" name="Straight Arrow Connector 61"/>
           <p:cNvCxnSpPr>
             <a:stCxn xmlns:a="http://schemas.openxmlformats.org/drawingml/2006/main" id="11" idx="2"/>
             <a:endCxn xmlns:a="http://schemas.openxmlformats.org/drawingml/2006/main" id="16" idx="0"/>
@@ -2002,29 +2002,7 @@
                 <a:ea typeface="Arial"/>
                 <a:cs typeface="Arial"/>
               </a:rPr>
-              <a:t>(</a:t>
-            </a:r>
-            <a:r>
-              <a:rPr sz="1650">
-                <a:solidFill>
-                  <a:srgbClr val="333333"/>
-                </a:solidFill>
-                <a:latin typeface="Arial"/>
-                <a:ea typeface="Arial"/>
-                <a:cs typeface="Arial"/>
-              </a:rPr>
-              <a:t>270</a:t>
-            </a:r>
-            <a:r>
-              <a:rPr sz="1650">
-                <a:solidFill>
-                  <a:srgbClr val="333333"/>
-                </a:solidFill>
-                <a:latin typeface="Arial"/>
-                <a:ea typeface="Arial"/>
-                <a:cs typeface="Arial"/>
-              </a:rPr>
-              <a:t> topics)</a:t>
+              <a:t>(271 topics)</a:t>
             </a:r>
           </a:p>
         </p:txBody>
@@ -2142,29 +2120,7 @@
                 <a:ea typeface="Arial"/>
                 <a:cs typeface="Arial"/>
               </a:rPr>
-              <a:t>(</a:t>
-            </a:r>
-            <a:r>
-              <a:rPr sz="1650">
-                <a:solidFill>
-                  <a:srgbClr val="333333"/>
-                </a:solidFill>
-                <a:latin typeface="Arial"/>
-                <a:ea typeface="Arial"/>
-                <a:cs typeface="Arial"/>
-              </a:rPr>
-              <a:t>1,473</a:t>
-            </a:r>
-            <a:r>
-              <a:rPr sz="1650">
-                <a:solidFill>
-                  <a:srgbClr val="333333"/>
-                </a:solidFill>
-                <a:latin typeface="Arial"/>
-                <a:ea typeface="Arial"/>
-                <a:cs typeface="Arial"/>
-              </a:rPr>
-              <a:t> keywords)</a:t>
+              <a:t>(1,473 keywords)</a:t>
             </a:r>
           </a:p>
         </p:txBody>
@@ -3130,7 +3086,7 @@
                 <a:ea typeface="Arial"/>
                 <a:cs typeface="Arial"/>
               </a:rPr>
-              <a:t> (</a:t>
+              <a:t> </a:t>
             </a:r>
             <a:r>
               <a:rPr sz="1650">
@@ -3141,18 +3097,7 @@
                 <a:ea typeface="Arial"/>
                 <a:cs typeface="Arial"/>
               </a:rPr>
-              <a:t>270</a:t>
-            </a:r>
-            <a:r>
-              <a:rPr sz="1650">
-                <a:solidFill>
-                  <a:srgbClr val="333333"/>
-                </a:solidFill>
-                <a:latin typeface="Arial"/>
-                <a:ea typeface="Arial"/>
-                <a:cs typeface="Arial"/>
-              </a:rPr>
-              <a:t> topics)</a:t>
+              <a:t>(271 topics)</a:t>
             </a:r>
           </a:p>
         </p:txBody>

</xml_diff>

<commit_message>
Add July posts and refresh search demo
</commit_message>
<xml_diff>
--- a/docs/ehrman_search_methods_editable.pptx
+++ b/docs/ehrman_search_methods_editable.pptx
@@ -2,13 +2,13 @@
 <file path=ppt/presentation.xml><?xml version="1.0" encoding="utf-8"?>
 <p:presentation xmlns:p="http://schemas.openxmlformats.org/presentationml/2006/main">
   <p:sldMasterIdLst>
-    <p:sldMasterId xmlns:r="http://schemas.openxmlformats.org/officeDocument/2006/relationships" id="2147483648" r:id="R91e0085fcf3b4e4e"/>
+    <p:sldMasterId xmlns:r="http://schemas.openxmlformats.org/officeDocument/2006/relationships" id="2147483648" r:id="Rd5ee7dbbc7534d19"/>
   </p:sldMasterIdLst>
   <p:notesMasterIdLst>
-    <p:notesMasterId xmlns:r="http://schemas.openxmlformats.org/officeDocument/2006/relationships" r:id="R4439e6f202614089"/>
+    <p:notesMasterId xmlns:r="http://schemas.openxmlformats.org/officeDocument/2006/relationships" r:id="R1ad9e9e01a8449c9"/>
   </p:notesMasterIdLst>
   <p:sldIdLst>
-    <p:sldId xmlns:r="http://schemas.openxmlformats.org/officeDocument/2006/relationships" id="256" r:id="R312dbbfd24594a9e"/>
+    <p:sldId xmlns:r="http://schemas.openxmlformats.org/officeDocument/2006/relationships" id="256" r:id="Rdaba9af9f1d442a8"/>
   </p:sldIdLst>
   <p:sldSz cx="11430000" cy="7334250"/>
   <p:notesSz cx="6858000" cy="9144000"/>
@@ -506,7 +506,7 @@
   </p:cSld>
   <p:clrMap bg1="lt1" tx1="dk1" bg2="lt2" tx2="dk2" accent1="accent1" accent2="accent2" accent3="accent3" accent4="accent4" accent5="accent5" accent6="accent6" hlink="hlink" folHlink="folHlink"/>
   <p:sldLayoutIdLst>
-    <p:sldLayoutId xmlns:r="http://schemas.openxmlformats.org/officeDocument/2006/relationships" id="2147483649" r:id="R239f1357883b43fc"/>
+    <p:sldLayoutId xmlns:r="http://schemas.openxmlformats.org/officeDocument/2006/relationships" id="2147483649" r:id="Rf1929a58e5e84cd5"/>
   </p:sldLayoutIdLst>
   <p:txStyles>
     <p:titleStyle>
@@ -1787,7 +1787,7 @@
       </p:sp>
       <p:cxnSp>
         <p:nvCxnSpPr>
-          <p:cNvPr id="162" name="Straight Arrow Connector 58"/>
+          <p:cNvPr id="202" name="Straight Arrow Connector 58"/>
           <p:cNvCxnSpPr>
             <a:stCxn xmlns:a="http://schemas.openxmlformats.org/drawingml/2006/main" id="7" idx="2"/>
             <a:endCxn xmlns:a="http://schemas.openxmlformats.org/drawingml/2006/main" id="8" idx="0"/>
@@ -1813,7 +1813,7 @@
       </p:cxnSp>
       <p:cxnSp>
         <p:nvCxnSpPr>
-          <p:cNvPr id="163" name="Straight Arrow Connector 59"/>
+          <p:cNvPr id="203" name="Straight Arrow Connector 59"/>
           <p:cNvCxnSpPr>
             <a:stCxn xmlns:a="http://schemas.openxmlformats.org/drawingml/2006/main" id="8" idx="2"/>
             <a:endCxn xmlns:a="http://schemas.openxmlformats.org/drawingml/2006/main" id="9" idx="0"/>
@@ -1839,7 +1839,7 @@
       </p:cxnSp>
       <p:cxnSp>
         <p:nvCxnSpPr>
-          <p:cNvPr id="164" name="Straight Arrow Connector 60"/>
+          <p:cNvPr id="204" name="Straight Arrow Connector 60"/>
           <p:cNvCxnSpPr>
             <a:stCxn xmlns:a="http://schemas.openxmlformats.org/drawingml/2006/main" id="9" idx="2"/>
             <a:endCxn xmlns:a="http://schemas.openxmlformats.org/drawingml/2006/main" id="10" idx="0"/>
@@ -1865,7 +1865,7 @@
       </p:cxnSp>
       <p:cxnSp>
         <p:nvCxnSpPr>
-          <p:cNvPr id="165" name="Straight Arrow Connector 61"/>
+          <p:cNvPr id="205" name="Straight Arrow Connector 61"/>
           <p:cNvCxnSpPr>
             <a:stCxn xmlns:a="http://schemas.openxmlformats.org/drawingml/2006/main" id="11" idx="2"/>
             <a:endCxn xmlns:a="http://schemas.openxmlformats.org/drawingml/2006/main" id="16" idx="0"/>
@@ -2120,7 +2120,7 @@
                 <a:ea typeface="Arial"/>
                 <a:cs typeface="Arial"/>
               </a:rPr>
-              <a:t>(1,473 keywords)</a:t>
+              <a:t>(1,567 keywords)</a:t>
             </a:r>
           </a:p>
         </p:txBody>
@@ -2238,7 +2238,18 @@
                 <a:ea typeface="Arial"/>
                 <a:cs typeface="Arial"/>
               </a:rPr>
-              <a:t> (4,381 posts)</a:t>
+              <a:t> </a:t>
+            </a:r>
+            <a:r>
+              <a:rPr sz="1650">
+                <a:solidFill>
+                  <a:srgbClr val="333333"/>
+                </a:solidFill>
+                <a:latin typeface="Arial"/>
+                <a:ea typeface="Arial"/>
+                <a:cs typeface="Arial"/>
+              </a:rPr>
+              <a:t>(4,385 posts)</a:t>
             </a:r>
           </a:p>
         </p:txBody>
@@ -3215,7 +3226,18 @@
                 <a:ea typeface="Arial"/>
                 <a:cs typeface="Arial"/>
               </a:rPr>
-              <a:t> (4,381 posts)</a:t>
+              <a:t> </a:t>
+            </a:r>
+            <a:r>
+              <a:rPr sz="1650">
+                <a:solidFill>
+                  <a:srgbClr val="333333"/>
+                </a:solidFill>
+                <a:latin typeface="Arial"/>
+                <a:ea typeface="Arial"/>
+                <a:cs typeface="Arial"/>
+              </a:rPr>
+              <a:t>(4,385 posts)</a:t>
             </a:r>
           </a:p>
         </p:txBody>

</xml_diff>

<commit_message>
Refine topics and secondary keyword index
</commit_message>
<xml_diff>
--- a/docs/ehrman_search_methods_editable.pptx
+++ b/docs/ehrman_search_methods_editable.pptx
@@ -2,13 +2,13 @@
 <file path=ppt/presentation.xml><?xml version="1.0" encoding="utf-8"?>
 <p:presentation xmlns:p="http://schemas.openxmlformats.org/presentationml/2006/main">
   <p:sldMasterIdLst>
-    <p:sldMasterId xmlns:r="http://schemas.openxmlformats.org/officeDocument/2006/relationships" id="2147483648" r:id="Rd5ee7dbbc7534d19"/>
+    <p:sldMasterId xmlns:r="http://schemas.openxmlformats.org/officeDocument/2006/relationships" id="2147483648" r:id="Rb70bb53903f34f36"/>
   </p:sldMasterIdLst>
   <p:notesMasterIdLst>
-    <p:notesMasterId xmlns:r="http://schemas.openxmlformats.org/officeDocument/2006/relationships" r:id="R1ad9e9e01a8449c9"/>
+    <p:notesMasterId xmlns:r="http://schemas.openxmlformats.org/officeDocument/2006/relationships" r:id="Rd82f6aaca3eb4282"/>
   </p:notesMasterIdLst>
   <p:sldIdLst>
-    <p:sldId xmlns:r="http://schemas.openxmlformats.org/officeDocument/2006/relationships" id="256" r:id="Rdaba9af9f1d442a8"/>
+    <p:sldId xmlns:r="http://schemas.openxmlformats.org/officeDocument/2006/relationships" id="256" r:id="R4b5d8dca3fdb4dcd"/>
   </p:sldIdLst>
   <p:sldSz cx="11430000" cy="7334250"/>
   <p:notesSz cx="6858000" cy="9144000"/>
@@ -506,7 +506,7 @@
   </p:cSld>
   <p:clrMap bg1="lt1" tx1="dk1" bg2="lt2" tx2="dk2" accent1="accent1" accent2="accent2" accent3="accent3" accent4="accent4" accent5="accent5" accent6="accent6" hlink="hlink" folHlink="folHlink"/>
   <p:sldLayoutIdLst>
-    <p:sldLayoutId xmlns:r="http://schemas.openxmlformats.org/officeDocument/2006/relationships" id="2147483649" r:id="Rf1929a58e5e84cd5"/>
+    <p:sldLayoutId xmlns:r="http://schemas.openxmlformats.org/officeDocument/2006/relationships" id="2147483649" r:id="R5a4352aafe2247f4"/>
   </p:sldLayoutIdLst>
   <p:txStyles>
     <p:titleStyle>
@@ -1787,7 +1787,7 @@
       </p:sp>
       <p:cxnSp>
         <p:nvCxnSpPr>
-          <p:cNvPr id="202" name="Straight Arrow Connector 58"/>
+          <p:cNvPr id="242" name="Straight Arrow Connector 58"/>
           <p:cNvCxnSpPr>
             <a:stCxn xmlns:a="http://schemas.openxmlformats.org/drawingml/2006/main" id="7" idx="2"/>
             <a:endCxn xmlns:a="http://schemas.openxmlformats.org/drawingml/2006/main" id="8" idx="0"/>
@@ -1813,7 +1813,7 @@
       </p:cxnSp>
       <p:cxnSp>
         <p:nvCxnSpPr>
-          <p:cNvPr id="203" name="Straight Arrow Connector 59"/>
+          <p:cNvPr id="243" name="Straight Arrow Connector 59"/>
           <p:cNvCxnSpPr>
             <a:stCxn xmlns:a="http://schemas.openxmlformats.org/drawingml/2006/main" id="8" idx="2"/>
             <a:endCxn xmlns:a="http://schemas.openxmlformats.org/drawingml/2006/main" id="9" idx="0"/>
@@ -1839,7 +1839,7 @@
       </p:cxnSp>
       <p:cxnSp>
         <p:nvCxnSpPr>
-          <p:cNvPr id="204" name="Straight Arrow Connector 60"/>
+          <p:cNvPr id="244" name="Straight Arrow Connector 60"/>
           <p:cNvCxnSpPr>
             <a:stCxn xmlns:a="http://schemas.openxmlformats.org/drawingml/2006/main" id="9" idx="2"/>
             <a:endCxn xmlns:a="http://schemas.openxmlformats.org/drawingml/2006/main" id="10" idx="0"/>
@@ -1865,7 +1865,7 @@
       </p:cxnSp>
       <p:cxnSp>
         <p:nvCxnSpPr>
-          <p:cNvPr id="205" name="Straight Arrow Connector 61"/>
+          <p:cNvPr id="245" name="Straight Arrow Connector 61"/>
           <p:cNvCxnSpPr>
             <a:stCxn xmlns:a="http://schemas.openxmlformats.org/drawingml/2006/main" id="11" idx="2"/>
             <a:endCxn xmlns:a="http://schemas.openxmlformats.org/drawingml/2006/main" id="16" idx="0"/>
@@ -2002,7 +2002,7 @@
                 <a:ea typeface="Arial"/>
                 <a:cs typeface="Arial"/>
               </a:rPr>
-              <a:t>(271 topics)</a:t>
+              <a:t>(270 topics)</a:t>
             </a:r>
           </a:p>
         </p:txBody>
@@ -2120,7 +2120,7 @@
                 <a:ea typeface="Arial"/>
                 <a:cs typeface="Arial"/>
               </a:rPr>
-              <a:t>(1,567 keywords)</a:t>
+              <a:t>(1,480 keywords)</a:t>
             </a:r>
           </a:p>
         </p:txBody>
@@ -3108,7 +3108,7 @@
                 <a:ea typeface="Arial"/>
                 <a:cs typeface="Arial"/>
               </a:rPr>
-              <a:t>(271 topics)</a:t>
+              <a:t>(270 topics)</a:t>
             </a:r>
           </a:p>
         </p:txBody>

</xml_diff>

<commit_message>
Refresh landing-page search counts
</commit_message>
<xml_diff>
--- a/docs/ehrman_search_methods_editable.pptx
+++ b/docs/ehrman_search_methods_editable.pptx
@@ -2,13 +2,13 @@
 <file path=ppt/presentation.xml><?xml version="1.0" encoding="utf-8"?>
 <p:presentation xmlns:p="http://schemas.openxmlformats.org/presentationml/2006/main">
   <p:sldMasterIdLst>
-    <p:sldMasterId xmlns:r="http://schemas.openxmlformats.org/officeDocument/2006/relationships" id="2147483648" r:id="Rb70bb53903f34f36"/>
+    <p:sldMasterId xmlns:r="http://schemas.openxmlformats.org/officeDocument/2006/relationships" id="2147483648" r:id="R1405c01e6c9443ee"/>
   </p:sldMasterIdLst>
   <p:notesMasterIdLst>
-    <p:notesMasterId xmlns:r="http://schemas.openxmlformats.org/officeDocument/2006/relationships" r:id="Rd82f6aaca3eb4282"/>
+    <p:notesMasterId xmlns:r="http://schemas.openxmlformats.org/officeDocument/2006/relationships" r:id="R25330bae177c4e87"/>
   </p:notesMasterIdLst>
   <p:sldIdLst>
-    <p:sldId xmlns:r="http://schemas.openxmlformats.org/officeDocument/2006/relationships" id="256" r:id="R4b5d8dca3fdb4dcd"/>
+    <p:sldId xmlns:r="http://schemas.openxmlformats.org/officeDocument/2006/relationships" id="256" r:id="R339d7e2edb69424c"/>
   </p:sldIdLst>
   <p:sldSz cx="11430000" cy="7334250"/>
   <p:notesSz cx="6858000" cy="9144000"/>
@@ -506,7 +506,7 @@
   </p:cSld>
   <p:clrMap bg1="lt1" tx1="dk1" bg2="lt2" tx2="dk2" accent1="accent1" accent2="accent2" accent3="accent3" accent4="accent4" accent5="accent5" accent6="accent6" hlink="hlink" folHlink="folHlink"/>
   <p:sldLayoutIdLst>
-    <p:sldLayoutId xmlns:r="http://schemas.openxmlformats.org/officeDocument/2006/relationships" id="2147483649" r:id="R5a4352aafe2247f4"/>
+    <p:sldLayoutId xmlns:r="http://schemas.openxmlformats.org/officeDocument/2006/relationships" id="2147483649" r:id="Rb02d0280d28940b6"/>
   </p:sldLayoutIdLst>
   <p:txStyles>
     <p:titleStyle>
@@ -1787,7 +1787,7 @@
       </p:sp>
       <p:cxnSp>
         <p:nvCxnSpPr>
-          <p:cNvPr id="242" name="Straight Arrow Connector 58"/>
+          <p:cNvPr id="262" name="Straight Arrow Connector 58"/>
           <p:cNvCxnSpPr>
             <a:stCxn xmlns:a="http://schemas.openxmlformats.org/drawingml/2006/main" id="7" idx="2"/>
             <a:endCxn xmlns:a="http://schemas.openxmlformats.org/drawingml/2006/main" id="8" idx="0"/>
@@ -1813,7 +1813,7 @@
       </p:cxnSp>
       <p:cxnSp>
         <p:nvCxnSpPr>
-          <p:cNvPr id="243" name="Straight Arrow Connector 59"/>
+          <p:cNvPr id="263" name="Straight Arrow Connector 59"/>
           <p:cNvCxnSpPr>
             <a:stCxn xmlns:a="http://schemas.openxmlformats.org/drawingml/2006/main" id="8" idx="2"/>
             <a:endCxn xmlns:a="http://schemas.openxmlformats.org/drawingml/2006/main" id="9" idx="0"/>
@@ -1839,7 +1839,7 @@
       </p:cxnSp>
       <p:cxnSp>
         <p:nvCxnSpPr>
-          <p:cNvPr id="244" name="Straight Arrow Connector 60"/>
+          <p:cNvPr id="264" name="Straight Arrow Connector 60"/>
           <p:cNvCxnSpPr>
             <a:stCxn xmlns:a="http://schemas.openxmlformats.org/drawingml/2006/main" id="9" idx="2"/>
             <a:endCxn xmlns:a="http://schemas.openxmlformats.org/drawingml/2006/main" id="10" idx="0"/>
@@ -1865,7 +1865,7 @@
       </p:cxnSp>
       <p:cxnSp>
         <p:nvCxnSpPr>
-          <p:cNvPr id="245" name="Straight Arrow Connector 61"/>
+          <p:cNvPr id="265" name="Straight Arrow Connector 61"/>
           <p:cNvCxnSpPr>
             <a:stCxn xmlns:a="http://schemas.openxmlformats.org/drawingml/2006/main" id="11" idx="2"/>
             <a:endCxn xmlns:a="http://schemas.openxmlformats.org/drawingml/2006/main" id="16" idx="0"/>
@@ -2120,7 +2120,29 @@
                 <a:ea typeface="Arial"/>
                 <a:cs typeface="Arial"/>
               </a:rPr>
-              <a:t>(1,480 keywords)</a:t>
+              <a:t>(</a:t>
+            </a:r>
+            <a:r>
+              <a:rPr sz="1650">
+                <a:solidFill>
+                  <a:srgbClr val="333333"/>
+                </a:solidFill>
+                <a:latin typeface="Arial"/>
+                <a:ea typeface="Arial"/>
+                <a:cs typeface="Arial"/>
+              </a:rPr>
+              <a:t>1,036 keywords</a:t>
+            </a:r>
+            <a:r>
+              <a:rPr sz="1650">
+                <a:solidFill>
+                  <a:srgbClr val="333333"/>
+                </a:solidFill>
+                <a:latin typeface="Arial"/>
+                <a:ea typeface="Arial"/>
+                <a:cs typeface="Arial"/>
+              </a:rPr>
+              <a:t>)</a:t>
             </a:r>
           </a:p>
         </p:txBody>

</xml_diff>